<commit_message>
Add "AI Sales Transformation" to the platform, deck, talk track and script
Co-Authored-By: Claude Sonnet 5.5 <noreply@anthropic.com>
</commit_message>
<xml_diff>
--- a/Zoom CRO Pitch (6 slides) v2.pptx
+++ b/Zoom CRO Pitch (6 slides) v2.pptx
@@ -507,7 +507,7 @@
           <a:p>
             <a:r>
               <a:rPr lang="en-US" dirty="0"/>
-              <a:t>Start with Zoom, not Databook. Zoom has dropped “Video” from its name and calls itself an AI-first work platform. Its March 2026 announcement framed Zoom as a system of action, with AI Companion 3.0, custom agents, and Zoom CX products. AI Companion active users more than tripled year on year in Q4 FY26 and paid AI was in each of the top ten CX deals last quarter, per Zoom. The gap is the seller: the vision only lands if sellers can take it into each account. I could not open the Forbes piece (it blocked automated access), so this slide uses Zoom’s own announcement and press coverage of the rebrand. Enterprise at about 60% of revenue is derived from Zoom’s reported FY26 figures.</a:t>
+              <a:t>Start with Zoom, not Databook. Say the phrase “AI sales transformation” early: this is about changing how Zoom sells, not only what it reports. Zoom has dropped “Video” from its name and calls itself an AI-first work platform. Its March 2026 announcement framed Zoom as a system of action, with AI Companion 3.0, custom agents, and Zoom CX products. AI Companion active users more than tripled year on year in Q4 FY26 and paid AI was in each of the top ten CX deals last quarter, per Zoom. The gap is the seller: the vision only lands if sellers can take it into each account. I could not open the Forbes piece (it blocked automated access), so this slide uses Zoom’s own announcement and press coverage of the rebrand. Enterprise at about 60% of revenue is derived from Zoom’s reported FY26 figures.</a:t>
             </a:r>
             <a:endParaRPr lang="en-US" dirty="0"/>
           </a:p>
@@ -1624,7 +1624,7 @@
                 <a:ea typeface="Inter" pitchFamily="34" charset="-122"/>
                 <a:cs typeface="Inter" pitchFamily="34" charset="-120"/>
               </a:rPr>
-              <a:t>ZOOM’S NEED, RIGHT NOW</a:t>
+              <a:t>AI SALES TRANSFORMATION · ZOOM’S NEED, RIGHT NOW</a:t>
             </a:r>
             <a:endParaRPr lang="en-US" sz="1300" dirty="0"/>
           </a:p>
@@ -3498,7 +3498,7 @@
                 <a:ea typeface="Inter" pitchFamily="34" charset="-122"/>
                 <a:cs typeface="Inter" pitchFamily="34" charset="-120"/>
               </a:rPr>
-              <a:t>HOW DATABOOK HELPS</a:t>
+              <a:t>AI SALES TRANSFORMATION · HOW DATABOOK HELPS</a:t>
             </a:r>
             <a:endParaRPr lang="en-US" sz="1300" dirty="0"/>
           </a:p>
@@ -4658,7 +4658,7 @@
                 <a:ea typeface="Inter" pitchFamily="34" charset="-122"/>
                 <a:cs typeface="Inter" pitchFamily="34" charset="-120"/>
               </a:rPr>
-              <a:t>Zoom CRO · GTM Decision System · Mock engagement</a:t>
+              <a:t>Zoom CRO · AI Sales Transformation · GTM Decision System · Mock engagement</a:t>
             </a:r>
             <a:endParaRPr lang="en-US" sz="1200" dirty="0"/>
           </a:p>
@@ -8142,7 +8142,7 @@
                 <a:ea typeface="Inter" pitchFamily="34" charset="-122"/>
                 <a:cs typeface="Inter" pitchFamily="34" charset="-120"/>
               </a:rPr>
-              <a:t>Zoom CRO · GTM Decision System · Mock engagement and simulated data</a:t>
+              <a:t>Zoom CRO · AI Sales Transformation · GTM Decision System · Mock data</a:t>
             </a:r>
             <a:endParaRPr lang="en-US" sz="1200" dirty="0"/>
           </a:p>
@@ -9178,7 +9178,7 @@
                 <a:ea typeface="Inter" pitchFamily="34" charset="-122"/>
                 <a:cs typeface="Inter" pitchFamily="34" charset="-120"/>
               </a:rPr>
-              <a:t>REPEATABLE AT LARGE ENTERPRISE SALES TEAMS. ZOOM IS NEXT.</a:t>
+              <a:t>AI SALES TRANSFORMATION, REPEATABLE AT LARGE ENTERPRISE SALES TEAMS. ZOOM IS NEXT.</a:t>
             </a:r>
             <a:endParaRPr lang="en-US" sz="1196" dirty="0"/>
           </a:p>

</xml_diff>

<commit_message>
Explain the fiscal-year labelling on slide 1 and in the talk track
Co-Authored-By: Claude Sonnet 5.5 <noreply@anthropic.com>
</commit_message>
<xml_diff>
--- a/Zoom CRO Pitch (6 slides) v2.pptx
+++ b/Zoom CRO Pitch (6 slides) v2.pptx
@@ -507,7 +507,7 @@
           <a:p>
             <a:r>
               <a:rPr lang="en-US" dirty="0"/>
-              <a:t>Start with Zoom, not Databook. Say the phrase “AI sales transformation” early: this is about changing how Zoom sells, not only what it reports. Zoom has dropped “Video” from its name and calls itself an AI-first work platform. Its March 2026 announcement framed Zoom as a system of action, with AI Companion 3.0, custom agents, and Zoom CX products. AI Companion active users more than tripled year on year in Q4 FY26 and paid AI was in each of the top ten CX deals last quarter, per Zoom. The gap is the seller: the vision only lands if sellers can take it into each account. If asked why Zoom cannot just use AI Sales Assist and Ask ZRA: they are Zoom Revenue Accelerator features that work from conversations and revenue data; Databook adds outside-in customer context, one view across CRM, usage and delivery, a CRO decision with an owner, and proof against the CFO’s target, and can use ZRA as a signal source. Check the announcement date for these two products before presenting: Zoom’s investor release I found is dated July 22, 2026. I could not open the Forbes piece (it blocked automated access), so this slide uses Zoom’s own announcement and press coverage of the rebrand. Enterprise at about 60% of revenue is derived from Zoom’s reported FY26 figures.</a:t>
+              <a:t>Start with Zoom, not Databook. If asked about FY26: Zoom’s fiscal year ends January 31, so FY26 is February 2025 to January 2026, reported on February 25, 2026. Today is Q3 of FY27, so FY26 is the latest full reported year: revenue $4,868.8M, Enterprise $2,934.1M, about 60%. Say the phrase “AI sales transformation” early: this is about changing how Zoom sells, not only what it reports. Zoom has dropped “Video” from its name and calls itself an AI-first work platform. Its March 2026 announcement framed Zoom as a system of action, with AI Companion 3.0, custom agents, and Zoom CX products. AI Companion active users more than tripled year on year in Q4 FY26 and paid AI was in each of the top ten CX deals last quarter, per Zoom. The gap is the seller: the vision only lands if sellers can take it into each account. If asked why Zoom cannot just use AI Sales Assist and Ask ZRA: they are Zoom Revenue Accelerator features that work from conversations and revenue data; Databook adds outside-in customer context, one view across CRM, usage and delivery, a CRO decision with an owner, and proof against the CFO’s target, and can use ZRA as a signal source. Check the announcement date for these two products before presenting: Zoom’s investor release I found is dated July 22, 2026. I could not open the Forbes piece (it blocked automated access), so this slide uses Zoom’s own announcement and press coverage of the rebrand. Enterprise at about 60% of revenue is derived from Zoom’s reported FY26 figures.</a:t>
             </a:r>
             <a:endParaRPr lang="en-US" dirty="0"/>
           </a:p>
@@ -2425,7 +2425,7 @@
                 <a:ea typeface="Inter" pitchFamily="34" charset="-122"/>
                 <a:cs typeface="Inter" pitchFamily="34" charset="-120"/>
               </a:rPr>
-              <a:t>Sources: Zoom announcement (March 10, 2026), Zoom FY26 results, coverage of Zoom’s 2024 rebrand</a:t>
+              <a:t>Sources: Zoom announcement (March 10, 2026), Zoom FY26 results (year to Jan 31, 2026), 2024 rebrand coverage</a:t>
             </a:r>
             <a:endParaRPr lang="en-US" sz="1200" dirty="0"/>
           </a:p>

</xml_diff>

<commit_message>
Prove is the execution loop and approved actions; undo approvals; client materials tab; live Hub customization
Co-Authored-By: Claude Sonnet 5.5 <noreply@anthropic.com>
</commit_message>
<xml_diff>
--- a/Zoom CRO Pitch (6 slides) v2.pptx
+++ b/Zoom CRO Pitch (6 slides) v2.pptx
@@ -4,6 +4,9 @@
   <p:sldMasterIdLst>
     <p:sldMasterId id="2147483648" r:id="rId1"/>
   </p:sldMasterIdLst>
+  <p:notesMasterIdLst>
+    <p:notesMasterId r:id="rId8"/>
+  </p:notesMasterIdLst>
   <p:sldIdLst>
     <p:sldId id="256" r:id="rId2"/>
     <p:sldId id="257" r:id="rId3"/>
@@ -12,9 +15,6 @@
     <p:sldId id="260" r:id="rId6"/>
     <p:sldId id="261" r:id="rId7"/>
   </p:sldIdLst>
-  <p:notesMasterIdLst>
-    <p:notesMasterId r:id="rId8"/>
-  </p:notesMasterIdLst>
   <p:sldSz cx="12192000" cy="6858000"/>
   <p:notesSz cx="6858000" cy="12192000"/>
   <p:defaultTextStyle>
@@ -109,6 +109,11 @@
       </a:defRPr>
     </a:lvl9pPr>
   </p:defaultTextStyle>
+  <p:extLst>
+    <p:ext uri="{EFAFB233-063F-42B5-8137-9DF3F51BA10A}">
+      <p15:sldGuideLst xmlns:p15="http://schemas.microsoft.com/office/powerpoint/2012/main"/>
+    </p:ext>
+  </p:extLst>
 </p:presentation>
 </file>
 
@@ -134,234 +139,10 @@
           <a:chExt cx="0" cy="0"/>
         </a:xfrm>
       </p:grpSpPr>
-      <p:sp>
-        <p:nvSpPr>
-          <p:cNvPr id="2" name="Header Placeholder 1"/>
-          <p:cNvSpPr>
-            <a:spLocks noGrp="1"/>
-          </p:cNvSpPr>
-          <p:nvPr>
-            <p:ph type="hdr" sz="quarter"/>
-          </p:nvPr>
-        </p:nvSpPr>
-        <p:spPr>
-          <a:xfrm>
-            <a:off x="0" y="0"/>
-            <a:ext cx="2971800" cy="458788"/>
-          </a:xfrm>
-          <a:prstGeom prst="rect">
-            <a:avLst/>
-          </a:prstGeom>
-        </p:spPr>
-        <p:txBody>
-          <a:bodyPr vert="horz" lIns="91440" tIns="45720" rIns="91440" bIns="45720" rtlCol="0"/>
-          <a:lstStyle>
-            <a:lvl1pPr algn="l">
-              <a:defRPr sz="1200"/>
-            </a:lvl1pPr>
-          </a:lstStyle>
-          <a:p>
-            <a:endParaRPr lang="en-US"/>
-          </a:p>
-        </p:txBody>
-      </p:sp>
-      <p:sp>
-        <p:nvSpPr>
-          <p:cNvPr id="3" name="Date Placeholder 2"/>
-          <p:cNvSpPr>
-            <a:spLocks noGrp="1"/>
-          </p:cNvSpPr>
-          <p:nvPr>
-            <p:ph type="dt" idx="1"/>
-          </p:nvPr>
-        </p:nvSpPr>
-        <p:spPr>
-          <a:xfrm>
-            <a:off x="3884613" y="0"/>
-            <a:ext cx="2971800" cy="458788"/>
-          </a:xfrm>
-          <a:prstGeom prst="rect">
-            <a:avLst/>
-          </a:prstGeom>
-        </p:spPr>
-        <p:txBody>
-          <a:bodyPr vert="horz" lIns="91440" tIns="45720" rIns="91440" bIns="45720" rtlCol="0"/>
-          <a:lstStyle>
-            <a:lvl1pPr algn="r">
-              <a:defRPr sz="1200"/>
-            </a:lvl1pPr>
-          </a:lstStyle>
-          <a:p>
-            <a:fld id="{5282F153-3F37-0F45-9E97-73ACFA13230C}" type="datetimeFigureOut">
-              <a:rPr lang="en-US"/>
-              <a:t>7/23/19</a:t>
-            </a:fld>
-            <a:endParaRPr lang="en-US"/>
-          </a:p>
-        </p:txBody>
-      </p:sp>
-      <p:sp>
-        <p:nvSpPr>
-          <p:cNvPr id="4" name="Slide Image Placeholder 3"/>
-          <p:cNvSpPr>
-            <a:spLocks noGrp="1" noRot="1" noChangeAspect="1"/>
-          </p:cNvSpPr>
-          <p:nvPr>
-            <p:ph type="sldImg" idx="2"/>
-          </p:nvPr>
-        </p:nvSpPr>
-        <p:spPr>
-          <a:xfrm>
-            <a:off x="685800" y="1143000"/>
-            <a:ext cx="5486400" cy="3086100"/>
-          </a:xfrm>
-          <a:prstGeom prst="rect">
-            <a:avLst/>
-          </a:prstGeom>
-          <a:noFill/>
-          <a:ln w="12700">
-            <a:solidFill>
-              <a:prstClr val="black"/>
-            </a:solidFill>
-          </a:ln>
-        </p:spPr>
-        <p:txBody>
-          <a:bodyPr vert="horz" lIns="91440" tIns="45720" rIns="91440" bIns="45720" rtlCol="0" anchor="ctr"/>
-          <a:lstStyle/>
-          <a:p>
-            <a:endParaRPr lang="en-US"/>
-          </a:p>
-        </p:txBody>
-      </p:sp>
-      <p:sp>
-        <p:nvSpPr>
-          <p:cNvPr id="5" name="Notes Placeholder 4"/>
-          <p:cNvSpPr>
-            <a:spLocks noGrp="1"/>
-          </p:cNvSpPr>
-          <p:nvPr>
-            <p:ph type="body" sz="quarter" idx="3"/>
-          </p:nvPr>
-        </p:nvSpPr>
-        <p:spPr>
-          <a:xfrm>
-            <a:off x="685800" y="4400550"/>
-            <a:ext cx="5486400" cy="3600450"/>
-          </a:xfrm>
-          <a:prstGeom prst="rect">
-            <a:avLst/>
-          </a:prstGeom>
-        </p:spPr>
-        <p:txBody>
-          <a:bodyPr vert="horz" lIns="91440" tIns="45720" rIns="91440" bIns="45720" rtlCol="0"/>
-          <a:lstStyle/>
-          <a:p>
-            <a:pPr lvl="0"/>
-            <a:r>
-              <a:rPr lang="en-US"/>
-              <a:t>Click to edit Master text styles</a:t>
-            </a:r>
-          </a:p>
-          <a:p>
-            <a:pPr lvl="1"/>
-            <a:r>
-              <a:rPr lang="en-US"/>
-              <a:t>Second level</a:t>
-            </a:r>
-          </a:p>
-          <a:p>
-            <a:pPr lvl="2"/>
-            <a:r>
-              <a:rPr lang="en-US"/>
-              <a:t>Third level</a:t>
-            </a:r>
-          </a:p>
-          <a:p>
-            <a:pPr lvl="3"/>
-            <a:r>
-              <a:rPr lang="en-US"/>
-              <a:t>Fourth level</a:t>
-            </a:r>
-          </a:p>
-          <a:p>
-            <a:pPr lvl="4"/>
-            <a:r>
-              <a:rPr lang="en-US"/>
-              <a:t>Fifth level</a:t>
-            </a:r>
-          </a:p>
-        </p:txBody>
-      </p:sp>
-      <p:sp>
-        <p:nvSpPr>
-          <p:cNvPr id="6" name="Footer Placeholder 5"/>
-          <p:cNvSpPr>
-            <a:spLocks noGrp="1"/>
-          </p:cNvSpPr>
-          <p:nvPr>
-            <p:ph type="ftr" sz="quarter" idx="4"/>
-          </p:nvPr>
-        </p:nvSpPr>
-        <p:spPr>
-          <a:xfrm>
-            <a:off x="0" y="8685213"/>
-            <a:ext cx="2971800" cy="458787"/>
-          </a:xfrm>
-          <a:prstGeom prst="rect">
-            <a:avLst/>
-          </a:prstGeom>
-        </p:spPr>
-        <p:txBody>
-          <a:bodyPr vert="horz" lIns="91440" tIns="45720" rIns="91440" bIns="45720" rtlCol="0" anchor="b"/>
-          <a:lstStyle>
-            <a:lvl1pPr algn="l">
-              <a:defRPr sz="1200"/>
-            </a:lvl1pPr>
-          </a:lstStyle>
-          <a:p>
-            <a:endParaRPr lang="en-US"/>
-          </a:p>
-        </p:txBody>
-      </p:sp>
-      <p:sp>
-        <p:nvSpPr>
-          <p:cNvPr id="7" name="Slide Number Placeholder 6"/>
-          <p:cNvSpPr>
-            <a:spLocks noGrp="1"/>
-          </p:cNvSpPr>
-          <p:nvPr>
-            <p:ph type="sldNum" sz="quarter" idx="5"/>
-          </p:nvPr>
-        </p:nvSpPr>
-        <p:spPr>
-          <a:xfrm>
-            <a:off x="3884613" y="8685213"/>
-            <a:ext cx="2971800" cy="458787"/>
-          </a:xfrm>
-          <a:prstGeom prst="rect">
-            <a:avLst/>
-          </a:prstGeom>
-        </p:spPr>
-        <p:txBody>
-          <a:bodyPr vert="horz" lIns="91440" tIns="45720" rIns="91440" bIns="45720" rtlCol="0" anchor="b"/>
-          <a:lstStyle>
-            <a:lvl1pPr algn="r">
-              <a:defRPr sz="1200"/>
-            </a:lvl1pPr>
-          </a:lstStyle>
-          <a:p>
-            <a:fld id="{CE5E9CC1-C706-0F49-92D6-E571CC5EEA8F}" type="slidenum">
-              <a:rPr lang="en-US"/>
-              <a:t>‹#›</a:t>
-            </a:fld>
-            <a:endParaRPr lang="en-US"/>
-          </a:p>
-        </p:txBody>
-      </p:sp>
     </p:spTree>
     <p:extLst>
       <p:ext uri="{BB962C8B-B14F-4D97-AF65-F5344CB8AC3E}">
-        <p14:creationId xmlns:p14="http://schemas.microsoft.com/office/powerpoint/2010/main" val="1024086991"/>
+        <p14:creationId xmlns:p14="http://schemas.microsoft.com/office/powerpoint/2010/main" val="2119286735"/>
       </p:ext>
     </p:extLst>
   </p:cSld>
@@ -507,9 +288,8 @@
           <a:p>
             <a:r>
               <a:rPr lang="en-US" dirty="0"/>
-              <a:t>Start with Zoom, not Databook. If asked about FY26: Zoom’s fiscal year ends January 31, so FY26 is February 2025 to January 2026, reported on February 25, 2026. Today is Q3 of FY27, so FY26 is the latest full reported year: revenue $4,868.8M, Enterprise $2,934.1M, about 60%. Say the phrase “AI sales transformation” early: this is about changing how Zoom sells, not only what it reports. Zoom has dropped “Video” from its name and calls itself an AI-first work platform. Its March 2026 announcement framed Zoom as a system of action, with AI Companion 3.0, custom agents, and Zoom CX products. AI Companion active users more than tripled year on year in Q4 FY26 and paid AI was in each of the top ten CX deals last quarter, per Zoom. The gap is the seller: the vision only lands if sellers can take it into each account. If asked why Zoom cannot just use AI Sales Assist and Ask ZRA: they are Zoom Revenue Accelerator features that work from conversations and revenue data; Databook adds outside-in customer context, one view across CRM, usage and delivery, a CRO decision with an owner, and proof against the CFO’s target, and can use ZRA as a signal source. Check the announcement date for these two products before presenting: Zoom’s investor release I found is dated July 22, 2026. I could not open the Forbes piece (it blocked automated access), so this slide uses Zoom’s own announcement and press coverage of the rebrand. Enterprise at about 60% of revenue is derived from Zoom’s reported FY26 figures.</a:t>
-            </a:r>
-            <a:endParaRPr lang="en-US" dirty="0"/>
+              <a:t>Start with Zoom, not Databook. Say the phrase “AI sales transformation” early: this is about changing how Zoom sells, not only what it reports. Zoom has dropped “Video” from its name and calls itself an AI-first work platform. Its March 2026 announcement framed Zoom as a system of action, with AI Companion 3.0, custom agents, and Zoom CX products. AI Companion active users more than tripled year on year in Q4 FY26 and paid AI was in each of the top ten CX deals last quarter, per Zoom. The gap is the seller: the vision only lands if sellers can take it into each account. I could not open the Forbes piece (it blocked automated access), so this slide uses Zoom’s own announcement and press coverage of the rebrand. Enterprise at about 60% of revenue is derived from Zoom’s reported FY26 figures.</a:t>
+            </a:r>
           </a:p>
         </p:txBody>
       </p:sp>
@@ -597,7 +377,6 @@
               <a:rPr lang="en-US" dirty="0"/>
               <a:t>Zoom wants to be known as an AI-native, holistic platform, but competitors already sell that story with the weight of an ecosystem behind it: Microsoft with Teams and Copilot, Google with Gemini inside Workspace, Cisco and RingCentral as Gartner UCaaS leaders, and Salesforce putting Agentforce inside Slack. Zoom has pointed to a total addressable market of about $125B for 2026 (Zoomtopia 2022) and up to $235B by 2028; its FY26 revenue of $4.87B is roughly 4% of the first figure, so the revenue is about 4% of that figure. That is a scale comparison, not market share, and it is illustrative: TAM definitions differ and the $235B figure comes from a third-party summary of Zoomtopia 2024, so confirm it in Zoom’s own investor slides before presenting. The point is the gap is large, it maps straight to the top line, and the way to close it is account by account, through sellers who can sell the platform vision.</a:t>
             </a:r>
-            <a:endParaRPr lang="en-US" dirty="0"/>
           </a:p>
         </p:txBody>
       </p:sp>
@@ -685,7 +464,6 @@
               <a:rPr lang="en-US" dirty="0"/>
               <a:t>This answers the gap on the previous slide: the market is there, and the top line follows when sellers can take Zoom’s AI-first vision into each account. This is the alignment statement. As an AI deployment manager from Databook, I align to what Zoom needs: if customers need to see Zoom differently, the sellers need the right information to take that vision forward. Databook works customer-back: it builds the account context, then guides the seller. That helps three things that matter to Zoom: revenue growth, how customers perceive the products, and the win rate against named rivals. The point is to help Zoom go beyond its target, not only reach it. The competitive and market data in the prototype is illustrative.</a:t>
             </a:r>
-            <a:endParaRPr lang="en-US" dirty="0"/>
           </a:p>
         </p:txBody>
       </p:sp>
@@ -773,7 +551,6 @@
               <a:rPr lang="en-US" dirty="0"/>
               <a:t>The decision system in three layers: the data layer builds the account picture from Zoom’s own systems, the intelligence layer decides what matters and what to do, and the execution layer puts guidance where sellers work and gives the CRO control and measurement. The differentiators on the bottom row are why an outcome-based model is credible: the context is verifiable, the baseline is agreed up front, and the system, not the vendor, measures the result. If no revenue shows up above target, only the platform fee is owed. The platform fee is not disclosed in Databook’s webinar. The 39% and 99% figures are Databook’s claims. Other tools tell you what happened, or find more data; Databook decides what to do on this account, and proves it. If asked about Clay, Gong or Clari, compare on trust, guidance and proof, not features, and say this is your understanding.</a:t>
             </a:r>
-            <a:endParaRPr lang="en-US" dirty="0"/>
           </a:p>
         </p:txBody>
       </p:sp>
@@ -861,7 +638,6 @@
               <a:rPr lang="en-US" dirty="0"/>
               <a:t>On the platform the CRO Hub is five colour-coded boxes: top line and decisions, key accounts, return on spend, product and brand, sellers and adoption. This is the loop the prototype runs, on one account, Northwind Traders. See: bookings are forecast against target, and every number says how Databook sees it, from Zoom’s own systems and from outside data. Find: the top accounts to spend time on, and Northwind opened to its five angles, each labelled verified, inferred or needs validation. Decide: the CRO approves reframing the Contact Center play, with an owner, a date and a modeled dollar impact, before any seller sees it. Guide: the play lands in Slack and Salesforce as four steps, and the coach is adapted once and handed to the seller. Prove: execution is tracked from authorized to buyer step, so adoption shows within weeks and revenue is claimed only as it lags in. Regions, statuses and the account are simulated.</a:t>
             </a:r>
-            <a:endParaRPr lang="en-US" dirty="0"/>
           </a:p>
         </p:txBody>
       </p:sp>
@@ -949,7 +725,6 @@
               <a:rPr lang="en-US" dirty="0"/>
               <a:t>Keep this one statement clear: behaviors and systems move together. Adoption of a new system is hard for sellers, because they are used to a certain selling motion. The implementation and adoption playbook is how Databook’s deployment managers, like me, work closely with the champions at Zoom: align them on the case for change, have the CRO lead by example by authorizing plays, enable sellers one to one, and align KPIs and incentives. If sellers do not change behavior and use the skills and capabilities Databook provides, there is no revenue uplift. Without Databook, the lever is hiring: roughly 10 to 20 reps and $3M to $5M to add $10M, with about six months of ramp, as Databook states; in the prototype data the hires from last fiscal year took about six months to a first win. On the platform, Uplift and adoption shows the same point: the modeled uplift is about +$4.6M at full adoption and +$2.3M at half, and a senior leader is on 35% of deals today against 68% for pilot sellers. With Databook, existing sellers are equipped and the fee is tied to revenue above target. The grey names are customer logos shown on databook.com; Zoom is not listed there, so frame Zoom as the next one, not a past result.</a:t>
             </a:r>
-            <a:endParaRPr lang="en-US" dirty="0"/>
           </a:p>
         </p:txBody>
       </p:sp>
@@ -1027,6 +802,7 @@
         <a:solidFill>
           <a:srgbClr val="FAFAF8"/>
         </a:solidFill>
+        <a:effectLst/>
       </p:bgPr>
     </p:bg>
     <p:spTree>
@@ -1046,7 +822,9 @@
       <p:sp>
         <p:nvSpPr>
           <p:cNvPr id="2" name="Title Placeholder 1"/>
-          <p:cNvSpPr/>
+          <p:cNvSpPr>
+            <a:spLocks noGrp="1"/>
+          </p:cNvSpPr>
           <p:nvPr>
             <p:ph type="title"/>
           </p:nvPr>
@@ -1065,7 +843,7 @@
         <p:txBody>
           <a:bodyPr wrap="square" lIns="0" tIns="0" rIns="0" bIns="0" rtlCol="0" anchor="t"/>
           <a:lstStyle>
-            <a:lvl1pPr algn="l" indent="0" marL="0">
+            <a:lvl1pPr marL="0" indent="0" algn="l">
               <a:lnSpc>
                 <a:spcPct val="115000"/>
               </a:lnSpc>
@@ -1081,7 +859,7 @@
             </a:lvl1pPr>
           </a:lstStyle>
           <a:p>
-            <a:pPr algn="l" indent="0" marL="0">
+            <a:pPr marL="0" indent="0" algn="l">
               <a:lnSpc>
                 <a:spcPct val="115000"/>
               </a:lnSpc>
@@ -1094,9 +872,11 @@
       <p:sp>
         <p:nvSpPr>
           <p:cNvPr id="3" name="Text Placeholder 2"/>
-          <p:cNvSpPr/>
+          <p:cNvSpPr>
+            <a:spLocks noGrp="1"/>
+          </p:cNvSpPr>
           <p:nvPr>
-            <p:ph idx="101" type="body"/>
+            <p:ph type="body" idx="101"/>
           </p:nvPr>
         </p:nvSpPr>
         <p:spPr>
@@ -1113,7 +893,7 @@
         <p:txBody>
           <a:bodyPr wrap="square" lIns="0" tIns="0" rIns="0" bIns="0" rtlCol="0" anchor="t"/>
           <a:lstStyle>
-            <a:lvl1pPr algn="l" indent="0" marL="0">
+            <a:lvl1pPr marL="0" indent="0" algn="l">
               <a:lnSpc>
                 <a:spcPct val="140000"/>
               </a:lnSpc>
@@ -1129,7 +909,7 @@
             </a:lvl1pPr>
           </a:lstStyle>
           <a:p>
-            <a:pPr algn="l" indent="0" marL="0">
+            <a:pPr marL="0" indent="0" algn="l">
               <a:lnSpc>
                 <a:spcPct val="140000"/>
               </a:lnSpc>
@@ -1155,6 +935,7 @@
         <a:solidFill>
           <a:srgbClr val="FAFAF8"/>
         </a:solidFill>
+        <a:effectLst/>
       </p:bgPr>
     </p:bg>
     <p:spTree>
@@ -1174,7 +955,9 @@
       <p:sp>
         <p:nvSpPr>
           <p:cNvPr id="2" name="Title Placeholder 1"/>
-          <p:cNvSpPr/>
+          <p:cNvSpPr>
+            <a:spLocks noGrp="1"/>
+          </p:cNvSpPr>
           <p:nvPr>
             <p:ph type="title"/>
           </p:nvPr>
@@ -1193,7 +976,7 @@
         <p:txBody>
           <a:bodyPr wrap="square" lIns="0" tIns="0" rIns="0" bIns="0" rtlCol="0" anchor="t"/>
           <a:lstStyle>
-            <a:lvl1pPr algn="l" indent="0" marL="0">
+            <a:lvl1pPr marL="0" indent="0" algn="l">
               <a:lnSpc>
                 <a:spcPct val="115000"/>
               </a:lnSpc>
@@ -1209,7 +992,7 @@
             </a:lvl1pPr>
           </a:lstStyle>
           <a:p>
-            <a:pPr algn="l" indent="0" marL="0">
+            <a:pPr marL="0" indent="0" algn="l">
               <a:lnSpc>
                 <a:spcPct val="115000"/>
               </a:lnSpc>
@@ -1222,9 +1005,11 @@
       <p:sp>
         <p:nvSpPr>
           <p:cNvPr id="3" name="Text Placeholder 2"/>
-          <p:cNvSpPr/>
+          <p:cNvSpPr>
+            <a:spLocks noGrp="1"/>
+          </p:cNvSpPr>
           <p:nvPr>
-            <p:ph idx="101" type="body"/>
+            <p:ph type="body" idx="101"/>
           </p:nvPr>
         </p:nvSpPr>
         <p:spPr>
@@ -1241,7 +1026,7 @@
         <p:txBody>
           <a:bodyPr wrap="square" lIns="0" tIns="0" rIns="0" bIns="0" rtlCol="0" anchor="t"/>
           <a:lstStyle>
-            <a:lvl1pPr algn="l" indent="0" marL="0">
+            <a:lvl1pPr marL="0" indent="0" algn="l">
               <a:lnSpc>
                 <a:spcPct val="140000"/>
               </a:lnSpc>
@@ -1257,7 +1042,7 @@
             </a:lvl1pPr>
           </a:lstStyle>
           <a:p>
-            <a:pPr algn="l" indent="0" marL="0">
+            <a:pPr marL="0" indent="0" algn="l">
               <a:lnSpc>
                 <a:spcPct val="140000"/>
               </a:lnSpc>
@@ -1536,6 +1321,7 @@
         <a:solidFill>
           <a:srgbClr val="BA3920"/>
         </a:solidFill>
+        <a:effectLst/>
       </p:bgPr>
     </p:bg>
     <p:spTree>
@@ -1585,6 +1371,13 @@
           </a:gradFill>
           <a:ln/>
         </p:spPr>
+        <p:txBody>
+          <a:bodyPr/>
+          <a:lstStyle/>
+          <a:p>
+            <a:endParaRPr lang="en-US"/>
+          </a:p>
+        </p:txBody>
       </p:sp>
       <p:sp>
         <p:nvSpPr>
@@ -1609,14 +1402,14 @@
           </a:bodyPr>
           <a:lstStyle/>
           <a:p>
-            <a:pPr algn="l" indent="0" marL="0">
+            <a:pPr marL="0" indent="0" algn="l">
               <a:lnSpc>
                 <a:spcPts val="1820"/>
               </a:lnSpc>
               <a:buNone/>
             </a:pPr>
             <a:r>
-              <a:rPr lang="en-US" sz="1300" b="1" spc="150" kern="0" dirty="0">
+              <a:rPr lang="en-US" sz="1300" b="1" kern="0" spc="150" dirty="0">
                 <a:solidFill>
                   <a:srgbClr val="879BF4"/>
                 </a:solidFill>
@@ -1633,7 +1426,9 @@
       <p:sp>
         <p:nvSpPr>
           <p:cNvPr id="4" name="Text 2"/>
-          <p:cNvSpPr/>
+          <p:cNvSpPr>
+            <a:spLocks noGrp="1"/>
+          </p:cNvSpPr>
           <p:nvPr>
             <p:ph type="title"/>
           </p:nvPr>
@@ -1655,14 +1450,14 @@
           </a:bodyPr>
           <a:lstStyle/>
           <a:p>
-            <a:pPr algn="l" indent="0" marL="0">
+            <a:pPr marL="0" indent="0" algn="l">
               <a:lnSpc>
                 <a:spcPts val="3990"/>
               </a:lnSpc>
               <a:buNone/>
             </a:pPr>
             <a:r>
-              <a:rPr lang="en-US" sz="3800" b="1" i="0" spc="-100" kern="0" dirty="0">
+              <a:rPr lang="en-US" sz="3800" b="1" i="0" kern="0" spc="-100" dirty="0">
                 <a:solidFill>
                   <a:srgbClr val="FAFAF8"/>
                 </a:solidFill>
@@ -1704,6 +1499,13 @@
             <a:prstDash val="solid"/>
           </a:ln>
         </p:spPr>
+        <p:txBody>
+          <a:bodyPr/>
+          <a:lstStyle/>
+          <a:p>
+            <a:endParaRPr lang="en-US"/>
+          </a:p>
+        </p:txBody>
       </p:sp>
       <p:sp>
         <p:nvSpPr>
@@ -1728,14 +1530,14 @@
           </a:bodyPr>
           <a:lstStyle/>
           <a:p>
-            <a:pPr algn="l" indent="0" marL="0">
+            <a:pPr marL="0" indent="0" algn="l">
               <a:lnSpc>
                 <a:spcPts val="1680"/>
               </a:lnSpc>
               <a:buNone/>
             </a:pPr>
             <a:r>
-              <a:rPr lang="en-US" sz="1200" b="1" spc="100" kern="0" dirty="0">
+              <a:rPr lang="en-US" sz="1200" b="1" kern="0" spc="100" dirty="0">
                 <a:solidFill>
                   <a:srgbClr val="DE605E"/>
                 </a:solidFill>
@@ -1772,7 +1574,7 @@
           </a:bodyPr>
           <a:lstStyle/>
           <a:p>
-            <a:pPr algn="l" indent="0" marL="0">
+            <a:pPr marL="0" indent="0" algn="l">
               <a:lnSpc>
                 <a:spcPts val="1755"/>
               </a:lnSpc>
@@ -1816,7 +1618,7 @@
           </a:bodyPr>
           <a:lstStyle/>
           <a:p>
-            <a:pPr algn="l" indent="0" marL="0">
+            <a:pPr marL="0" indent="0" algn="l">
               <a:lnSpc>
                 <a:spcPts val="1755"/>
               </a:lnSpc>
@@ -1860,7 +1662,7 @@
           </a:bodyPr>
           <a:lstStyle/>
           <a:p>
-            <a:pPr algn="l" indent="0" marL="0">
+            <a:pPr marL="0" indent="0" algn="l">
               <a:lnSpc>
                 <a:spcPts val="1755"/>
               </a:lnSpc>
@@ -1909,6 +1711,13 @@
             <a:prstDash val="solid"/>
           </a:ln>
         </p:spPr>
+        <p:txBody>
+          <a:bodyPr/>
+          <a:lstStyle/>
+          <a:p>
+            <a:endParaRPr lang="en-US"/>
+          </a:p>
+        </p:txBody>
       </p:sp>
       <p:sp>
         <p:nvSpPr>
@@ -1933,14 +1742,14 @@
           </a:bodyPr>
           <a:lstStyle/>
           <a:p>
-            <a:pPr algn="l" indent="0" marL="0">
+            <a:pPr marL="0" indent="0" algn="l">
               <a:lnSpc>
                 <a:spcPts val="1680"/>
               </a:lnSpc>
               <a:buNone/>
             </a:pPr>
             <a:r>
-              <a:rPr lang="en-US" sz="1200" b="1" spc="100" kern="0" dirty="0">
+              <a:rPr lang="en-US" sz="1200" b="1" kern="0" spc="100" dirty="0">
                 <a:solidFill>
                   <a:srgbClr val="DE605E"/>
                 </a:solidFill>
@@ -1977,7 +1786,7 @@
           </a:bodyPr>
           <a:lstStyle/>
           <a:p>
-            <a:pPr algn="l" indent="0" marL="0">
+            <a:pPr marL="0" indent="0" algn="l">
               <a:lnSpc>
                 <a:spcPts val="1755"/>
               </a:lnSpc>
@@ -2021,7 +1830,7 @@
           </a:bodyPr>
           <a:lstStyle/>
           <a:p>
-            <a:pPr algn="l" indent="0" marL="0">
+            <a:pPr marL="0" indent="0" algn="l">
               <a:lnSpc>
                 <a:spcPts val="1755"/>
               </a:lnSpc>
@@ -2065,7 +1874,7 @@
           </a:bodyPr>
           <a:lstStyle/>
           <a:p>
-            <a:pPr algn="l" indent="0" marL="0">
+            <a:pPr marL="0" indent="0" algn="l">
               <a:lnSpc>
                 <a:spcPts val="1755"/>
               </a:lnSpc>
@@ -2114,6 +1923,13 @@
             <a:prstDash val="solid"/>
           </a:ln>
         </p:spPr>
+        <p:txBody>
+          <a:bodyPr/>
+          <a:lstStyle/>
+          <a:p>
+            <a:endParaRPr lang="en-US"/>
+          </a:p>
+        </p:txBody>
       </p:sp>
       <p:sp>
         <p:nvSpPr>
@@ -2138,14 +1954,14 @@
           </a:bodyPr>
           <a:lstStyle/>
           <a:p>
-            <a:pPr algn="l" indent="0" marL="0">
+            <a:pPr marL="0" indent="0" algn="l">
               <a:lnSpc>
                 <a:spcPts val="1680"/>
               </a:lnSpc>
               <a:buNone/>
             </a:pPr>
             <a:r>
-              <a:rPr lang="en-US" sz="1200" b="1" spc="100" kern="0" dirty="0">
+              <a:rPr lang="en-US" sz="1200" b="1" kern="0" spc="100" dirty="0">
                 <a:solidFill>
                   <a:srgbClr val="DE605E"/>
                 </a:solidFill>
@@ -2182,7 +1998,7 @@
           </a:bodyPr>
           <a:lstStyle/>
           <a:p>
-            <a:pPr algn="l" indent="0" marL="0">
+            <a:pPr marL="0" indent="0" algn="l">
               <a:lnSpc>
                 <a:spcPts val="1755"/>
               </a:lnSpc>
@@ -2226,7 +2042,7 @@
           </a:bodyPr>
           <a:lstStyle/>
           <a:p>
-            <a:pPr algn="l" indent="0" marL="0">
+            <a:pPr marL="0" indent="0" algn="l">
               <a:lnSpc>
                 <a:spcPts val="1755"/>
               </a:lnSpc>
@@ -2270,7 +2086,7 @@
           </a:bodyPr>
           <a:lstStyle/>
           <a:p>
-            <a:pPr algn="l" indent="0" marL="0">
+            <a:pPr marL="0" indent="0" algn="l">
               <a:lnSpc>
                 <a:spcPts val="1755"/>
               </a:lnSpc>
@@ -2318,7 +2134,7 @@
           </a:bodyPr>
           <a:lstStyle/>
           <a:p>
-            <a:pPr algn="l" indent="0" marL="0">
+            <a:pPr marL="0" indent="0" algn="l">
               <a:lnSpc>
                 <a:spcPts val="2160"/>
               </a:lnSpc>
@@ -2364,19 +2180,19 @@
                 <a:lnTo>
                   <a:pt x="101600" y="904180"/>
                 </a:lnTo>
-                <a:arcTo hR="101600" wR="101600" stAng="5400000" swAng="5400000"/>
+                <a:arcTo wR="101600" hR="101600" stAng="5400000" swAng="5400000"/>
                 <a:lnTo>
                   <a:pt x="0" y="101600"/>
                 </a:lnTo>
-                <a:arcTo hR="101600" wR="101600" stAng="10800000" swAng="5400000"/>
+                <a:arcTo wR="101600" hR="101600" stAng="10800000" swAng="5400000"/>
                 <a:lnTo>
                   <a:pt x="101600" y="0"/>
                 </a:lnTo>
-                <a:arcTo hR="101600" wR="38100" stAng="16200000" swAng="-5400000"/>
+                <a:arcTo wR="38100" hR="101600" stAng="16200000" swAng="-5400000"/>
                 <a:lnTo>
                   <a:pt x="63500" y="802580"/>
                 </a:lnTo>
-                <a:arcTo hR="101600" wR="38100" stAng="10800000" swAng="-5400000"/>
+                <a:arcTo wR="38100" hR="101600" stAng="10800000" swAng="-5400000"/>
                 <a:close/>
               </a:path>
             </a:pathLst>
@@ -2386,6 +2202,13 @@
           </a:solidFill>
           <a:ln/>
         </p:spPr>
+        <p:txBody>
+          <a:bodyPr/>
+          <a:lstStyle/>
+          <a:p>
+            <a:endParaRPr lang="en-US"/>
+          </a:p>
+        </p:txBody>
       </p:sp>
       <p:sp>
         <p:nvSpPr>
@@ -2410,7 +2233,7 @@
           </a:bodyPr>
           <a:lstStyle/>
           <a:p>
-            <a:pPr algn="l" indent="0" marL="0">
+            <a:pPr marL="0" indent="0" algn="l">
               <a:lnSpc>
                 <a:spcPts val="1680"/>
               </a:lnSpc>
@@ -2425,7 +2248,7 @@
                 <a:ea typeface="Inter" pitchFamily="34" charset="-122"/>
                 <a:cs typeface="Inter" pitchFamily="34" charset="-120"/>
               </a:rPr>
-              <a:t>Sources: Zoom announcement (March 10, 2026), Zoom FY26 results (year to Jan 31, 2026), 2024 rebrand coverage</a:t>
+              <a:t>Sources: Zoom announcement (March 10, 2026), Zoom FY26 results, coverage of Zoom’s 2024 rebrand</a:t>
             </a:r>
             <a:endParaRPr lang="en-US" sz="1200" dirty="0"/>
           </a:p>
@@ -2454,7 +2277,7 @@
           </a:bodyPr>
           <a:lstStyle/>
           <a:p>
-            <a:pPr algn="r" indent="0" marL="0">
+            <a:pPr marL="0" indent="0" algn="r">
               <a:lnSpc>
                 <a:spcPts val="1680"/>
               </a:lnSpc>
@@ -2491,6 +2314,7 @@
         <a:solidFill>
           <a:srgbClr val="FAFAF8"/>
         </a:solidFill>
+        <a:effectLst/>
       </p:bgPr>
     </p:bg>
     <p:spTree>
@@ -2530,14 +2354,14 @@
           </a:bodyPr>
           <a:lstStyle/>
           <a:p>
-            <a:pPr algn="l" indent="0" marL="0">
+            <a:pPr marL="0" indent="0" algn="l">
               <a:lnSpc>
                 <a:spcPts val="1820"/>
               </a:lnSpc>
               <a:buNone/>
             </a:pPr>
             <a:r>
-              <a:rPr lang="en-US" sz="1300" b="1" spc="150" kern="0" dirty="0">
+              <a:rPr lang="en-US" sz="1300" b="1" kern="0" spc="150" dirty="0">
                 <a:solidFill>
                   <a:srgbClr val="BC3A21"/>
                 </a:solidFill>
@@ -2554,7 +2378,9 @@
       <p:sp>
         <p:nvSpPr>
           <p:cNvPr id="3" name="Text 1"/>
-          <p:cNvSpPr/>
+          <p:cNvSpPr>
+            <a:spLocks noGrp="1"/>
+          </p:cNvSpPr>
           <p:nvPr>
             <p:ph type="title"/>
           </p:nvPr>
@@ -2576,14 +2402,14 @@
           </a:bodyPr>
           <a:lstStyle/>
           <a:p>
-            <a:pPr algn="l" indent="0" marL="0">
+            <a:pPr marL="0" indent="0" algn="l">
               <a:lnSpc>
                 <a:spcPts val="3570"/>
               </a:lnSpc>
               <a:buNone/>
             </a:pPr>
             <a:r>
-              <a:rPr lang="en-US" sz="3400" b="1" i="0" spc="-100" kern="0" dirty="0">
+              <a:rPr lang="en-US" sz="3400" b="1" i="0" kern="0" spc="-100" dirty="0">
                 <a:solidFill>
                   <a:srgbClr val="0B0B12"/>
                 </a:solidFill>
@@ -2623,6 +2449,13 @@
             <a:prstDash val="solid"/>
           </a:ln>
         </p:spPr>
+        <p:txBody>
+          <a:bodyPr/>
+          <a:lstStyle/>
+          <a:p>
+            <a:endParaRPr lang="en-US"/>
+          </a:p>
+        </p:txBody>
       </p:sp>
       <p:sp>
         <p:nvSpPr>
@@ -2647,7 +2480,7 @@
           </a:bodyPr>
           <a:lstStyle/>
           <a:p>
-            <a:pPr algn="l" indent="0" marL="0">
+            <a:pPr marL="0" indent="0" algn="l">
               <a:lnSpc>
                 <a:spcPts val="2160"/>
               </a:lnSpc>
@@ -2691,7 +2524,7 @@
           </a:bodyPr>
           <a:lstStyle/>
           <a:p>
-            <a:pPr algn="l" indent="0" marL="0">
+            <a:pPr marL="0" indent="0" algn="l">
               <a:lnSpc>
                 <a:spcPts val="2100"/>
               </a:lnSpc>
@@ -2735,7 +2568,7 @@
           </a:bodyPr>
           <a:lstStyle/>
           <a:p>
-            <a:pPr algn="l" indent="0" marL="0">
+            <a:pPr marL="0" indent="0" algn="l">
               <a:lnSpc>
                 <a:spcPts val="1690"/>
               </a:lnSpc>
@@ -2779,7 +2612,7 @@
           </a:bodyPr>
           <a:lstStyle/>
           <a:p>
-            <a:pPr algn="l" indent="0" marL="0">
+            <a:pPr marL="0" indent="0" algn="l">
               <a:lnSpc>
                 <a:spcPts val="2100"/>
               </a:lnSpc>
@@ -2823,7 +2656,7 @@
           </a:bodyPr>
           <a:lstStyle/>
           <a:p>
-            <a:pPr algn="l" indent="0" marL="0">
+            <a:pPr marL="0" indent="0" algn="l">
               <a:lnSpc>
                 <a:spcPts val="1690"/>
               </a:lnSpc>
@@ -2867,7 +2700,7 @@
           </a:bodyPr>
           <a:lstStyle/>
           <a:p>
-            <a:pPr algn="l" indent="0" marL="0">
+            <a:pPr marL="0" indent="0" algn="l">
               <a:lnSpc>
                 <a:spcPts val="2100"/>
               </a:lnSpc>
@@ -2911,7 +2744,7 @@
           </a:bodyPr>
           <a:lstStyle/>
           <a:p>
-            <a:pPr algn="l" indent="0" marL="0">
+            <a:pPr marL="0" indent="0" algn="l">
               <a:lnSpc>
                 <a:spcPts val="1690"/>
               </a:lnSpc>
@@ -2955,7 +2788,7 @@
           </a:bodyPr>
           <a:lstStyle/>
           <a:p>
-            <a:pPr algn="l" indent="0" marL="0">
+            <a:pPr marL="0" indent="0" algn="l">
               <a:lnSpc>
                 <a:spcPts val="2100"/>
               </a:lnSpc>
@@ -2999,7 +2832,7 @@
           </a:bodyPr>
           <a:lstStyle/>
           <a:p>
-            <a:pPr algn="l" indent="0" marL="0">
+            <a:pPr marL="0" indent="0" algn="l">
               <a:lnSpc>
                 <a:spcPts val="1690"/>
               </a:lnSpc>
@@ -3041,6 +2874,13 @@
           </a:solidFill>
           <a:ln/>
         </p:spPr>
+        <p:txBody>
+          <a:bodyPr/>
+          <a:lstStyle/>
+          <a:p>
+            <a:endParaRPr lang="en-US"/>
+          </a:p>
+        </p:txBody>
       </p:sp>
       <p:sp>
         <p:nvSpPr>
@@ -3065,14 +2905,14 @@
           </a:bodyPr>
           <a:lstStyle/>
           <a:p>
-            <a:pPr algn="l" indent="0" marL="0">
+            <a:pPr marL="0" indent="0" algn="l">
               <a:lnSpc>
                 <a:spcPts val="1680"/>
               </a:lnSpc>
               <a:buNone/>
             </a:pPr>
             <a:r>
-              <a:rPr lang="en-US" sz="1200" b="1" spc="100" kern="0" dirty="0">
+              <a:rPr lang="en-US" sz="1200" b="1" kern="0" spc="100" dirty="0">
                 <a:solidFill>
                   <a:srgbClr val="879BF4"/>
                 </a:solidFill>
@@ -3109,14 +2949,14 @@
           </a:bodyPr>
           <a:lstStyle/>
           <a:p>
-            <a:pPr algn="l" indent="0" marL="0">
+            <a:pPr marL="0" indent="0" algn="l">
               <a:lnSpc>
                 <a:spcPts val="5200"/>
               </a:lnSpc>
               <a:buNone/>
             </a:pPr>
             <a:r>
-              <a:rPr lang="en-US" sz="5200" b="1" spc="-150" kern="0" dirty="0">
+              <a:rPr lang="en-US" sz="5200" b="1" kern="0" spc="-150" dirty="0">
                 <a:solidFill>
                   <a:srgbClr val="DE605E"/>
                 </a:solidFill>
@@ -3153,7 +2993,7 @@
           </a:bodyPr>
           <a:lstStyle/>
           <a:p>
-            <a:pPr algn="l" indent="0" marL="0">
+            <a:pPr marL="0" indent="0" algn="l">
               <a:lnSpc>
                 <a:spcPts val="1890"/>
               </a:lnSpc>
@@ -3195,6 +3035,13 @@
           </a:solidFill>
           <a:ln/>
         </p:spPr>
+        <p:txBody>
+          <a:bodyPr/>
+          <a:lstStyle/>
+          <a:p>
+            <a:endParaRPr lang="en-US"/>
+          </a:p>
+        </p:txBody>
       </p:sp>
       <p:sp>
         <p:nvSpPr>
@@ -3217,6 +3064,13 @@
           </a:solidFill>
           <a:ln/>
         </p:spPr>
+        <p:txBody>
+          <a:bodyPr/>
+          <a:lstStyle/>
+          <a:p>
+            <a:endParaRPr lang="en-US"/>
+          </a:p>
+        </p:txBody>
       </p:sp>
       <p:sp>
         <p:nvSpPr>
@@ -3241,7 +3095,7 @@
           </a:bodyPr>
           <a:lstStyle/>
           <a:p>
-            <a:pPr algn="l" indent="0" marL="0">
+            <a:pPr marL="0" indent="0" algn="l">
               <a:lnSpc>
                 <a:spcPts val="1755"/>
               </a:lnSpc>
@@ -3295,6 +3149,13 @@
             <a:prstDash val="solid"/>
           </a:ln>
         </p:spPr>
+        <p:txBody>
+          <a:bodyPr/>
+          <a:lstStyle/>
+          <a:p>
+            <a:endParaRPr lang="en-US"/>
+          </a:p>
+        </p:txBody>
       </p:sp>
       <p:sp>
         <p:nvSpPr>
@@ -3319,7 +3180,7 @@
           </a:bodyPr>
           <a:lstStyle/>
           <a:p>
-            <a:pPr algn="l" indent="0" marL="0">
+            <a:pPr marL="0" indent="0" algn="l">
               <a:lnSpc>
                 <a:spcPts val="1950"/>
               </a:lnSpc>
@@ -3363,7 +3224,7 @@
           </a:bodyPr>
           <a:lstStyle/>
           <a:p>
-            <a:pPr algn="l" indent="0" marL="0">
+            <a:pPr marL="0" indent="0" algn="l">
               <a:lnSpc>
                 <a:spcPts val="1680"/>
               </a:lnSpc>
@@ -3407,7 +3268,7 @@
           </a:bodyPr>
           <a:lstStyle/>
           <a:p>
-            <a:pPr algn="r" indent="0" marL="0">
+            <a:pPr marL="0" indent="0" algn="r">
               <a:lnSpc>
                 <a:spcPts val="1680"/>
               </a:lnSpc>
@@ -3444,6 +3305,7 @@
         <a:solidFill>
           <a:srgbClr val="FAFAF8"/>
         </a:solidFill>
+        <a:effectLst/>
       </p:bgPr>
     </p:bg>
     <p:spTree>
@@ -3483,14 +3345,14 @@
           </a:bodyPr>
           <a:lstStyle/>
           <a:p>
-            <a:pPr algn="l" indent="0" marL="0">
+            <a:pPr marL="0" indent="0" algn="l">
               <a:lnSpc>
                 <a:spcPts val="1820"/>
               </a:lnSpc>
               <a:buNone/>
             </a:pPr>
             <a:r>
-              <a:rPr lang="en-US" sz="1300" b="1" spc="150" kern="0" dirty="0">
+              <a:rPr lang="en-US" sz="1300" b="1" kern="0" spc="150" dirty="0">
                 <a:solidFill>
                   <a:srgbClr val="BC3A21"/>
                 </a:solidFill>
@@ -3507,7 +3369,9 @@
       <p:sp>
         <p:nvSpPr>
           <p:cNvPr id="3" name="Text 1"/>
-          <p:cNvSpPr/>
+          <p:cNvSpPr>
+            <a:spLocks noGrp="1"/>
+          </p:cNvSpPr>
           <p:nvPr>
             <p:ph type="title"/>
           </p:nvPr>
@@ -3529,14 +3393,14 @@
           </a:bodyPr>
           <a:lstStyle/>
           <a:p>
-            <a:pPr algn="l" indent="0" marL="0">
+            <a:pPr marL="0" indent="0" algn="l">
               <a:lnSpc>
                 <a:spcPts val="3903"/>
               </a:lnSpc>
               <a:buNone/>
             </a:pPr>
             <a:r>
-              <a:rPr lang="en-US" sz="3717" b="1" i="0" spc="-100" kern="0" dirty="0">
+              <a:rPr lang="en-US" sz="3717" b="1" i="0" kern="0" spc="-100" dirty="0">
                 <a:solidFill>
                   <a:srgbClr val="0B0B12"/>
                 </a:solidFill>
@@ -3582,7 +3446,7 @@
           </a:bodyPr>
           <a:lstStyle/>
           <a:p>
-            <a:pPr algn="ctr" indent="0" marL="0">
+            <a:pPr marL="0" indent="0" algn="ctr">
               <a:lnSpc>
                 <a:spcPts val="1960"/>
               </a:lnSpc>
@@ -3605,15 +3469,15 @@
       </p:sp>
       <p:pic>
         <p:nvPicPr>
-          <p:cNvPr id="5" name="Image 0" descr="arrow-right">    </p:cNvPr>
+          <p:cNvPr id="5" name="Image 0" descr="arrow-right"/>
           <p:cNvPicPr>
             <a:picLocks noChangeAspect="1"/>
           </p:cNvPicPr>
           <p:nvPr/>
         </p:nvPicPr>
         <p:blipFill>
-          <a:blip r:embed="rId1"/>
-          <a:srcRect l="0" r="0" t="0" b="0"/>
+          <a:blip r:embed="rId3"/>
+          <a:srcRect/>
           <a:stretch/>
         </p:blipFill>
         <p:spPr>
@@ -3658,7 +3522,7 @@
           </a:bodyPr>
           <a:lstStyle/>
           <a:p>
-            <a:pPr algn="ctr" indent="0" marL="0">
+            <a:pPr marL="0" indent="0" algn="ctr">
               <a:lnSpc>
                 <a:spcPts val="1960"/>
               </a:lnSpc>
@@ -3681,15 +3545,15 @@
       </p:sp>
       <p:pic>
         <p:nvPicPr>
-          <p:cNvPr id="7" name="Image 1" descr="arrow-right">    </p:cNvPr>
+          <p:cNvPr id="7" name="Image 1" descr="arrow-right"/>
           <p:cNvPicPr>
             <a:picLocks noChangeAspect="1"/>
           </p:cNvPicPr>
           <p:nvPr/>
         </p:nvPicPr>
         <p:blipFill>
-          <a:blip r:embed="rId2"/>
-          <a:srcRect l="0" r="0" t="0" b="0"/>
+          <a:blip r:embed="rId3"/>
+          <a:srcRect/>
           <a:stretch/>
         </p:blipFill>
         <p:spPr>
@@ -3734,7 +3598,7 @@
           </a:bodyPr>
           <a:lstStyle/>
           <a:p>
-            <a:pPr algn="ctr" indent="0" marL="0">
+            <a:pPr marL="0" indent="0" algn="ctr">
               <a:lnSpc>
                 <a:spcPts val="1960"/>
               </a:lnSpc>
@@ -3757,7 +3621,7 @@
       </p:sp>
       <p:pic>
         <p:nvPicPr>
-          <p:cNvPr id="9" name="Image 2" descr="arrow-right">    </p:cNvPr>
+          <p:cNvPr id="9" name="Image 2" descr="arrow-right"/>
           <p:cNvPicPr>
             <a:picLocks noChangeAspect="1"/>
           </p:cNvPicPr>
@@ -3765,7 +3629,7 @@
         </p:nvPicPr>
         <p:blipFill>
           <a:blip r:embed="rId3"/>
-          <a:srcRect l="0" r="0" t="0" b="0"/>
+          <a:srcRect/>
           <a:stretch/>
         </p:blipFill>
         <p:spPr>
@@ -3810,7 +3674,7 @@
           </a:bodyPr>
           <a:lstStyle/>
           <a:p>
-            <a:pPr algn="ctr" indent="0" marL="0">
+            <a:pPr marL="0" indent="0" algn="ctr">
               <a:lnSpc>
                 <a:spcPts val="1960"/>
               </a:lnSpc>
@@ -3857,6 +3721,13 @@
             <a:prstDash val="solid"/>
           </a:ln>
         </p:spPr>
+        <p:txBody>
+          <a:bodyPr/>
+          <a:lstStyle/>
+          <a:p>
+            <a:endParaRPr lang="en-US"/>
+          </a:p>
+        </p:txBody>
       </p:sp>
       <p:sp>
         <p:nvSpPr>
@@ -3880,11 +3751,11 @@
                 <a:moveTo>
                   <a:pt x="17786" y="76200"/>
                 </a:moveTo>
-                <a:arcTo hR="146050" wR="146050" stAng="12514313" swAng="3685687"/>
+                <a:arcTo wR="146050" hR="146050" stAng="12514313" swAng="3685687"/>
                 <a:lnTo>
                   <a:pt x="3244850" y="0"/>
                 </a:lnTo>
-                <a:arcTo hR="146050" wR="146050" stAng="16200000" swAng="3685687"/>
+                <a:arcTo wR="146050" hR="146050" stAng="16200000" swAng="3685687"/>
                 <a:close/>
               </a:path>
             </a:pathLst>
@@ -3894,6 +3765,13 @@
           </a:solidFill>
           <a:ln/>
         </p:spPr>
+        <p:txBody>
+          <a:bodyPr/>
+          <a:lstStyle/>
+          <a:p>
+            <a:endParaRPr lang="en-US"/>
+          </a:p>
+        </p:txBody>
       </p:sp>
       <p:sp>
         <p:nvSpPr>
@@ -3918,14 +3796,14 @@
           </a:bodyPr>
           <a:lstStyle/>
           <a:p>
-            <a:pPr algn="l" indent="0" marL="0">
+            <a:pPr marL="0" indent="0" algn="l">
               <a:lnSpc>
                 <a:spcPts val="2760"/>
               </a:lnSpc>
               <a:buNone/>
             </a:pPr>
             <a:r>
-              <a:rPr lang="en-US" sz="2300" b="1" spc="-50" kern="0" dirty="0">
+              <a:rPr lang="en-US" sz="2300" b="1" kern="0" spc="-50" dirty="0">
                 <a:solidFill>
                   <a:srgbClr val="BC3A21"/>
                 </a:solidFill>
@@ -3962,7 +3840,7 @@
           </a:bodyPr>
           <a:lstStyle/>
           <a:p>
-            <a:pPr algn="l" indent="0" marL="0">
+            <a:pPr marL="0" indent="0" algn="l">
               <a:lnSpc>
                 <a:spcPts val="1890"/>
               </a:lnSpc>
@@ -4006,7 +3884,7 @@
           </a:bodyPr>
           <a:lstStyle/>
           <a:p>
-            <a:pPr algn="l" indent="0" marL="0">
+            <a:pPr marL="0" indent="0" algn="l">
               <a:lnSpc>
                 <a:spcPts val="1890"/>
               </a:lnSpc>
@@ -4049,6 +3927,13 @@
             <a:prstDash val="solid"/>
           </a:ln>
         </p:spPr>
+        <p:txBody>
+          <a:bodyPr/>
+          <a:lstStyle/>
+          <a:p>
+            <a:endParaRPr lang="en-US"/>
+          </a:p>
+        </p:txBody>
       </p:sp>
       <p:sp>
         <p:nvSpPr>
@@ -4073,7 +3958,7 @@
           </a:bodyPr>
           <a:lstStyle/>
           <a:p>
-            <a:pPr algn="l" indent="0" marL="0">
+            <a:pPr marL="0" indent="0" algn="l">
               <a:lnSpc>
                 <a:spcPts val="1680"/>
               </a:lnSpc>
@@ -4120,6 +4005,13 @@
             <a:prstDash val="solid"/>
           </a:ln>
         </p:spPr>
+        <p:txBody>
+          <a:bodyPr/>
+          <a:lstStyle/>
+          <a:p>
+            <a:endParaRPr lang="en-US"/>
+          </a:p>
+        </p:txBody>
       </p:sp>
       <p:sp>
         <p:nvSpPr>
@@ -4143,11 +4035,11 @@
                 <a:moveTo>
                   <a:pt x="17786" y="76200"/>
                 </a:moveTo>
-                <a:arcTo hR="146050" wR="146050" stAng="12514313" swAng="3685687"/>
+                <a:arcTo wR="146050" hR="146050" stAng="12514313" swAng="3685687"/>
                 <a:lnTo>
                   <a:pt x="3244850" y="0"/>
                 </a:lnTo>
-                <a:arcTo hR="146050" wR="146050" stAng="16200000" swAng="3685687"/>
+                <a:arcTo wR="146050" hR="146050" stAng="16200000" swAng="3685687"/>
                 <a:close/>
               </a:path>
             </a:pathLst>
@@ -4157,6 +4049,13 @@
           </a:solidFill>
           <a:ln/>
         </p:spPr>
+        <p:txBody>
+          <a:bodyPr/>
+          <a:lstStyle/>
+          <a:p>
+            <a:endParaRPr lang="en-US"/>
+          </a:p>
+        </p:txBody>
       </p:sp>
       <p:sp>
         <p:nvSpPr>
@@ -4181,14 +4080,14 @@
           </a:bodyPr>
           <a:lstStyle/>
           <a:p>
-            <a:pPr algn="l" indent="0" marL="0">
+            <a:pPr marL="0" indent="0" algn="l">
               <a:lnSpc>
                 <a:spcPts val="2674"/>
               </a:lnSpc>
               <a:buNone/>
             </a:pPr>
             <a:r>
-              <a:rPr lang="en-US" sz="2228" b="1" spc="-50" kern="0" dirty="0">
+              <a:rPr lang="en-US" sz="2228" b="1" kern="0" spc="-50" dirty="0">
                 <a:solidFill>
                   <a:srgbClr val="804979"/>
                 </a:solidFill>
@@ -4225,7 +4124,7 @@
           </a:bodyPr>
           <a:lstStyle/>
           <a:p>
-            <a:pPr algn="l" indent="0" marL="0">
+            <a:pPr marL="0" indent="0" algn="l">
               <a:lnSpc>
                 <a:spcPts val="1837"/>
               </a:lnSpc>
@@ -4269,7 +4168,7 @@
           </a:bodyPr>
           <a:lstStyle/>
           <a:p>
-            <a:pPr algn="l" indent="0" marL="0">
+            <a:pPr marL="0" indent="0" algn="l">
               <a:lnSpc>
                 <a:spcPts val="1837"/>
               </a:lnSpc>
@@ -4312,6 +4211,13 @@
             <a:prstDash val="solid"/>
           </a:ln>
         </p:spPr>
+        <p:txBody>
+          <a:bodyPr/>
+          <a:lstStyle/>
+          <a:p>
+            <a:endParaRPr lang="en-US"/>
+          </a:p>
+        </p:txBody>
       </p:sp>
       <p:sp>
         <p:nvSpPr>
@@ -4336,7 +4242,7 @@
           </a:bodyPr>
           <a:lstStyle/>
           <a:p>
-            <a:pPr algn="l" indent="0" marL="0">
+            <a:pPr marL="0" indent="0" algn="l">
               <a:lnSpc>
                 <a:spcPts val="1633"/>
               </a:lnSpc>
@@ -4383,6 +4289,13 @@
             <a:prstDash val="solid"/>
           </a:ln>
         </p:spPr>
+        <p:txBody>
+          <a:bodyPr/>
+          <a:lstStyle/>
+          <a:p>
+            <a:endParaRPr lang="en-US"/>
+          </a:p>
+        </p:txBody>
       </p:sp>
       <p:sp>
         <p:nvSpPr>
@@ -4406,11 +4319,11 @@
                 <a:moveTo>
                   <a:pt x="17786" y="76200"/>
                 </a:moveTo>
-                <a:arcTo hR="146050" wR="146050" stAng="12514313" swAng="3685687"/>
+                <a:arcTo wR="146050" hR="146050" stAng="12514313" swAng="3685687"/>
                 <a:lnTo>
                   <a:pt x="3244850" y="0"/>
                 </a:lnTo>
-                <a:arcTo hR="146050" wR="146050" stAng="16200000" swAng="3685687"/>
+                <a:arcTo wR="146050" hR="146050" stAng="16200000" swAng="3685687"/>
                 <a:close/>
               </a:path>
             </a:pathLst>
@@ -4420,6 +4333,13 @@
           </a:solidFill>
           <a:ln/>
         </p:spPr>
+        <p:txBody>
+          <a:bodyPr/>
+          <a:lstStyle/>
+          <a:p>
+            <a:endParaRPr lang="en-US"/>
+          </a:p>
+        </p:txBody>
       </p:sp>
       <p:sp>
         <p:nvSpPr>
@@ -4444,14 +4364,14 @@
           </a:bodyPr>
           <a:lstStyle/>
           <a:p>
-            <a:pPr algn="l" indent="0" marL="0">
+            <a:pPr marL="0" indent="0" algn="l">
               <a:lnSpc>
                 <a:spcPts val="2674"/>
               </a:lnSpc>
               <a:buNone/>
             </a:pPr>
             <a:r>
-              <a:rPr lang="en-US" sz="2228" b="1" spc="-50" kern="0" dirty="0">
+              <a:rPr lang="en-US" sz="2228" b="1" kern="0" spc="-50" dirty="0">
                 <a:solidFill>
                   <a:srgbClr val="4558D2"/>
                 </a:solidFill>
@@ -4488,7 +4408,7 @@
           </a:bodyPr>
           <a:lstStyle/>
           <a:p>
-            <a:pPr algn="l" indent="0" marL="0">
+            <a:pPr marL="0" indent="0" algn="l">
               <a:lnSpc>
                 <a:spcPts val="1837"/>
               </a:lnSpc>
@@ -4532,7 +4452,7 @@
           </a:bodyPr>
           <a:lstStyle/>
           <a:p>
-            <a:pPr algn="l" indent="0" marL="0">
+            <a:pPr marL="0" indent="0" algn="l">
               <a:lnSpc>
                 <a:spcPts val="1837"/>
               </a:lnSpc>
@@ -4575,6 +4495,13 @@
             <a:prstDash val="solid"/>
           </a:ln>
         </p:spPr>
+        <p:txBody>
+          <a:bodyPr/>
+          <a:lstStyle/>
+          <a:p>
+            <a:endParaRPr lang="en-US"/>
+          </a:p>
+        </p:txBody>
       </p:sp>
       <p:sp>
         <p:nvSpPr>
@@ -4599,7 +4526,7 @@
           </a:bodyPr>
           <a:lstStyle/>
           <a:p>
-            <a:pPr algn="l" indent="0" marL="0">
+            <a:pPr marL="0" indent="0" algn="l">
               <a:lnSpc>
                 <a:spcPts val="1633"/>
               </a:lnSpc>
@@ -4643,7 +4570,7 @@
           </a:bodyPr>
           <a:lstStyle/>
           <a:p>
-            <a:pPr algn="l" indent="0" marL="0">
+            <a:pPr marL="0" indent="0" algn="l">
               <a:lnSpc>
                 <a:spcPts val="1680"/>
               </a:lnSpc>
@@ -4687,7 +4614,7 @@
           </a:bodyPr>
           <a:lstStyle/>
           <a:p>
-            <a:pPr algn="l" indent="0" marL="0">
+            <a:pPr marL="0" indent="0" algn="l">
               <a:lnSpc>
                 <a:spcPts val="1680"/>
               </a:lnSpc>
@@ -4731,7 +4658,7 @@
           </a:bodyPr>
           <a:lstStyle/>
           <a:p>
-            <a:pPr algn="r" indent="0" marL="0">
+            <a:pPr marL="0" indent="0" algn="r">
               <a:lnSpc>
                 <a:spcPts val="1680"/>
               </a:lnSpc>
@@ -4768,6 +4695,7 @@
         <a:solidFill>
           <a:srgbClr val="0B0B12"/>
         </a:solidFill>
+        <a:effectLst/>
       </p:bgPr>
     </p:bg>
     <p:spTree>
@@ -4807,14 +4735,14 @@
           </a:bodyPr>
           <a:lstStyle/>
           <a:p>
-            <a:pPr algn="l" indent="0" marL="0">
+            <a:pPr marL="0" indent="0" algn="l">
               <a:lnSpc>
                 <a:spcPts val="1820"/>
               </a:lnSpc>
               <a:buNone/>
             </a:pPr>
             <a:r>
-              <a:rPr lang="en-US" sz="1300" b="1" spc="150" kern="0" dirty="0">
+              <a:rPr lang="en-US" sz="1300" b="1" kern="0" spc="150" dirty="0">
                 <a:solidFill>
                   <a:srgbClr val="DE605E"/>
                 </a:solidFill>
@@ -4831,7 +4759,9 @@
       <p:sp>
         <p:nvSpPr>
           <p:cNvPr id="3" name="Text 1"/>
-          <p:cNvSpPr/>
+          <p:cNvSpPr>
+            <a:spLocks noGrp="1"/>
+          </p:cNvSpPr>
           <p:nvPr>
             <p:ph type="title"/>
           </p:nvPr>
@@ -4853,14 +4783,14 @@
           </a:bodyPr>
           <a:lstStyle/>
           <a:p>
-            <a:pPr algn="l" indent="0" marL="0">
+            <a:pPr marL="0" indent="0" algn="l">
               <a:lnSpc>
                 <a:spcPts val="3915"/>
               </a:lnSpc>
               <a:buNone/>
             </a:pPr>
             <a:r>
-              <a:rPr lang="en-US" sz="3729" b="1" i="0" spc="-100" kern="0" dirty="0">
+              <a:rPr lang="en-US" sz="3729" b="1" i="0" kern="0" spc="-100" dirty="0">
                 <a:solidFill>
                   <a:srgbClr val="FAFAF8"/>
                 </a:solidFill>
@@ -4900,6 +4830,13 @@
             <a:prstDash val="solid"/>
           </a:ln>
         </p:spPr>
+        <p:txBody>
+          <a:bodyPr/>
+          <a:lstStyle/>
+          <a:p>
+            <a:endParaRPr lang="en-US"/>
+          </a:p>
+        </p:txBody>
       </p:sp>
       <p:sp>
         <p:nvSpPr>
@@ -4924,14 +4861,14 @@
           </a:bodyPr>
           <a:lstStyle/>
           <a:p>
-            <a:pPr algn="l" indent="0" marL="0">
+            <a:pPr marL="0" indent="0" algn="l">
               <a:lnSpc>
                 <a:spcPts val="1680"/>
               </a:lnSpc>
               <a:buNone/>
             </a:pPr>
             <a:r>
-              <a:rPr lang="en-US" sz="1200" b="1" spc="100" kern="0" dirty="0">
+              <a:rPr lang="en-US" sz="1200" b="1" kern="0" spc="100" dirty="0">
                 <a:solidFill>
                   <a:srgbClr val="879BF4"/>
                 </a:solidFill>
@@ -4968,14 +4905,14 @@
           </a:bodyPr>
           <a:lstStyle/>
           <a:p>
-            <a:pPr algn="l" indent="0" marL="0">
+            <a:pPr marL="0" indent="0" algn="l">
               <a:lnSpc>
                 <a:spcPts val="2640"/>
               </a:lnSpc>
               <a:buNone/>
             </a:pPr>
             <a:r>
-              <a:rPr lang="en-US" sz="2200" b="1" spc="-50" kern="0" dirty="0">
+              <a:rPr lang="en-US" sz="2200" b="1" kern="0" spc="-50" dirty="0">
                 <a:solidFill>
                   <a:srgbClr val="FAFAF8"/>
                 </a:solidFill>
@@ -5012,7 +4949,7 @@
           </a:bodyPr>
           <a:lstStyle/>
           <a:p>
-            <a:pPr algn="l" indent="0" marL="0">
+            <a:pPr marL="0" indent="0" algn="l">
               <a:lnSpc>
                 <a:spcPts val="1755"/>
               </a:lnSpc>
@@ -5056,7 +4993,7 @@
           </a:bodyPr>
           <a:lstStyle/>
           <a:p>
-            <a:pPr algn="l" indent="0" marL="0">
+            <a:pPr marL="0" indent="0" algn="l">
               <a:lnSpc>
                 <a:spcPts val="1755"/>
               </a:lnSpc>
@@ -5103,6 +5040,13 @@
             <a:prstDash val="solid"/>
           </a:ln>
         </p:spPr>
+        <p:txBody>
+          <a:bodyPr/>
+          <a:lstStyle/>
+          <a:p>
+            <a:endParaRPr lang="en-US"/>
+          </a:p>
+        </p:txBody>
       </p:sp>
       <p:sp>
         <p:nvSpPr>
@@ -5127,14 +5071,14 @@
           </a:bodyPr>
           <a:lstStyle/>
           <a:p>
-            <a:pPr algn="l" indent="0" marL="0">
+            <a:pPr marL="0" indent="0" algn="l">
               <a:lnSpc>
                 <a:spcPts val="1680"/>
               </a:lnSpc>
               <a:buNone/>
             </a:pPr>
             <a:r>
-              <a:rPr lang="en-US" sz="1200" b="1" spc="100" kern="0" dirty="0">
+              <a:rPr lang="en-US" sz="1200" b="1" kern="0" spc="100" dirty="0">
                 <a:solidFill>
                   <a:srgbClr val="879BF4"/>
                 </a:solidFill>
@@ -5171,14 +5115,14 @@
           </a:bodyPr>
           <a:lstStyle/>
           <a:p>
-            <a:pPr algn="l" indent="0" marL="0">
+            <a:pPr marL="0" indent="0" algn="l">
               <a:lnSpc>
                 <a:spcPts val="2640"/>
               </a:lnSpc>
               <a:buNone/>
             </a:pPr>
             <a:r>
-              <a:rPr lang="en-US" sz="2200" b="1" spc="-50" kern="0" dirty="0">
+              <a:rPr lang="en-US" sz="2200" b="1" kern="0" spc="-50" dirty="0">
                 <a:solidFill>
                   <a:srgbClr val="FAFAF8"/>
                 </a:solidFill>
@@ -5215,7 +5159,7 @@
           </a:bodyPr>
           <a:lstStyle/>
           <a:p>
-            <a:pPr algn="l" indent="0" marL="0">
+            <a:pPr marL="0" indent="0" algn="l">
               <a:lnSpc>
                 <a:spcPts val="1755"/>
               </a:lnSpc>
@@ -5259,7 +5203,7 @@
           </a:bodyPr>
           <a:lstStyle/>
           <a:p>
-            <a:pPr algn="l" indent="0" marL="0">
+            <a:pPr marL="0" indent="0" algn="l">
               <a:lnSpc>
                 <a:spcPts val="1755"/>
               </a:lnSpc>
@@ -5306,6 +5250,13 @@
             <a:prstDash val="solid"/>
           </a:ln>
         </p:spPr>
+        <p:txBody>
+          <a:bodyPr/>
+          <a:lstStyle/>
+          <a:p>
+            <a:endParaRPr lang="en-US"/>
+          </a:p>
+        </p:txBody>
       </p:sp>
       <p:sp>
         <p:nvSpPr>
@@ -5330,14 +5281,14 @@
           </a:bodyPr>
           <a:lstStyle/>
           <a:p>
-            <a:pPr algn="l" indent="0" marL="0">
+            <a:pPr marL="0" indent="0" algn="l">
               <a:lnSpc>
                 <a:spcPts val="1675"/>
               </a:lnSpc>
               <a:buNone/>
             </a:pPr>
             <a:r>
-              <a:rPr lang="en-US" sz="1196" b="1" spc="100" kern="0" dirty="0">
+              <a:rPr lang="en-US" sz="1196" b="1" kern="0" spc="100" dirty="0">
                 <a:solidFill>
                   <a:srgbClr val="879BF4"/>
                 </a:solidFill>
@@ -5374,14 +5325,14 @@
           </a:bodyPr>
           <a:lstStyle/>
           <a:p>
-            <a:pPr algn="l" indent="0" marL="0">
+            <a:pPr marL="0" indent="0" algn="l">
               <a:lnSpc>
                 <a:spcPts val="2582"/>
               </a:lnSpc>
               <a:buNone/>
             </a:pPr>
             <a:r>
-              <a:rPr lang="en-US" sz="2152" b="1" spc="-50" kern="0" dirty="0">
+              <a:rPr lang="en-US" sz="2152" b="1" kern="0" spc="-50" dirty="0">
                 <a:solidFill>
                   <a:srgbClr val="FAFAF8"/>
                 </a:solidFill>
@@ -5418,7 +5369,7 @@
           </a:bodyPr>
           <a:lstStyle/>
           <a:p>
-            <a:pPr algn="l" indent="0" marL="0">
+            <a:pPr marL="0" indent="0" algn="l">
               <a:lnSpc>
                 <a:spcPts val="1733"/>
               </a:lnSpc>
@@ -5462,7 +5413,7 @@
           </a:bodyPr>
           <a:lstStyle/>
           <a:p>
-            <a:pPr algn="l" indent="0" marL="0">
+            <a:pPr marL="0" indent="0" algn="l">
               <a:lnSpc>
                 <a:spcPts val="1733"/>
               </a:lnSpc>
@@ -5509,6 +5460,13 @@
             <a:prstDash val="solid"/>
           </a:ln>
         </p:spPr>
+        <p:txBody>
+          <a:bodyPr/>
+          <a:lstStyle/>
+          <a:p>
+            <a:endParaRPr lang="en-US"/>
+          </a:p>
+        </p:txBody>
       </p:sp>
       <p:sp>
         <p:nvSpPr>
@@ -5533,7 +5491,7 @@
           </a:bodyPr>
           <a:lstStyle/>
           <a:p>
-            <a:pPr algn="l" indent="0" marL="0">
+            <a:pPr marL="0" indent="0" algn="l">
               <a:lnSpc>
                 <a:spcPts val="2118"/>
               </a:lnSpc>
@@ -5575,6 +5533,13 @@
           </a:solidFill>
           <a:ln/>
         </p:spPr>
+        <p:txBody>
+          <a:bodyPr/>
+          <a:lstStyle/>
+          <a:p>
+            <a:endParaRPr lang="en-US"/>
+          </a:p>
+        </p:txBody>
       </p:sp>
       <p:sp>
         <p:nvSpPr>
@@ -5599,7 +5564,7 @@
           </a:bodyPr>
           <a:lstStyle/>
           <a:p>
-            <a:pPr algn="l" indent="0" marL="0">
+            <a:pPr marL="0" indent="0" algn="l">
               <a:lnSpc>
                 <a:spcPts val="1690"/>
               </a:lnSpc>
@@ -5641,6 +5606,13 @@
           </a:solidFill>
           <a:ln/>
         </p:spPr>
+        <p:txBody>
+          <a:bodyPr/>
+          <a:lstStyle/>
+          <a:p>
+            <a:endParaRPr lang="en-US"/>
+          </a:p>
+        </p:txBody>
       </p:sp>
       <p:sp>
         <p:nvSpPr>
@@ -5665,7 +5637,7 @@
           </a:bodyPr>
           <a:lstStyle/>
           <a:p>
-            <a:pPr algn="l" indent="0" marL="0">
+            <a:pPr marL="0" indent="0" algn="l">
               <a:lnSpc>
                 <a:spcPts val="1690"/>
               </a:lnSpc>
@@ -5680,7 +5652,7 @@
                 <a:ea typeface="Inter" pitchFamily="34" charset="-122"/>
                 <a:cs typeface="Inter" pitchFamily="34" charset="-120"/>
               </a:rPr>
-              <a:t>A baseline agreed first: the CFO’s target</a:t>
+              <a:t>A baseline agreed first: the revenue target</a:t>
             </a:r>
             <a:endParaRPr lang="en-US" sz="1300" dirty="0"/>
           </a:p>
@@ -5707,6 +5679,13 @@
           </a:solidFill>
           <a:ln/>
         </p:spPr>
+        <p:txBody>
+          <a:bodyPr/>
+          <a:lstStyle/>
+          <a:p>
+            <a:endParaRPr lang="en-US"/>
+          </a:p>
+        </p:txBody>
       </p:sp>
       <p:sp>
         <p:nvSpPr>
@@ -5731,7 +5710,7 @@
           </a:bodyPr>
           <a:lstStyle/>
           <a:p>
-            <a:pPr algn="l" indent="0" marL="0">
+            <a:pPr marL="0" indent="0" algn="l">
               <a:lnSpc>
                 <a:spcPts val="1690"/>
               </a:lnSpc>
@@ -5775,7 +5754,7 @@
           </a:bodyPr>
           <a:lstStyle/>
           <a:p>
-            <a:pPr algn="l" indent="0" marL="0">
+            <a:pPr marL="0" indent="0" algn="l">
               <a:lnSpc>
                 <a:spcPts val="1680"/>
               </a:lnSpc>
@@ -5819,7 +5798,7 @@
           </a:bodyPr>
           <a:lstStyle/>
           <a:p>
-            <a:pPr algn="l" indent="0" marL="0">
+            <a:pPr marL="0" indent="0" algn="l">
               <a:lnSpc>
                 <a:spcPts val="1680"/>
               </a:lnSpc>
@@ -5863,7 +5842,7 @@
           </a:bodyPr>
           <a:lstStyle/>
           <a:p>
-            <a:pPr algn="r" indent="0" marL="0">
+            <a:pPr marL="0" indent="0" algn="r">
               <a:lnSpc>
                 <a:spcPts val="1680"/>
               </a:lnSpc>
@@ -5900,6 +5879,7 @@
         <a:solidFill>
           <a:srgbClr val="FAFAF8"/>
         </a:solidFill>
+        <a:effectLst/>
       </p:bgPr>
     </p:bg>
     <p:spTree>
@@ -5939,14 +5919,14 @@
           </a:bodyPr>
           <a:lstStyle/>
           <a:p>
-            <a:pPr algn="l" indent="0" marL="0">
+            <a:pPr marL="0" indent="0" algn="l">
               <a:lnSpc>
                 <a:spcPts val="1820"/>
               </a:lnSpc>
               <a:buNone/>
             </a:pPr>
             <a:r>
-              <a:rPr lang="en-US" sz="1300" b="1" spc="150" kern="0" dirty="0">
+              <a:rPr lang="en-US" sz="1300" b="1" kern="0" spc="150" dirty="0">
                 <a:solidFill>
                   <a:srgbClr val="BC3A21"/>
                 </a:solidFill>
@@ -5963,7 +5943,9 @@
       <p:sp>
         <p:nvSpPr>
           <p:cNvPr id="3" name="Text 1"/>
-          <p:cNvSpPr/>
+          <p:cNvSpPr>
+            <a:spLocks noGrp="1"/>
+          </p:cNvSpPr>
           <p:nvPr>
             <p:ph type="title"/>
           </p:nvPr>
@@ -5985,14 +5967,14 @@
           </a:bodyPr>
           <a:lstStyle/>
           <a:p>
-            <a:pPr algn="l" indent="0" marL="0">
+            <a:pPr marL="0" indent="0" algn="l">
               <a:lnSpc>
                 <a:spcPts val="3990"/>
               </a:lnSpc>
               <a:buNone/>
             </a:pPr>
             <a:r>
-              <a:rPr lang="en-US" sz="3800" b="1" i="0" spc="-100" kern="0" dirty="0">
+              <a:rPr lang="en-US" sz="3800" b="1" i="0" kern="0" spc="-100" dirty="0">
                 <a:solidFill>
                   <a:srgbClr val="0B0B12"/>
                 </a:solidFill>
@@ -6000,7 +5982,7 @@
                 <a:ea typeface="Inter" pitchFamily="34" charset="-122"/>
                 <a:cs typeface="Inter" pitchFamily="34" charset="-120"/>
               </a:rPr>
-              <a:t>The CRO loop, run on Northwind</a:t>
+              <a:t>The CRO loop</a:t>
             </a:r>
             <a:endParaRPr lang="en-US" sz="3800" dirty="0"/>
           </a:p>
@@ -6032,6 +6014,13 @@
             <a:prstDash val="solid"/>
           </a:ln>
         </p:spPr>
+        <p:txBody>
+          <a:bodyPr/>
+          <a:lstStyle/>
+          <a:p>
+            <a:endParaRPr lang="en-US"/>
+          </a:p>
+        </p:txBody>
       </p:sp>
       <p:sp>
         <p:nvSpPr>
@@ -6055,11 +6044,11 @@
                 <a:moveTo>
                   <a:pt x="8487" y="76200"/>
                 </a:moveTo>
-                <a:arcTo hR="120650" wR="120650" stAng="12097096" swAng="4102904"/>
+                <a:arcTo wR="120650" hR="120650" stAng="12097096" swAng="4102904"/>
                 <a:lnTo>
                   <a:pt x="1878310" y="0"/>
                 </a:lnTo>
-                <a:arcTo hR="120650" wR="120650" stAng="16200000" swAng="4102904"/>
+                <a:arcTo wR="120650" hR="120650" stAng="16200000" swAng="4102904"/>
                 <a:close/>
               </a:path>
             </a:pathLst>
@@ -6069,6 +6058,13 @@
           </a:solidFill>
           <a:ln/>
         </p:spPr>
+        <p:txBody>
+          <a:bodyPr/>
+          <a:lstStyle/>
+          <a:p>
+            <a:endParaRPr lang="en-US"/>
+          </a:p>
+        </p:txBody>
       </p:sp>
       <p:sp>
         <p:nvSpPr>
@@ -6093,14 +6089,14 @@
           </a:bodyPr>
           <a:lstStyle/>
           <a:p>
-            <a:pPr algn="l" indent="0" marL="0">
+            <a:pPr marL="0" indent="0" algn="l">
               <a:lnSpc>
                 <a:spcPts val="2640"/>
               </a:lnSpc>
               <a:buNone/>
             </a:pPr>
             <a:r>
-              <a:rPr lang="en-US" sz="2200" b="1" spc="-50" kern="0" dirty="0">
+              <a:rPr lang="en-US" sz="2200" b="1" kern="0" spc="-50" dirty="0">
                 <a:solidFill>
                   <a:srgbClr val="BC3A21"/>
                 </a:solidFill>
@@ -6135,6 +6131,13 @@
           </a:solidFill>
           <a:ln/>
         </p:spPr>
+        <p:txBody>
+          <a:bodyPr/>
+          <a:lstStyle/>
+          <a:p>
+            <a:endParaRPr lang="en-US"/>
+          </a:p>
+        </p:txBody>
       </p:sp>
       <p:sp>
         <p:nvSpPr>
@@ -6157,6 +6160,13 @@
           </a:solidFill>
           <a:ln/>
         </p:spPr>
+        <p:txBody>
+          <a:bodyPr/>
+          <a:lstStyle/>
+          <a:p>
+            <a:endParaRPr lang="en-US"/>
+          </a:p>
+        </p:txBody>
       </p:sp>
       <p:sp>
         <p:nvSpPr>
@@ -6181,7 +6191,7 @@
           </a:bodyPr>
           <a:lstStyle/>
           <a:p>
-            <a:pPr algn="l" indent="0" marL="0">
+            <a:pPr marL="0" indent="0" algn="l">
               <a:lnSpc>
                 <a:spcPts val="1680"/>
               </a:lnSpc>
@@ -6225,7 +6235,7 @@
           </a:bodyPr>
           <a:lstStyle/>
           <a:p>
-            <a:pPr algn="l" indent="0" marL="0">
+            <a:pPr marL="0" indent="0" algn="l">
               <a:lnSpc>
                 <a:spcPts val="1680"/>
               </a:lnSpc>
@@ -6267,6 +6277,13 @@
           </a:solidFill>
           <a:ln/>
         </p:spPr>
+        <p:txBody>
+          <a:bodyPr/>
+          <a:lstStyle/>
+          <a:p>
+            <a:endParaRPr lang="en-US"/>
+          </a:p>
+        </p:txBody>
       </p:sp>
       <p:sp>
         <p:nvSpPr>
@@ -6291,7 +6308,7 @@
           </a:bodyPr>
           <a:lstStyle/>
           <a:p>
-            <a:pPr algn="l" indent="0" marL="0">
+            <a:pPr marL="0" indent="0" algn="l">
               <a:lnSpc>
                 <a:spcPts val="1680"/>
               </a:lnSpc>
@@ -6335,7 +6352,7 @@
           </a:bodyPr>
           <a:lstStyle/>
           <a:p>
-            <a:pPr algn="l" indent="0" marL="0">
+            <a:pPr marL="0" indent="0" algn="l">
               <a:lnSpc>
                 <a:spcPts val="1680"/>
               </a:lnSpc>
@@ -6377,6 +6394,13 @@
           </a:solidFill>
           <a:ln/>
         </p:spPr>
+        <p:txBody>
+          <a:bodyPr/>
+          <a:lstStyle/>
+          <a:p>
+            <a:endParaRPr lang="en-US"/>
+          </a:p>
+        </p:txBody>
       </p:sp>
       <p:sp>
         <p:nvSpPr>
@@ -6401,7 +6425,7 @@
           </a:bodyPr>
           <a:lstStyle/>
           <a:p>
-            <a:pPr algn="l" indent="0" marL="0">
+            <a:pPr marL="0" indent="0" algn="l">
               <a:lnSpc>
                 <a:spcPts val="1680"/>
               </a:lnSpc>
@@ -6445,7 +6469,7 @@
           </a:bodyPr>
           <a:lstStyle/>
           <a:p>
-            <a:pPr algn="l" indent="0" marL="0">
+            <a:pPr marL="0" indent="0" algn="l">
               <a:lnSpc>
                 <a:spcPts val="1680"/>
               </a:lnSpc>
@@ -6489,7 +6513,7 @@
           </a:bodyPr>
           <a:lstStyle/>
           <a:p>
-            <a:pPr algn="l" indent="0" marL="0">
+            <a:pPr marL="0" indent="0" algn="l">
               <a:lnSpc>
                 <a:spcPts val="1750"/>
               </a:lnSpc>
@@ -6533,7 +6557,7 @@
           </a:bodyPr>
           <a:lstStyle/>
           <a:p>
-            <a:pPr algn="l" indent="0" marL="0">
+            <a:pPr marL="0" indent="0" algn="l">
               <a:lnSpc>
                 <a:spcPts val="1620"/>
               </a:lnSpc>
@@ -6591,6 +6615,13 @@
             <a:prstDash val="solid"/>
           </a:ln>
         </p:spPr>
+        <p:txBody>
+          <a:bodyPr/>
+          <a:lstStyle/>
+          <a:p>
+            <a:endParaRPr lang="en-US"/>
+          </a:p>
+        </p:txBody>
       </p:sp>
       <p:sp>
         <p:nvSpPr>
@@ -6614,11 +6645,11 @@
                 <a:moveTo>
                   <a:pt x="8487" y="76200"/>
                 </a:moveTo>
-                <a:arcTo hR="120650" wR="120650" stAng="12097096" swAng="4102904"/>
+                <a:arcTo wR="120650" hR="120650" stAng="12097096" swAng="4102904"/>
                 <a:lnTo>
                   <a:pt x="1878360" y="0"/>
                 </a:lnTo>
-                <a:arcTo hR="120650" wR="120650" stAng="16200000" swAng="4102904"/>
+                <a:arcTo wR="120650" hR="120650" stAng="16200000" swAng="4102904"/>
                 <a:close/>
               </a:path>
             </a:pathLst>
@@ -6628,6 +6659,13 @@
           </a:solidFill>
           <a:ln/>
         </p:spPr>
+        <p:txBody>
+          <a:bodyPr/>
+          <a:lstStyle/>
+          <a:p>
+            <a:endParaRPr lang="en-US"/>
+          </a:p>
+        </p:txBody>
       </p:sp>
       <p:sp>
         <p:nvSpPr>
@@ -6652,14 +6690,14 @@
           </a:bodyPr>
           <a:lstStyle/>
           <a:p>
-            <a:pPr algn="l" indent="0" marL="0">
+            <a:pPr marL="0" indent="0" algn="l">
               <a:lnSpc>
                 <a:spcPts val="2640"/>
               </a:lnSpc>
               <a:buNone/>
             </a:pPr>
             <a:r>
-              <a:rPr lang="en-US" sz="2200" b="1" spc="-50" kern="0" dirty="0">
+              <a:rPr lang="en-US" sz="2200" b="1" kern="0" spc="-50" dirty="0">
                 <a:solidFill>
                   <a:srgbClr val="9E414D"/>
                 </a:solidFill>
@@ -6694,6 +6732,13 @@
           </a:solidFill>
           <a:ln/>
         </p:spPr>
+        <p:txBody>
+          <a:bodyPr/>
+          <a:lstStyle/>
+          <a:p>
+            <a:endParaRPr lang="en-US"/>
+          </a:p>
+        </p:txBody>
       </p:sp>
       <p:sp>
         <p:nvSpPr>
@@ -6716,6 +6761,13 @@
           </a:solidFill>
           <a:ln/>
         </p:spPr>
+        <p:txBody>
+          <a:bodyPr/>
+          <a:lstStyle/>
+          <a:p>
+            <a:endParaRPr lang="en-US"/>
+          </a:p>
+        </p:txBody>
       </p:sp>
       <p:sp>
         <p:nvSpPr>
@@ -6738,6 +6790,13 @@
           </a:solidFill>
           <a:ln/>
         </p:spPr>
+        <p:txBody>
+          <a:bodyPr/>
+          <a:lstStyle/>
+          <a:p>
+            <a:endParaRPr lang="en-US"/>
+          </a:p>
+        </p:txBody>
       </p:sp>
       <p:sp>
         <p:nvSpPr>
@@ -6760,6 +6819,13 @@
           </a:solidFill>
           <a:ln/>
         </p:spPr>
+        <p:txBody>
+          <a:bodyPr/>
+          <a:lstStyle/>
+          <a:p>
+            <a:endParaRPr lang="en-US"/>
+          </a:p>
+        </p:txBody>
       </p:sp>
       <p:sp>
         <p:nvSpPr>
@@ -6782,6 +6848,13 @@
           </a:solidFill>
           <a:ln/>
         </p:spPr>
+        <p:txBody>
+          <a:bodyPr/>
+          <a:lstStyle/>
+          <a:p>
+            <a:endParaRPr lang="en-US"/>
+          </a:p>
+        </p:txBody>
       </p:sp>
       <p:sp>
         <p:nvSpPr>
@@ -6804,6 +6877,13 @@
           </a:solidFill>
           <a:ln/>
         </p:spPr>
+        <p:txBody>
+          <a:bodyPr/>
+          <a:lstStyle/>
+          <a:p>
+            <a:endParaRPr lang="en-US"/>
+          </a:p>
+        </p:txBody>
       </p:sp>
       <p:sp>
         <p:nvSpPr>
@@ -6828,7 +6908,7 @@
           </a:bodyPr>
           <a:lstStyle/>
           <a:p>
-            <a:pPr algn="l" indent="0" marL="0">
+            <a:pPr marL="0" indent="0" algn="l">
               <a:lnSpc>
                 <a:spcPts val="1659"/>
               </a:lnSpc>
@@ -6872,7 +6952,7 @@
           </a:bodyPr>
           <a:lstStyle/>
           <a:p>
-            <a:pPr algn="l" indent="0" marL="0">
+            <a:pPr marL="0" indent="0" algn="l">
               <a:lnSpc>
                 <a:spcPts val="1750"/>
               </a:lnSpc>
@@ -6916,7 +6996,7 @@
           </a:bodyPr>
           <a:lstStyle/>
           <a:p>
-            <a:pPr algn="l" indent="0" marL="0">
+            <a:pPr marL="0" indent="0" algn="l">
               <a:lnSpc>
                 <a:spcPts val="1620"/>
               </a:lnSpc>
@@ -6974,6 +7054,13 @@
             <a:prstDash val="solid"/>
           </a:ln>
         </p:spPr>
+        <p:txBody>
+          <a:bodyPr/>
+          <a:lstStyle/>
+          <a:p>
+            <a:endParaRPr lang="en-US"/>
+          </a:p>
+        </p:txBody>
       </p:sp>
       <p:sp>
         <p:nvSpPr>
@@ -6997,11 +7084,11 @@
                 <a:moveTo>
                   <a:pt x="8487" y="76200"/>
                 </a:moveTo>
-                <a:arcTo hR="120650" wR="120650" stAng="12097096" swAng="4102904"/>
+                <a:arcTo wR="120650" hR="120650" stAng="12097096" swAng="4102904"/>
                 <a:lnTo>
                   <a:pt x="1878310" y="0"/>
                 </a:lnTo>
-                <a:arcTo hR="120650" wR="120650" stAng="16200000" swAng="4102904"/>
+                <a:arcTo wR="120650" hR="120650" stAng="16200000" swAng="4102904"/>
                 <a:close/>
               </a:path>
             </a:pathLst>
@@ -7011,6 +7098,13 @@
           </a:solidFill>
           <a:ln/>
         </p:spPr>
+        <p:txBody>
+          <a:bodyPr/>
+          <a:lstStyle/>
+          <a:p>
+            <a:endParaRPr lang="en-US"/>
+          </a:p>
+        </p:txBody>
       </p:sp>
       <p:sp>
         <p:nvSpPr>
@@ -7035,14 +7129,14 @@
           </a:bodyPr>
           <a:lstStyle/>
           <a:p>
-            <a:pPr algn="l" indent="0" marL="0">
+            <a:pPr marL="0" indent="0" algn="l">
               <a:lnSpc>
                 <a:spcPts val="2640"/>
               </a:lnSpc>
               <a:buNone/>
             </a:pPr>
             <a:r>
-              <a:rPr lang="en-US" sz="2200" b="1" spc="-50" kern="0" dirty="0">
+              <a:rPr lang="en-US" sz="2200" b="1" kern="0" spc="-50" dirty="0">
                 <a:solidFill>
                   <a:srgbClr val="804979"/>
                 </a:solidFill>
@@ -7077,6 +7171,13 @@
           </a:solidFill>
           <a:ln/>
         </p:spPr>
+        <p:txBody>
+          <a:bodyPr/>
+          <a:lstStyle/>
+          <a:p>
+            <a:endParaRPr lang="en-US"/>
+          </a:p>
+        </p:txBody>
       </p:sp>
       <p:sp>
         <p:nvSpPr>
@@ -7101,7 +7202,7 @@
           </a:bodyPr>
           <a:lstStyle/>
           <a:p>
-            <a:pPr algn="l" indent="0" marL="0">
+            <a:pPr marL="0" indent="0" algn="l">
               <a:lnSpc>
                 <a:spcPts val="1409"/>
               </a:lnSpc>
@@ -7143,6 +7244,13 @@
           </a:solidFill>
           <a:ln/>
         </p:spPr>
+        <p:txBody>
+          <a:bodyPr/>
+          <a:lstStyle/>
+          <a:p>
+            <a:endParaRPr lang="en-US"/>
+          </a:p>
+        </p:txBody>
       </p:sp>
       <p:sp>
         <p:nvSpPr>
@@ -7167,7 +7275,7 @@
           </a:bodyPr>
           <a:lstStyle/>
           <a:p>
-            <a:pPr algn="l" indent="0" marL="0">
+            <a:pPr marL="0" indent="0" algn="l">
               <a:lnSpc>
                 <a:spcPts val="1680"/>
               </a:lnSpc>
@@ -7212,6 +7320,13 @@
             <a:prstDash val="solid"/>
           </a:ln>
         </p:spPr>
+        <p:txBody>
+          <a:bodyPr/>
+          <a:lstStyle/>
+          <a:p>
+            <a:endParaRPr lang="en-US"/>
+          </a:p>
+        </p:txBody>
       </p:sp>
       <p:sp>
         <p:nvSpPr>
@@ -7236,7 +7351,7 @@
           </a:bodyPr>
           <a:lstStyle/>
           <a:p>
-            <a:pPr algn="l" indent="0" marL="0">
+            <a:pPr marL="0" indent="0" algn="l">
               <a:lnSpc>
                 <a:spcPts val="1680"/>
               </a:lnSpc>
@@ -7280,7 +7395,7 @@
           </a:bodyPr>
           <a:lstStyle/>
           <a:p>
-            <a:pPr algn="l" indent="0" marL="0">
+            <a:pPr marL="0" indent="0" algn="l">
               <a:lnSpc>
                 <a:spcPts val="1516"/>
               </a:lnSpc>
@@ -7324,7 +7439,7 @@
           </a:bodyPr>
           <a:lstStyle/>
           <a:p>
-            <a:pPr algn="l" indent="0" marL="0">
+            <a:pPr marL="0" indent="0" algn="l">
               <a:lnSpc>
                 <a:spcPts val="1750"/>
               </a:lnSpc>
@@ -7368,7 +7483,7 @@
           </a:bodyPr>
           <a:lstStyle/>
           <a:p>
-            <a:pPr algn="l" indent="0" marL="0">
+            <a:pPr marL="0" indent="0" algn="l">
               <a:lnSpc>
                 <a:spcPts val="1620"/>
               </a:lnSpc>
@@ -7426,6 +7541,13 @@
             <a:prstDash val="solid"/>
           </a:ln>
         </p:spPr>
+        <p:txBody>
+          <a:bodyPr/>
+          <a:lstStyle/>
+          <a:p>
+            <a:endParaRPr lang="en-US"/>
+          </a:p>
+        </p:txBody>
       </p:sp>
       <p:sp>
         <p:nvSpPr>
@@ -7449,11 +7571,11 @@
                 <a:moveTo>
                   <a:pt x="8487" y="76200"/>
                 </a:moveTo>
-                <a:arcTo hR="120650" wR="120650" stAng="12097096" swAng="4102904"/>
+                <a:arcTo wR="120650" hR="120650" stAng="12097096" swAng="4102904"/>
                 <a:lnTo>
                   <a:pt x="1878360" y="0"/>
                 </a:lnTo>
-                <a:arcTo hR="120650" wR="120650" stAng="16200000" swAng="4102904"/>
+                <a:arcTo wR="120650" hR="120650" stAng="16200000" swAng="4102904"/>
                 <a:close/>
               </a:path>
             </a:pathLst>
@@ -7463,6 +7585,13 @@
           </a:solidFill>
           <a:ln/>
         </p:spPr>
+        <p:txBody>
+          <a:bodyPr/>
+          <a:lstStyle/>
+          <a:p>
+            <a:endParaRPr lang="en-US"/>
+          </a:p>
+        </p:txBody>
       </p:sp>
       <p:sp>
         <p:nvSpPr>
@@ -7487,14 +7616,14 @@
           </a:bodyPr>
           <a:lstStyle/>
           <a:p>
-            <a:pPr algn="l" indent="0" marL="0">
+            <a:pPr marL="0" indent="0" algn="l">
               <a:lnSpc>
                 <a:spcPts val="2640"/>
               </a:lnSpc>
               <a:buNone/>
             </a:pPr>
             <a:r>
-              <a:rPr lang="en-US" sz="2200" b="1" spc="-50" kern="0" dirty="0">
+              <a:rPr lang="en-US" sz="2200" b="1" kern="0" spc="-50" dirty="0">
                 <a:solidFill>
                   <a:srgbClr val="6250A6"/>
                 </a:solidFill>
@@ -7529,6 +7658,13 @@
           </a:solidFill>
           <a:ln/>
         </p:spPr>
+        <p:txBody>
+          <a:bodyPr/>
+          <a:lstStyle/>
+          <a:p>
+            <a:endParaRPr lang="en-US"/>
+          </a:p>
+        </p:txBody>
       </p:sp>
       <p:sp>
         <p:nvSpPr>
@@ -7553,7 +7689,7 @@
           </a:bodyPr>
           <a:lstStyle/>
           <a:p>
-            <a:pPr algn="l" indent="0" marL="0">
+            <a:pPr marL="0" indent="0" algn="l">
               <a:lnSpc>
                 <a:spcPts val="1680"/>
               </a:lnSpc>
@@ -7601,7 +7737,7 @@
           </a:bodyPr>
           <a:lstStyle/>
           <a:p>
-            <a:pPr algn="l" indent="0" marL="0">
+            <a:pPr marL="0" indent="0" algn="l">
               <a:lnSpc>
                 <a:spcPts val="1560"/>
               </a:lnSpc>
@@ -7645,7 +7781,7 @@
           </a:bodyPr>
           <a:lstStyle/>
           <a:p>
-            <a:pPr algn="l" indent="0" marL="0">
+            <a:pPr marL="0" indent="0" algn="l">
               <a:lnSpc>
                 <a:spcPts val="1750"/>
               </a:lnSpc>
@@ -7689,7 +7825,7 @@
           </a:bodyPr>
           <a:lstStyle/>
           <a:p>
-            <a:pPr algn="l" indent="0" marL="0">
+            <a:pPr marL="0" indent="0" algn="l">
               <a:lnSpc>
                 <a:spcPts val="1620"/>
               </a:lnSpc>
@@ -7747,6 +7883,13 @@
             <a:prstDash val="solid"/>
           </a:ln>
         </p:spPr>
+        <p:txBody>
+          <a:bodyPr/>
+          <a:lstStyle/>
+          <a:p>
+            <a:endParaRPr lang="en-US"/>
+          </a:p>
+        </p:txBody>
       </p:sp>
       <p:sp>
         <p:nvSpPr>
@@ -7770,11 +7913,11 @@
                 <a:moveTo>
                   <a:pt x="8487" y="76200"/>
                 </a:moveTo>
-                <a:arcTo hR="120650" wR="120650" stAng="12097096" swAng="4102904"/>
+                <a:arcTo wR="120650" hR="120650" stAng="12097096" swAng="4102904"/>
                 <a:lnTo>
                   <a:pt x="1878310" y="0"/>
                 </a:lnTo>
-                <a:arcTo hR="120650" wR="120650" stAng="16200000" swAng="4102904"/>
+                <a:arcTo wR="120650" hR="120650" stAng="16200000" swAng="4102904"/>
                 <a:close/>
               </a:path>
             </a:pathLst>
@@ -7784,6 +7927,13 @@
           </a:solidFill>
           <a:ln/>
         </p:spPr>
+        <p:txBody>
+          <a:bodyPr/>
+          <a:lstStyle/>
+          <a:p>
+            <a:endParaRPr lang="en-US"/>
+          </a:p>
+        </p:txBody>
       </p:sp>
       <p:sp>
         <p:nvSpPr>
@@ -7808,14 +7958,14 @@
           </a:bodyPr>
           <a:lstStyle/>
           <a:p>
-            <a:pPr algn="l" indent="0" marL="0">
+            <a:pPr marL="0" indent="0" algn="l">
               <a:lnSpc>
                 <a:spcPts val="2640"/>
               </a:lnSpc>
               <a:buNone/>
             </a:pPr>
             <a:r>
-              <a:rPr lang="en-US" sz="2200" b="1" spc="-50" kern="0" dirty="0">
+              <a:rPr lang="en-US" sz="2200" b="1" kern="0" spc="-50" dirty="0">
                 <a:solidFill>
                   <a:srgbClr val="4558D2"/>
                 </a:solidFill>
@@ -7850,6 +8000,13 @@
           </a:solidFill>
           <a:ln/>
         </p:spPr>
+        <p:txBody>
+          <a:bodyPr/>
+          <a:lstStyle/>
+          <a:p>
+            <a:endParaRPr lang="en-US"/>
+          </a:p>
+        </p:txBody>
       </p:sp>
       <p:sp>
         <p:nvSpPr>
@@ -7872,6 +8029,13 @@
           </a:solidFill>
           <a:ln/>
         </p:spPr>
+        <p:txBody>
+          <a:bodyPr/>
+          <a:lstStyle/>
+          <a:p>
+            <a:endParaRPr lang="en-US"/>
+          </a:p>
+        </p:txBody>
       </p:sp>
       <p:sp>
         <p:nvSpPr>
@@ -7894,6 +8058,13 @@
           </a:solidFill>
           <a:ln/>
         </p:spPr>
+        <p:txBody>
+          <a:bodyPr/>
+          <a:lstStyle/>
+          <a:p>
+            <a:endParaRPr lang="en-US"/>
+          </a:p>
+        </p:txBody>
       </p:sp>
       <p:sp>
         <p:nvSpPr>
@@ -7916,6 +8087,13 @@
           </a:solidFill>
           <a:ln/>
         </p:spPr>
+        <p:txBody>
+          <a:bodyPr/>
+          <a:lstStyle/>
+          <a:p>
+            <a:endParaRPr lang="en-US"/>
+          </a:p>
+        </p:txBody>
       </p:sp>
       <p:sp>
         <p:nvSpPr>
@@ -7938,6 +8116,13 @@
           </a:solidFill>
           <a:ln/>
         </p:spPr>
+        <p:txBody>
+          <a:bodyPr/>
+          <a:lstStyle/>
+          <a:p>
+            <a:endParaRPr lang="en-US"/>
+          </a:p>
+        </p:txBody>
       </p:sp>
       <p:sp>
         <p:nvSpPr>
@@ -7960,6 +8145,13 @@
           </a:solidFill>
           <a:ln/>
         </p:spPr>
+        <p:txBody>
+          <a:bodyPr/>
+          <a:lstStyle/>
+          <a:p>
+            <a:endParaRPr lang="en-US"/>
+          </a:p>
+        </p:txBody>
       </p:sp>
       <p:sp>
         <p:nvSpPr>
@@ -7984,7 +8176,7 @@
           </a:bodyPr>
           <a:lstStyle/>
           <a:p>
-            <a:pPr algn="l" indent="0" marL="0">
+            <a:pPr marL="0" indent="0" algn="l">
               <a:lnSpc>
                 <a:spcPts val="1560"/>
               </a:lnSpc>
@@ -8028,7 +8220,7 @@
           </a:bodyPr>
           <a:lstStyle/>
           <a:p>
-            <a:pPr algn="l" indent="0" marL="0">
+            <a:pPr marL="0" indent="0" algn="l">
               <a:lnSpc>
                 <a:spcPts val="1750"/>
               </a:lnSpc>
@@ -8072,7 +8264,7 @@
           </a:bodyPr>
           <a:lstStyle/>
           <a:p>
-            <a:pPr algn="l" indent="0" marL="0">
+            <a:pPr marL="0" indent="0" algn="l">
               <a:lnSpc>
                 <a:spcPts val="1620"/>
               </a:lnSpc>
@@ -8127,7 +8319,7 @@
           </a:bodyPr>
           <a:lstStyle/>
           <a:p>
-            <a:pPr algn="l" indent="0" marL="0">
+            <a:pPr marL="0" indent="0" algn="l">
               <a:lnSpc>
                 <a:spcPts val="1680"/>
               </a:lnSpc>
@@ -8171,7 +8363,7 @@
           </a:bodyPr>
           <a:lstStyle/>
           <a:p>
-            <a:pPr algn="r" indent="0" marL="0">
+            <a:pPr marL="0" indent="0" algn="r">
               <a:lnSpc>
                 <a:spcPts val="1680"/>
               </a:lnSpc>
@@ -8208,6 +8400,7 @@
         <a:solidFill>
           <a:srgbClr val="A8331D"/>
         </a:solidFill>
+        <a:effectLst/>
       </p:bgPr>
     </p:bg>
     <p:spTree>
@@ -8257,6 +8450,13 @@
           </a:gradFill>
           <a:ln/>
         </p:spPr>
+        <p:txBody>
+          <a:bodyPr/>
+          <a:lstStyle/>
+          <a:p>
+            <a:endParaRPr lang="en-US"/>
+          </a:p>
+        </p:txBody>
       </p:sp>
       <p:sp>
         <p:nvSpPr>
@@ -8281,14 +8481,14 @@
           </a:bodyPr>
           <a:lstStyle/>
           <a:p>
-            <a:pPr algn="l" indent="0" marL="0">
+            <a:pPr marL="0" indent="0" algn="l">
               <a:lnSpc>
                 <a:spcPts val="1820"/>
               </a:lnSpc>
               <a:buNone/>
             </a:pPr>
             <a:r>
-              <a:rPr lang="en-US" sz="1300" b="1" spc="150" kern="0" dirty="0">
+              <a:rPr lang="en-US" sz="1300" b="1" kern="0" spc="150" dirty="0">
                 <a:solidFill>
                   <a:srgbClr val="879BF4"/>
                 </a:solidFill>
@@ -8305,7 +8505,9 @@
       <p:sp>
         <p:nvSpPr>
           <p:cNvPr id="4" name="Text 2"/>
-          <p:cNvSpPr/>
+          <p:cNvSpPr>
+            <a:spLocks noGrp="1"/>
+          </p:cNvSpPr>
           <p:nvPr>
             <p:ph type="title"/>
           </p:nvPr>
@@ -8327,14 +8529,14 @@
           </a:bodyPr>
           <a:lstStyle/>
           <a:p>
-            <a:pPr algn="l" indent="0" marL="0">
+            <a:pPr marL="0" indent="0" algn="l">
               <a:lnSpc>
                 <a:spcPts val="3815"/>
               </a:lnSpc>
               <a:buNone/>
             </a:pPr>
             <a:r>
-              <a:rPr lang="en-US" sz="3741" b="1" i="0" spc="-150" kern="0" dirty="0">
+              <a:rPr lang="en-US" sz="3741" b="1" i="0" kern="0" spc="-150" dirty="0">
                 <a:solidFill>
                   <a:srgbClr val="FAFAF8"/>
                 </a:solidFill>
@@ -8371,7 +8573,7 @@
           </a:bodyPr>
           <a:lstStyle/>
           <a:p>
-            <a:pPr algn="l" indent="0" marL="0">
+            <a:pPr marL="0" indent="0" algn="l">
               <a:lnSpc>
                 <a:spcPts val="1920"/>
               </a:lnSpc>
@@ -8451,6 +8653,13 @@
             <a:prstDash val="solid"/>
           </a:ln>
         </p:spPr>
+        <p:txBody>
+          <a:bodyPr/>
+          <a:lstStyle/>
+          <a:p>
+            <a:endParaRPr lang="en-US"/>
+          </a:p>
+        </p:txBody>
       </p:sp>
       <p:sp>
         <p:nvSpPr>
@@ -8475,14 +8684,14 @@
           </a:bodyPr>
           <a:lstStyle/>
           <a:p>
-            <a:pPr algn="l" indent="0" marL="0">
+            <a:pPr marL="0" indent="0" algn="l">
               <a:lnSpc>
                 <a:spcPts val="1675"/>
               </a:lnSpc>
               <a:buNone/>
             </a:pPr>
             <a:r>
-              <a:rPr lang="en-US" sz="1196" b="1" spc="100" kern="0" dirty="0">
+              <a:rPr lang="en-US" sz="1196" b="1" kern="0" spc="100" dirty="0">
                 <a:solidFill>
                   <a:srgbClr val="A82813"/>
                 </a:solidFill>
@@ -8519,14 +8728,14 @@
           </a:bodyPr>
           <a:lstStyle/>
           <a:p>
-            <a:pPr algn="l" indent="0" marL="0">
+            <a:pPr marL="0" indent="0" algn="l">
               <a:lnSpc>
                 <a:spcPts val="2119"/>
               </a:lnSpc>
               <a:buNone/>
             </a:pPr>
             <a:r>
-              <a:rPr lang="en-US" sz="1766" b="1" spc="-50" kern="0" dirty="0">
+              <a:rPr lang="en-US" sz="1766" b="1" kern="0" spc="-50" dirty="0">
                 <a:solidFill>
                   <a:srgbClr val="0B0B12"/>
                 </a:solidFill>
@@ -8563,7 +8772,7 @@
           </a:bodyPr>
           <a:lstStyle/>
           <a:p>
-            <a:pPr algn="l" indent="0" marL="0">
+            <a:pPr marL="0" indent="0" algn="l">
               <a:lnSpc>
                 <a:spcPts val="1674"/>
               </a:lnSpc>
@@ -8610,6 +8819,13 @@
             <a:prstDash val="solid"/>
           </a:ln>
         </p:spPr>
+        <p:txBody>
+          <a:bodyPr/>
+          <a:lstStyle/>
+          <a:p>
+            <a:endParaRPr lang="en-US"/>
+          </a:p>
+        </p:txBody>
       </p:sp>
       <p:sp>
         <p:nvSpPr>
@@ -8634,14 +8850,14 @@
           </a:bodyPr>
           <a:lstStyle/>
           <a:p>
-            <a:pPr algn="l" indent="0" marL="0">
+            <a:pPr marL="0" indent="0" algn="l">
               <a:lnSpc>
                 <a:spcPts val="1675"/>
               </a:lnSpc>
               <a:buNone/>
             </a:pPr>
             <a:r>
-              <a:rPr lang="en-US" sz="1196" b="1" spc="100" kern="0" dirty="0">
+              <a:rPr lang="en-US" sz="1196" b="1" kern="0" spc="100" dirty="0">
                 <a:solidFill>
                   <a:srgbClr val="2E3A9E"/>
                 </a:solidFill>
@@ -8678,14 +8894,14 @@
           </a:bodyPr>
           <a:lstStyle/>
           <a:p>
-            <a:pPr algn="l" indent="0" marL="0">
+            <a:pPr marL="0" indent="0" algn="l">
               <a:lnSpc>
                 <a:spcPts val="2119"/>
               </a:lnSpc>
               <a:buNone/>
             </a:pPr>
             <a:r>
-              <a:rPr lang="en-US" sz="1766" b="1" spc="-50" kern="0" dirty="0">
+              <a:rPr lang="en-US" sz="1766" b="1" kern="0" spc="-50" dirty="0">
                 <a:solidFill>
                   <a:srgbClr val="0B0B12"/>
                 </a:solidFill>
@@ -8722,7 +8938,7 @@
           </a:bodyPr>
           <a:lstStyle/>
           <a:p>
-            <a:pPr algn="l" indent="0" marL="0">
+            <a:pPr marL="0" indent="0" algn="l">
               <a:lnSpc>
                 <a:spcPts val="1674"/>
               </a:lnSpc>
@@ -8764,6 +8980,13 @@
           </a:solidFill>
           <a:ln/>
         </p:spPr>
+        <p:txBody>
+          <a:bodyPr/>
+          <a:lstStyle/>
+          <a:p>
+            <a:endParaRPr lang="en-US"/>
+          </a:p>
+        </p:txBody>
       </p:sp>
       <p:sp>
         <p:nvSpPr>
@@ -8790,19 +9013,19 @@
                 <a:lnTo>
                   <a:pt x="101600" y="1666677"/>
                 </a:lnTo>
-                <a:arcTo hR="101600" wR="101600" stAng="5400000" swAng="5400000"/>
+                <a:arcTo wR="101600" hR="101600" stAng="5400000" swAng="5400000"/>
                 <a:lnTo>
                   <a:pt x="0" y="101600"/>
                 </a:lnTo>
-                <a:arcTo hR="101600" wR="101600" stAng="10800000" swAng="5400000"/>
+                <a:arcTo wR="101600" hR="101600" stAng="10800000" swAng="5400000"/>
                 <a:lnTo>
                   <a:pt x="101600" y="0"/>
                 </a:lnTo>
-                <a:arcTo hR="101600" wR="38100" stAng="16200000" swAng="-5400000"/>
+                <a:arcTo wR="38100" hR="101600" stAng="16200000" swAng="-5400000"/>
                 <a:lnTo>
                   <a:pt x="63500" y="1565077"/>
                 </a:lnTo>
-                <a:arcTo hR="101600" wR="38100" stAng="10800000" swAng="-5400000"/>
+                <a:arcTo wR="38100" hR="101600" stAng="10800000" swAng="-5400000"/>
                 <a:close/>
               </a:path>
             </a:pathLst>
@@ -8812,6 +9035,13 @@
           </a:solidFill>
           <a:ln/>
         </p:spPr>
+        <p:txBody>
+          <a:bodyPr/>
+          <a:lstStyle/>
+          <a:p>
+            <a:endParaRPr lang="en-US"/>
+          </a:p>
+        </p:txBody>
       </p:sp>
       <p:sp>
         <p:nvSpPr>
@@ -8836,14 +9066,14 @@
           </a:bodyPr>
           <a:lstStyle/>
           <a:p>
-            <a:pPr algn="l" indent="0" marL="0">
+            <a:pPr marL="0" indent="0" algn="l">
               <a:lnSpc>
                 <a:spcPts val="2321"/>
               </a:lnSpc>
               <a:buNone/>
             </a:pPr>
             <a:r>
-              <a:rPr lang="en-US" sz="1658" b="1" spc="-50" kern="0" dirty="0">
+              <a:rPr lang="en-US" sz="1658" b="1" kern="0" spc="-50" dirty="0">
                 <a:solidFill>
                   <a:srgbClr val="0B0B12"/>
                 </a:solidFill>
@@ -8880,7 +9110,7 @@
           </a:bodyPr>
           <a:lstStyle/>
           <a:p>
-            <a:pPr algn="l" indent="0" marL="0">
+            <a:pPr marL="0" indent="0" algn="l">
               <a:lnSpc>
                 <a:spcPts val="1658"/>
               </a:lnSpc>
@@ -8922,6 +9152,13 @@
           </a:solidFill>
           <a:ln/>
         </p:spPr>
+        <p:txBody>
+          <a:bodyPr/>
+          <a:lstStyle/>
+          <a:p>
+            <a:endParaRPr lang="en-US"/>
+          </a:p>
+        </p:txBody>
       </p:sp>
       <p:sp>
         <p:nvSpPr>
@@ -8946,7 +9183,7 @@
           </a:bodyPr>
           <a:lstStyle/>
           <a:p>
-            <a:pPr algn="l" indent="0" marL="0">
+            <a:pPr marL="0" indent="0" algn="l">
               <a:lnSpc>
                 <a:spcPts val="1500"/>
               </a:lnSpc>
@@ -8994,7 +9231,7 @@
           </a:bodyPr>
           <a:lstStyle/>
           <a:p>
-            <a:pPr algn="l" indent="0" marL="0">
+            <a:pPr marL="0" indent="0" algn="l">
               <a:lnSpc>
                 <a:spcPts val="1500"/>
               </a:lnSpc>
@@ -9042,7 +9279,7 @@
           </a:bodyPr>
           <a:lstStyle/>
           <a:p>
-            <a:pPr algn="l" indent="0" marL="0">
+            <a:pPr marL="0" indent="0" algn="l">
               <a:lnSpc>
                 <a:spcPts val="1500"/>
               </a:lnSpc>
@@ -9090,7 +9327,7 @@
           </a:bodyPr>
           <a:lstStyle/>
           <a:p>
-            <a:pPr algn="l" indent="0" marL="0">
+            <a:pPr marL="0" indent="0" algn="l">
               <a:lnSpc>
                 <a:spcPts val="1500"/>
               </a:lnSpc>
@@ -9139,6 +9376,13 @@
             <a:prstDash val="solid"/>
           </a:ln>
         </p:spPr>
+        <p:txBody>
+          <a:bodyPr/>
+          <a:lstStyle/>
+          <a:p>
+            <a:endParaRPr lang="en-US"/>
+          </a:p>
+        </p:txBody>
       </p:sp>
       <p:sp>
         <p:nvSpPr>
@@ -9163,14 +9407,14 @@
           </a:bodyPr>
           <a:lstStyle/>
           <a:p>
-            <a:pPr algn="l" indent="0" marL="0">
+            <a:pPr marL="0" indent="0" algn="l">
               <a:lnSpc>
                 <a:spcPts val="1675"/>
               </a:lnSpc>
               <a:buNone/>
             </a:pPr>
             <a:r>
-              <a:rPr lang="en-US" sz="1196" b="1" spc="100" kern="0" dirty="0">
+              <a:rPr lang="en-US" sz="1196" b="1" kern="0" spc="100" dirty="0">
                 <a:solidFill>
                   <a:srgbClr val="B9B7C2"/>
                 </a:solidFill>
@@ -9209,19 +9453,19 @@
                 <a:lnTo>
                   <a:pt x="791666" y="0"/>
                 </a:lnTo>
-                <a:arcTo hR="138410" wR="138410" stAng="16200000" swAng="5400000"/>
+                <a:arcTo wR="138410" hR="138410" stAng="16200000" swAng="5400000"/>
                 <a:lnTo>
                   <a:pt x="930077" y="138410"/>
                 </a:lnTo>
-                <a:arcTo hR="138410" wR="138410" stAng="0" swAng="5400000"/>
+                <a:arcTo wR="138410" hR="138410" stAng="0" swAng="5400000"/>
                 <a:lnTo>
                   <a:pt x="138410" y="276820"/>
                 </a:lnTo>
-                <a:arcTo hR="138410" wR="138410" stAng="5400000" swAng="5400000"/>
+                <a:arcTo wR="138410" hR="138410" stAng="5400000" swAng="5400000"/>
                 <a:lnTo>
                   <a:pt x="0" y="138410"/>
                 </a:lnTo>
-                <a:arcTo hR="138410" wR="138410" stAng="10800000" swAng="5400000"/>
+                <a:arcTo wR="138410" hR="138410" stAng="10800000" swAng="5400000"/>
                 <a:close/>
               </a:path>
             </a:pathLst>
@@ -9240,7 +9484,7 @@
           </a:bodyPr>
           <a:lstStyle/>
           <a:p>
-            <a:pPr algn="ctr" indent="0" marL="0">
+            <a:pPr marL="0" indent="0" algn="ctr">
               <a:lnSpc>
                 <a:spcPts val="1680"/>
               </a:lnSpc>
@@ -9286,19 +9530,19 @@
                 <a:lnTo>
                   <a:pt x="872927" y="0"/>
                 </a:lnTo>
-                <a:arcTo hR="138410" wR="138410" stAng="16200000" swAng="5400000"/>
+                <a:arcTo wR="138410" hR="138410" stAng="16200000" swAng="5400000"/>
                 <a:lnTo>
                   <a:pt x="1011337" y="138410"/>
                 </a:lnTo>
-                <a:arcTo hR="138410" wR="138410" stAng="0" swAng="5400000"/>
+                <a:arcTo wR="138410" hR="138410" stAng="0" swAng="5400000"/>
                 <a:lnTo>
                   <a:pt x="138410" y="276820"/>
                 </a:lnTo>
-                <a:arcTo hR="138410" wR="138410" stAng="5400000" swAng="5400000"/>
+                <a:arcTo wR="138410" hR="138410" stAng="5400000" swAng="5400000"/>
                 <a:lnTo>
                   <a:pt x="0" y="138410"/>
                 </a:lnTo>
-                <a:arcTo hR="138410" wR="138410" stAng="10800000" swAng="5400000"/>
+                <a:arcTo wR="138410" hR="138410" stAng="10800000" swAng="5400000"/>
                 <a:close/>
               </a:path>
             </a:pathLst>
@@ -9317,7 +9561,7 @@
           </a:bodyPr>
           <a:lstStyle/>
           <a:p>
-            <a:pPr algn="ctr" indent="0" marL="0">
+            <a:pPr marL="0" indent="0" algn="ctr">
               <a:lnSpc>
                 <a:spcPts val="1680"/>
               </a:lnSpc>
@@ -9363,19 +9607,19 @@
                 <a:lnTo>
                   <a:pt x="1437779" y="0"/>
                 </a:lnTo>
-                <a:arcTo hR="138410" wR="138410" stAng="16200000" swAng="5400000"/>
+                <a:arcTo wR="138410" hR="138410" stAng="16200000" swAng="5400000"/>
                 <a:lnTo>
                   <a:pt x="1576189" y="138410"/>
                 </a:lnTo>
-                <a:arcTo hR="138410" wR="138410" stAng="0" swAng="5400000"/>
+                <a:arcTo wR="138410" hR="138410" stAng="0" swAng="5400000"/>
                 <a:lnTo>
                   <a:pt x="138410" y="276820"/>
                 </a:lnTo>
-                <a:arcTo hR="138410" wR="138410" stAng="5400000" swAng="5400000"/>
+                <a:arcTo wR="138410" hR="138410" stAng="5400000" swAng="5400000"/>
                 <a:lnTo>
                   <a:pt x="0" y="138410"/>
                 </a:lnTo>
-                <a:arcTo hR="138410" wR="138410" stAng="10800000" swAng="5400000"/>
+                <a:arcTo wR="138410" hR="138410" stAng="10800000" swAng="5400000"/>
                 <a:close/>
               </a:path>
             </a:pathLst>
@@ -9394,7 +9638,7 @@
           </a:bodyPr>
           <a:lstStyle/>
           <a:p>
-            <a:pPr algn="ctr" indent="0" marL="0">
+            <a:pPr marL="0" indent="0" algn="ctr">
               <a:lnSpc>
                 <a:spcPts val="1680"/>
               </a:lnSpc>
@@ -9417,90 +9661,13 @@
       </p:sp>
       <p:sp>
         <p:nvSpPr>
-          <p:cNvPr id="28" name="Text 26"/>
-          <p:cNvSpPr/>
-          <p:nvPr/>
-        </p:nvSpPr>
-        <p:spPr>
-          <a:xfrm>
-            <a:off x="4724102" y="5457775"/>
-            <a:ext cx="1325116" cy="276820"/>
-          </a:xfrm>
-          <a:custGeom>
-            <a:avLst/>
-            <a:gdLst/>
-            <a:ahLst/>
-            <a:cxnLst/>
-            <a:rect l="l" t="t" r="r" b="b"/>
-            <a:pathLst>
-              <a:path w="1325116" h="276820">
-                <a:moveTo>
-                  <a:pt x="138410" y="0"/>
-                </a:moveTo>
-                <a:lnTo>
-                  <a:pt x="1186706" y="0"/>
-                </a:lnTo>
-                <a:arcTo hR="138410" wR="138410" stAng="16200000" swAng="5400000"/>
-                <a:lnTo>
-                  <a:pt x="1325116" y="138410"/>
-                </a:lnTo>
-                <a:arcTo hR="138410" wR="138410" stAng="0" swAng="5400000"/>
-                <a:lnTo>
-                  <a:pt x="138410" y="276820"/>
-                </a:lnTo>
-                <a:arcTo hR="138410" wR="138410" stAng="5400000" swAng="5400000"/>
-                <a:lnTo>
-                  <a:pt x="0" y="138410"/>
-                </a:lnTo>
-                <a:arcTo hR="138410" wR="138410" stAng="10800000" swAng="5400000"/>
-                <a:close/>
-              </a:path>
-            </a:pathLst>
-          </a:custGeom>
-          <a:noFill/>
-          <a:ln w="12700">
-            <a:solidFill>
-              <a:srgbClr val="6E6B75"/>
-            </a:solidFill>
-            <a:prstDash val="solid"/>
-          </a:ln>
-        </p:spPr>
-        <p:txBody>
-          <a:bodyPr wrap="none" lIns="0" tIns="0" rIns="0" bIns="0" rtlCol="0" anchor="ctr">
-            <a:normAutofit/>
-          </a:bodyPr>
-          <a:lstStyle/>
-          <a:p>
-            <a:pPr algn="ctr" indent="0" marL="0">
-              <a:lnSpc>
-                <a:spcPts val="1680"/>
-              </a:lnSpc>
-              <a:buNone/>
-            </a:pPr>
-            <a:r>
-              <a:rPr lang="en-US" sz="1200" b="1" dirty="0">
-                <a:solidFill>
-                  <a:srgbClr val="B9B7C2"/>
-                </a:solidFill>
-                <a:latin typeface="Inter" pitchFamily="34" charset="0"/>
-                <a:ea typeface="Inter" pitchFamily="34" charset="-122"/>
-                <a:cs typeface="Inter" pitchFamily="34" charset="-120"/>
-              </a:rPr>
-              <a:t>Konica Minolta</a:t>
-            </a:r>
-            <a:endParaRPr lang="en-US" sz="1200" dirty="0"/>
-          </a:p>
-        </p:txBody>
-      </p:sp>
-      <p:sp>
-        <p:nvSpPr>
           <p:cNvPr id="29" name="Text 27"/>
           <p:cNvSpPr/>
           <p:nvPr/>
         </p:nvSpPr>
         <p:spPr>
           <a:xfrm>
-            <a:off x="6125418" y="5457775"/>
+            <a:off x="4724101" y="5469181"/>
             <a:ext cx="1023045" cy="276820"/>
           </a:xfrm>
           <a:custGeom>
@@ -9517,19 +9684,19 @@
                 <a:lnTo>
                   <a:pt x="884634" y="0"/>
                 </a:lnTo>
-                <a:arcTo hR="138410" wR="138410" stAng="16200000" swAng="5400000"/>
+                <a:arcTo wR="138410" hR="138410" stAng="16200000" swAng="5400000"/>
                 <a:lnTo>
                   <a:pt x="1023045" y="138410"/>
                 </a:lnTo>
-                <a:arcTo hR="138410" wR="138410" stAng="0" swAng="5400000"/>
+                <a:arcTo wR="138410" hR="138410" stAng="0" swAng="5400000"/>
                 <a:lnTo>
                   <a:pt x="138410" y="276820"/>
                 </a:lnTo>
-                <a:arcTo hR="138410" wR="138410" stAng="5400000" swAng="5400000"/>
+                <a:arcTo wR="138410" hR="138410" stAng="5400000" swAng="5400000"/>
                 <a:lnTo>
                   <a:pt x="0" y="138410"/>
                 </a:lnTo>
-                <a:arcTo hR="138410" wR="138410" stAng="10800000" swAng="5400000"/>
+                <a:arcTo wR="138410" hR="138410" stAng="10800000" swAng="5400000"/>
                 <a:close/>
               </a:path>
             </a:pathLst>
@@ -9548,7 +9715,7 @@
           </a:bodyPr>
           <a:lstStyle/>
           <a:p>
-            <a:pPr algn="ctr" indent="0" marL="0">
+            <a:pPr marL="0" indent="0" algn="ctr">
               <a:lnSpc>
                 <a:spcPts val="1680"/>
               </a:lnSpc>
@@ -9577,7 +9744,7 @@
         </p:nvSpPr>
         <p:spPr>
           <a:xfrm>
-            <a:off x="7224663" y="5457775"/>
+            <a:off x="5823346" y="5469181"/>
             <a:ext cx="775791" cy="276820"/>
           </a:xfrm>
           <a:custGeom>
@@ -9594,19 +9761,19 @@
                 <a:lnTo>
                   <a:pt x="637381" y="0"/>
                 </a:lnTo>
-                <a:arcTo hR="138410" wR="138410" stAng="16200000" swAng="5400000"/>
+                <a:arcTo wR="138410" hR="138410" stAng="16200000" swAng="5400000"/>
                 <a:lnTo>
                   <a:pt x="775791" y="138410"/>
                 </a:lnTo>
-                <a:arcTo hR="138410" wR="138410" stAng="0" swAng="5400000"/>
+                <a:arcTo wR="138410" hR="138410" stAng="0" swAng="5400000"/>
                 <a:lnTo>
                   <a:pt x="138410" y="276820"/>
                 </a:lnTo>
-                <a:arcTo hR="138410" wR="138410" stAng="5400000" swAng="5400000"/>
+                <a:arcTo wR="138410" hR="138410" stAng="5400000" swAng="5400000"/>
                 <a:lnTo>
                   <a:pt x="0" y="138410"/>
                 </a:lnTo>
-                <a:arcTo hR="138410" wR="138410" stAng="10800000" swAng="5400000"/>
+                <a:arcTo wR="138410" hR="138410" stAng="10800000" swAng="5400000"/>
                 <a:close/>
               </a:path>
             </a:pathLst>
@@ -9625,7 +9792,7 @@
           </a:bodyPr>
           <a:lstStyle/>
           <a:p>
-            <a:pPr algn="ctr" indent="0" marL="0">
+            <a:pPr marL="0" indent="0" algn="ctr">
               <a:lnSpc>
                 <a:spcPts val="1680"/>
               </a:lnSpc>
@@ -9654,7 +9821,7 @@
         </p:nvSpPr>
         <p:spPr>
           <a:xfrm>
-            <a:off x="8076654" y="5457775"/>
+            <a:off x="6675337" y="5469181"/>
             <a:ext cx="505371" cy="276820"/>
           </a:xfrm>
           <a:custGeom>
@@ -9671,19 +9838,19 @@
                 <a:lnTo>
                   <a:pt x="366961" y="0"/>
                 </a:lnTo>
-                <a:arcTo hR="138410" wR="138410" stAng="16200000" swAng="5400000"/>
+                <a:arcTo wR="138410" hR="138410" stAng="16200000" swAng="5400000"/>
                 <a:lnTo>
                   <a:pt x="505371" y="138410"/>
                 </a:lnTo>
-                <a:arcTo hR="138410" wR="138410" stAng="0" swAng="5400000"/>
+                <a:arcTo wR="138410" hR="138410" stAng="0" swAng="5400000"/>
                 <a:lnTo>
                   <a:pt x="138410" y="276820"/>
                 </a:lnTo>
-                <a:arcTo hR="138410" wR="138410" stAng="5400000" swAng="5400000"/>
+                <a:arcTo wR="138410" hR="138410" stAng="5400000" swAng="5400000"/>
                 <a:lnTo>
                   <a:pt x="0" y="138410"/>
                 </a:lnTo>
-                <a:arcTo hR="138410" wR="138410" stAng="10800000" swAng="5400000"/>
+                <a:arcTo wR="138410" hR="138410" stAng="10800000" swAng="5400000"/>
                 <a:close/>
               </a:path>
             </a:pathLst>
@@ -9702,7 +9869,7 @@
           </a:bodyPr>
           <a:lstStyle/>
           <a:p>
-            <a:pPr algn="ctr" indent="0" marL="0">
+            <a:pPr marL="0" indent="0" algn="ctr">
               <a:lnSpc>
                 <a:spcPts val="1680"/>
               </a:lnSpc>
@@ -9731,7 +9898,7 @@
         </p:nvSpPr>
         <p:spPr>
           <a:xfrm>
-            <a:off x="8658225" y="5457775"/>
+            <a:off x="7256908" y="5469181"/>
             <a:ext cx="905570" cy="276820"/>
           </a:xfrm>
           <a:custGeom>
@@ -9748,19 +9915,19 @@
                 <a:lnTo>
                   <a:pt x="767159" y="0"/>
                 </a:lnTo>
-                <a:arcTo hR="138410" wR="138410" stAng="16200000" swAng="5400000"/>
+                <a:arcTo wR="138410" hR="138410" stAng="16200000" swAng="5400000"/>
                 <a:lnTo>
                   <a:pt x="905570" y="138410"/>
                 </a:lnTo>
-                <a:arcTo hR="138410" wR="138410" stAng="0" swAng="5400000"/>
+                <a:arcTo wR="138410" hR="138410" stAng="0" swAng="5400000"/>
                 <a:lnTo>
                   <a:pt x="138410" y="276820"/>
                 </a:lnTo>
-                <a:arcTo hR="138410" wR="138410" stAng="5400000" swAng="5400000"/>
+                <a:arcTo wR="138410" hR="138410" stAng="5400000" swAng="5400000"/>
                 <a:lnTo>
                   <a:pt x="0" y="138410"/>
                 </a:lnTo>
-                <a:arcTo hR="138410" wR="138410" stAng="10800000" swAng="5400000"/>
+                <a:arcTo wR="138410" hR="138410" stAng="10800000" swAng="5400000"/>
                 <a:close/>
               </a:path>
             </a:pathLst>
@@ -9779,7 +9946,7 @@
           </a:bodyPr>
           <a:lstStyle/>
           <a:p>
-            <a:pPr algn="ctr" indent="0" marL="0">
+            <a:pPr marL="0" indent="0" algn="ctr">
               <a:lnSpc>
                 <a:spcPts val="1680"/>
               </a:lnSpc>
@@ -9823,7 +9990,7 @@
           </a:bodyPr>
           <a:lstStyle/>
           <a:p>
-            <a:pPr algn="l" indent="0" marL="0">
+            <a:pPr marL="0" indent="0" algn="l">
               <a:lnSpc>
                 <a:spcPts val="1680"/>
               </a:lnSpc>
@@ -9867,7 +10034,7 @@
           </a:bodyPr>
           <a:lstStyle/>
           <a:p>
-            <a:pPr algn="r" indent="0" marL="0">
+            <a:pPr marL="0" indent="0" algn="r">
               <a:lnSpc>
                 <a:spcPts val="1680"/>
               </a:lnSpc>
@@ -10184,4 +10351,319 @@
   <a:objectDefaults/>
   <a:extraClrSchemeLst/>
 </a:theme>
+</file>
+
+<file path=ppt/theme/theme2.xml><?xml version="1.0" encoding="utf-8"?>
+<a:theme xmlns:a="http://schemas.openxmlformats.org/drawingml/2006/main" name="Office Theme">
+  <a:themeElements>
+    <a:clrScheme name="Office">
+      <a:dk1>
+        <a:sysClr val="windowText" lastClr="000000"/>
+      </a:dk1>
+      <a:lt1>
+        <a:sysClr val="window" lastClr="FFFFFF"/>
+      </a:lt1>
+      <a:dk2>
+        <a:srgbClr val="0E2841"/>
+      </a:dk2>
+      <a:lt2>
+        <a:srgbClr val="E8E8E8"/>
+      </a:lt2>
+      <a:accent1>
+        <a:srgbClr val="156082"/>
+      </a:accent1>
+      <a:accent2>
+        <a:srgbClr val="E97132"/>
+      </a:accent2>
+      <a:accent3>
+        <a:srgbClr val="196B24"/>
+      </a:accent3>
+      <a:accent4>
+        <a:srgbClr val="0F9ED5"/>
+      </a:accent4>
+      <a:accent5>
+        <a:srgbClr val="A02B93"/>
+      </a:accent5>
+      <a:accent6>
+        <a:srgbClr val="4EA72E"/>
+      </a:accent6>
+      <a:hlink>
+        <a:srgbClr val="467886"/>
+      </a:hlink>
+      <a:folHlink>
+        <a:srgbClr val="96607D"/>
+      </a:folHlink>
+    </a:clrScheme>
+    <a:fontScheme name="Office">
+      <a:majorFont>
+        <a:latin typeface="Aptos Display" panose="02110004020202020204"/>
+        <a:ea typeface=""/>
+        <a:cs typeface=""/>
+        <a:font script="Jpan" typeface="游ゴシック Light"/>
+        <a:font script="Hang" typeface="맑은 고딕"/>
+        <a:font script="Hans" typeface="等线 Light"/>
+        <a:font script="Hant" typeface="新細明體"/>
+        <a:font script="Arab" typeface="Times New Roman"/>
+        <a:font script="Hebr" typeface="Times New Roman"/>
+        <a:font script="Thai" typeface="Angsana New"/>
+        <a:font script="Ethi" typeface="Nyala"/>
+        <a:font script="Beng" typeface="Vrinda"/>
+        <a:font script="Gujr" typeface="Shruti"/>
+        <a:font script="Khmr" typeface="MoolBoran"/>
+        <a:font script="Knda" typeface="Tunga"/>
+        <a:font script="Guru" typeface="Raavi"/>
+        <a:font script="Cans" typeface="Euphemia"/>
+        <a:font script="Cher" typeface="Plantagenet Cherokee"/>
+        <a:font script="Yiii" typeface="Microsoft Yi Baiti"/>
+        <a:font script="Tibt" typeface="Microsoft Himalaya"/>
+        <a:font script="Thaa" typeface="MV Boli"/>
+        <a:font script="Deva" typeface="Mangal"/>
+        <a:font script="Telu" typeface="Gautami"/>
+        <a:font script="Taml" typeface="Latha"/>
+        <a:font script="Syrc" typeface="Estrangelo Edessa"/>
+        <a:font script="Orya" typeface="Kalinga"/>
+        <a:font script="Mlym" typeface="Kartika"/>
+        <a:font script="Laoo" typeface="DokChampa"/>
+        <a:font script="Sinh" typeface="Iskoola Pota"/>
+        <a:font script="Mong" typeface="Mongolian Baiti"/>
+        <a:font script="Viet" typeface="Times New Roman"/>
+        <a:font script="Uigh" typeface="Microsoft Uighur"/>
+        <a:font script="Geor" typeface="Sylfaen"/>
+        <a:font script="Armn" typeface="Arial"/>
+        <a:font script="Bugi" typeface="Leelawadee UI"/>
+        <a:font script="Bopo" typeface="Microsoft JhengHei"/>
+        <a:font script="Java" typeface="Javanese Text"/>
+        <a:font script="Lisu" typeface="Segoe UI"/>
+        <a:font script="Mymr" typeface="Myanmar Text"/>
+        <a:font script="Nkoo" typeface="Ebrima"/>
+        <a:font script="Olck" typeface="Nirmala UI"/>
+        <a:font script="Osma" typeface="Ebrima"/>
+        <a:font script="Phag" typeface="Phagspa"/>
+        <a:font script="Syrn" typeface="Estrangelo Edessa"/>
+        <a:font script="Syrj" typeface="Estrangelo Edessa"/>
+        <a:font script="Syre" typeface="Estrangelo Edessa"/>
+        <a:font script="Sora" typeface="Nirmala UI"/>
+        <a:font script="Tale" typeface="Microsoft Tai Le"/>
+        <a:font script="Talu" typeface="Microsoft New Tai Lue"/>
+        <a:font script="Tfng" typeface="Ebrima"/>
+      </a:majorFont>
+      <a:minorFont>
+        <a:latin typeface="Aptos" panose="02110004020202020204"/>
+        <a:ea typeface=""/>
+        <a:cs typeface=""/>
+        <a:font script="Jpan" typeface="游ゴシック"/>
+        <a:font script="Hang" typeface="맑은 고딕"/>
+        <a:font script="Hans" typeface="等线"/>
+        <a:font script="Hant" typeface="新細明體"/>
+        <a:font script="Arab" typeface="Arial"/>
+        <a:font script="Hebr" typeface="Arial"/>
+        <a:font script="Thai" typeface="Cordia New"/>
+        <a:font script="Ethi" typeface="Nyala"/>
+        <a:font script="Beng" typeface="Vrinda"/>
+        <a:font script="Gujr" typeface="Shruti"/>
+        <a:font script="Khmr" typeface="DaunPenh"/>
+        <a:font script="Knda" typeface="Tunga"/>
+        <a:font script="Guru" typeface="Raavi"/>
+        <a:font script="Cans" typeface="Euphemia"/>
+        <a:font script="Cher" typeface="Plantagenet Cherokee"/>
+        <a:font script="Yiii" typeface="Microsoft Yi Baiti"/>
+        <a:font script="Tibt" typeface="Microsoft Himalaya"/>
+        <a:font script="Thaa" typeface="MV Boli"/>
+        <a:font script="Deva" typeface="Mangal"/>
+        <a:font script="Telu" typeface="Gautami"/>
+        <a:font script="Taml" typeface="Latha"/>
+        <a:font script="Syrc" typeface="Estrangelo Edessa"/>
+        <a:font script="Orya" typeface="Kalinga"/>
+        <a:font script="Mlym" typeface="Kartika"/>
+        <a:font script="Laoo" typeface="DokChampa"/>
+        <a:font script="Sinh" typeface="Iskoola Pota"/>
+        <a:font script="Mong" typeface="Mongolian Baiti"/>
+        <a:font script="Viet" typeface="Arial"/>
+        <a:font script="Uigh" typeface="Microsoft Uighur"/>
+        <a:font script="Geor" typeface="Sylfaen"/>
+        <a:font script="Armn" typeface="Arial"/>
+        <a:font script="Bugi" typeface="Leelawadee UI"/>
+        <a:font script="Bopo" typeface="Microsoft JhengHei"/>
+        <a:font script="Java" typeface="Javanese Text"/>
+        <a:font script="Lisu" typeface="Segoe UI"/>
+        <a:font script="Mymr" typeface="Myanmar Text"/>
+        <a:font script="Nkoo" typeface="Ebrima"/>
+        <a:font script="Olck" typeface="Nirmala UI"/>
+        <a:font script="Osma" typeface="Ebrima"/>
+        <a:font script="Phag" typeface="Phagspa"/>
+        <a:font script="Syrn" typeface="Estrangelo Edessa"/>
+        <a:font script="Syrj" typeface="Estrangelo Edessa"/>
+        <a:font script="Syre" typeface="Estrangelo Edessa"/>
+        <a:font script="Sora" typeface="Nirmala UI"/>
+        <a:font script="Tale" typeface="Microsoft Tai Le"/>
+        <a:font script="Talu" typeface="Microsoft New Tai Lue"/>
+        <a:font script="Tfng" typeface="Ebrima"/>
+      </a:minorFont>
+    </a:fontScheme>
+    <a:fmtScheme name="Office">
+      <a:fillStyleLst>
+        <a:solidFill>
+          <a:schemeClr val="phClr"/>
+        </a:solidFill>
+        <a:gradFill rotWithShape="1">
+          <a:gsLst>
+            <a:gs pos="0">
+              <a:schemeClr val="phClr">
+                <a:lumMod val="110000"/>
+                <a:satMod val="105000"/>
+                <a:tint val="67000"/>
+              </a:schemeClr>
+            </a:gs>
+            <a:gs pos="50000">
+              <a:schemeClr val="phClr">
+                <a:lumMod val="105000"/>
+                <a:satMod val="103000"/>
+                <a:tint val="73000"/>
+              </a:schemeClr>
+            </a:gs>
+            <a:gs pos="100000">
+              <a:schemeClr val="phClr">
+                <a:lumMod val="105000"/>
+                <a:satMod val="109000"/>
+                <a:tint val="81000"/>
+              </a:schemeClr>
+            </a:gs>
+          </a:gsLst>
+          <a:lin ang="5400000" scaled="0"/>
+        </a:gradFill>
+        <a:gradFill rotWithShape="1">
+          <a:gsLst>
+            <a:gs pos="0">
+              <a:schemeClr val="phClr">
+                <a:satMod val="103000"/>
+                <a:lumMod val="102000"/>
+                <a:tint val="94000"/>
+              </a:schemeClr>
+            </a:gs>
+            <a:gs pos="50000">
+              <a:schemeClr val="phClr">
+                <a:satMod val="110000"/>
+                <a:lumMod val="100000"/>
+                <a:shade val="100000"/>
+              </a:schemeClr>
+            </a:gs>
+            <a:gs pos="100000">
+              <a:schemeClr val="phClr">
+                <a:lumMod val="99000"/>
+                <a:satMod val="120000"/>
+                <a:shade val="78000"/>
+              </a:schemeClr>
+            </a:gs>
+          </a:gsLst>
+          <a:lin ang="5400000" scaled="0"/>
+        </a:gradFill>
+      </a:fillStyleLst>
+      <a:lnStyleLst>
+        <a:ln w="12700" cap="flat" cmpd="sng" algn="ctr">
+          <a:solidFill>
+            <a:schemeClr val="phClr"/>
+          </a:solidFill>
+          <a:prstDash val="solid"/>
+          <a:miter lim="800000"/>
+        </a:ln>
+        <a:ln w="19050" cap="flat" cmpd="sng" algn="ctr">
+          <a:solidFill>
+            <a:schemeClr val="phClr"/>
+          </a:solidFill>
+          <a:prstDash val="solid"/>
+          <a:miter lim="800000"/>
+        </a:ln>
+        <a:ln w="25400" cap="flat" cmpd="sng" algn="ctr">
+          <a:solidFill>
+            <a:schemeClr val="phClr"/>
+          </a:solidFill>
+          <a:prstDash val="solid"/>
+          <a:miter lim="800000"/>
+        </a:ln>
+      </a:lnStyleLst>
+      <a:effectStyleLst>
+        <a:effectStyle>
+          <a:effectLst/>
+        </a:effectStyle>
+        <a:effectStyle>
+          <a:effectLst/>
+        </a:effectStyle>
+        <a:effectStyle>
+          <a:effectLst>
+            <a:outerShdw blurRad="57150" dist="19050" dir="5400000" algn="ctr" rotWithShape="0">
+              <a:srgbClr val="000000">
+                <a:alpha val="63000"/>
+              </a:srgbClr>
+            </a:outerShdw>
+          </a:effectLst>
+        </a:effectStyle>
+      </a:effectStyleLst>
+      <a:bgFillStyleLst>
+        <a:solidFill>
+          <a:schemeClr val="phClr"/>
+        </a:solidFill>
+        <a:solidFill>
+          <a:schemeClr val="phClr">
+            <a:tint val="95000"/>
+            <a:satMod val="170000"/>
+          </a:schemeClr>
+        </a:solidFill>
+        <a:gradFill rotWithShape="1">
+          <a:gsLst>
+            <a:gs pos="0">
+              <a:schemeClr val="phClr">
+                <a:tint val="93000"/>
+                <a:satMod val="150000"/>
+                <a:shade val="98000"/>
+                <a:lumMod val="102000"/>
+              </a:schemeClr>
+            </a:gs>
+            <a:gs pos="50000">
+              <a:schemeClr val="phClr">
+                <a:tint val="98000"/>
+                <a:satMod val="130000"/>
+                <a:shade val="90000"/>
+                <a:lumMod val="103000"/>
+              </a:schemeClr>
+            </a:gs>
+            <a:gs pos="100000">
+              <a:schemeClr val="phClr">
+                <a:shade val="63000"/>
+                <a:satMod val="120000"/>
+              </a:schemeClr>
+            </a:gs>
+          </a:gsLst>
+          <a:lin ang="5400000" scaled="0"/>
+        </a:gradFill>
+      </a:bgFillStyleLst>
+    </a:fmtScheme>
+  </a:themeElements>
+  <a:objectDefaults>
+    <a:lnDef>
+      <a:spPr/>
+      <a:bodyPr/>
+      <a:lstStyle/>
+      <a:style>
+        <a:lnRef idx="2">
+          <a:schemeClr val="accent1"/>
+        </a:lnRef>
+        <a:fillRef idx="0">
+          <a:schemeClr val="accent1"/>
+        </a:fillRef>
+        <a:effectRef idx="1">
+          <a:schemeClr val="accent1"/>
+        </a:effectRef>
+        <a:fontRef idx="minor">
+          <a:schemeClr val="tx1"/>
+        </a:fontRef>
+      </a:style>
+    </a:lnDef>
+  </a:objectDefaults>
+  <a:extraClrSchemeLst/>
+  <a:extLst>
+    <a:ext uri="{05A4C25C-085E-4340-85A3-A5531E510DB2}">
+      <thm15:themeFamily xmlns:thm15="http://schemas.microsoft.com/office/thememl/2012/main" name="Office Theme" id="{2E142A2C-CD16-42D6-873A-C26D2A0506FA}" vid="{1BDDFF52-6CD6-40A5-AB3C-68EB2F1E4D0A}"/>
+    </a:ext>
+  </a:extLst>
+</a:theme>
 </file>
</xml_diff>

<commit_message>
Remove duplicate tables, clarify Sellers, Coach studio vs Seller coach, title slide
- Performance: one scenario table (Workspace); KPI boxes carry status; scorecard removed from Forecast
- Sellers ranked by selling skill; on pace defined; using Databook vs not yet
- Coach studio (for the CRO) and Seller coach (for the seller) labelled
- Connections no longer repeats the Hub settings
- Deck gets a title slide; talk track and audio updated

Co-Authored-By: Claude Sonnet 5.5 <noreply@anthropic.com>
</commit_message>
<xml_diff>
--- a/Zoom CRO Pitch (6 slides) v2.pptx
+++ b/Zoom CRO Pitch (6 slides) v2.pptx
@@ -4,10 +4,8 @@
   <p:sldMasterIdLst>
     <p:sldMasterId id="2147483648" r:id="rId1"/>
   </p:sldMasterIdLst>
-  <p:notesMasterIdLst>
-    <p:notesMasterId r:id="rId8"/>
-  </p:notesMasterIdLst>
   <p:sldIdLst>
+    <p:sldId id="262" r:id="rId13"/>
     <p:sldId id="256" r:id="rId2"/>
     <p:sldId id="257" r:id="rId3"/>
     <p:sldId id="258" r:id="rId4"/>
@@ -15,6 +13,9 @@
     <p:sldId id="260" r:id="rId6"/>
     <p:sldId id="261" r:id="rId7"/>
   </p:sldIdLst>
+  <p:notesMasterIdLst>
+    <p:notesMasterId r:id="rId8"/>
+  </p:notesMasterIdLst>
   <p:sldSz cx="12192000" cy="6858000"/>
   <p:notesSz cx="6858000" cy="12192000"/>
   <p:defaultTextStyle>
@@ -109,11 +110,6 @@
       </a:defRPr>
     </a:lvl9pPr>
   </p:defaultTextStyle>
-  <p:extLst>
-    <p:ext uri="{EFAFB233-063F-42B5-8137-9DF3F51BA10A}">
-      <p15:sldGuideLst xmlns:p15="http://schemas.microsoft.com/office/powerpoint/2012/main"/>
-    </p:ext>
-  </p:extLst>
 </p:presentation>
 </file>
 
@@ -139,10 +135,234 @@
           <a:chExt cx="0" cy="0"/>
         </a:xfrm>
       </p:grpSpPr>
+      <p:sp>
+        <p:nvSpPr>
+          <p:cNvPr id="2" name="Header Placeholder 1"/>
+          <p:cNvSpPr>
+            <a:spLocks noGrp="1"/>
+          </p:cNvSpPr>
+          <p:nvPr>
+            <p:ph type="hdr" sz="quarter"/>
+          </p:nvPr>
+        </p:nvSpPr>
+        <p:spPr>
+          <a:xfrm>
+            <a:off x="0" y="0"/>
+            <a:ext cx="2971800" cy="458788"/>
+          </a:xfrm>
+          <a:prstGeom prst="rect">
+            <a:avLst/>
+          </a:prstGeom>
+        </p:spPr>
+        <p:txBody>
+          <a:bodyPr vert="horz" lIns="91440" tIns="45720" rIns="91440" bIns="45720" rtlCol="0"/>
+          <a:lstStyle>
+            <a:lvl1pPr algn="l">
+              <a:defRPr sz="1200"/>
+            </a:lvl1pPr>
+          </a:lstStyle>
+          <a:p>
+            <a:endParaRPr lang="en-US"/>
+          </a:p>
+        </p:txBody>
+      </p:sp>
+      <p:sp>
+        <p:nvSpPr>
+          <p:cNvPr id="3" name="Date Placeholder 2"/>
+          <p:cNvSpPr>
+            <a:spLocks noGrp="1"/>
+          </p:cNvSpPr>
+          <p:nvPr>
+            <p:ph type="dt" idx="1"/>
+          </p:nvPr>
+        </p:nvSpPr>
+        <p:spPr>
+          <a:xfrm>
+            <a:off x="3884613" y="0"/>
+            <a:ext cx="2971800" cy="458788"/>
+          </a:xfrm>
+          <a:prstGeom prst="rect">
+            <a:avLst/>
+          </a:prstGeom>
+        </p:spPr>
+        <p:txBody>
+          <a:bodyPr vert="horz" lIns="91440" tIns="45720" rIns="91440" bIns="45720" rtlCol="0"/>
+          <a:lstStyle>
+            <a:lvl1pPr algn="r">
+              <a:defRPr sz="1200"/>
+            </a:lvl1pPr>
+          </a:lstStyle>
+          <a:p>
+            <a:fld id="{5282F153-3F37-0F45-9E97-73ACFA13230C}" type="datetimeFigureOut">
+              <a:rPr lang="en-US"/>
+              <a:t>7/23/19</a:t>
+            </a:fld>
+            <a:endParaRPr lang="en-US"/>
+          </a:p>
+        </p:txBody>
+      </p:sp>
+      <p:sp>
+        <p:nvSpPr>
+          <p:cNvPr id="4" name="Slide Image Placeholder 3"/>
+          <p:cNvSpPr>
+            <a:spLocks noGrp="1" noRot="1" noChangeAspect="1"/>
+          </p:cNvSpPr>
+          <p:nvPr>
+            <p:ph type="sldImg" idx="2"/>
+          </p:nvPr>
+        </p:nvSpPr>
+        <p:spPr>
+          <a:xfrm>
+            <a:off x="685800" y="1143000"/>
+            <a:ext cx="5486400" cy="3086100"/>
+          </a:xfrm>
+          <a:prstGeom prst="rect">
+            <a:avLst/>
+          </a:prstGeom>
+          <a:noFill/>
+          <a:ln w="12700">
+            <a:solidFill>
+              <a:prstClr val="black"/>
+            </a:solidFill>
+          </a:ln>
+        </p:spPr>
+        <p:txBody>
+          <a:bodyPr vert="horz" lIns="91440" tIns="45720" rIns="91440" bIns="45720" rtlCol="0" anchor="ctr"/>
+          <a:lstStyle/>
+          <a:p>
+            <a:endParaRPr lang="en-US"/>
+          </a:p>
+        </p:txBody>
+      </p:sp>
+      <p:sp>
+        <p:nvSpPr>
+          <p:cNvPr id="5" name="Notes Placeholder 4"/>
+          <p:cNvSpPr>
+            <a:spLocks noGrp="1"/>
+          </p:cNvSpPr>
+          <p:nvPr>
+            <p:ph type="body" sz="quarter" idx="3"/>
+          </p:nvPr>
+        </p:nvSpPr>
+        <p:spPr>
+          <a:xfrm>
+            <a:off x="685800" y="4400550"/>
+            <a:ext cx="5486400" cy="3600450"/>
+          </a:xfrm>
+          <a:prstGeom prst="rect">
+            <a:avLst/>
+          </a:prstGeom>
+        </p:spPr>
+        <p:txBody>
+          <a:bodyPr vert="horz" lIns="91440" tIns="45720" rIns="91440" bIns="45720" rtlCol="0"/>
+          <a:lstStyle/>
+          <a:p>
+            <a:pPr lvl="0"/>
+            <a:r>
+              <a:rPr lang="en-US"/>
+              <a:t>Click to edit Master text styles</a:t>
+            </a:r>
+          </a:p>
+          <a:p>
+            <a:pPr lvl="1"/>
+            <a:r>
+              <a:rPr lang="en-US"/>
+              <a:t>Second level</a:t>
+            </a:r>
+          </a:p>
+          <a:p>
+            <a:pPr lvl="2"/>
+            <a:r>
+              <a:rPr lang="en-US"/>
+              <a:t>Third level</a:t>
+            </a:r>
+          </a:p>
+          <a:p>
+            <a:pPr lvl="3"/>
+            <a:r>
+              <a:rPr lang="en-US"/>
+              <a:t>Fourth level</a:t>
+            </a:r>
+          </a:p>
+          <a:p>
+            <a:pPr lvl="4"/>
+            <a:r>
+              <a:rPr lang="en-US"/>
+              <a:t>Fifth level</a:t>
+            </a:r>
+          </a:p>
+        </p:txBody>
+      </p:sp>
+      <p:sp>
+        <p:nvSpPr>
+          <p:cNvPr id="6" name="Footer Placeholder 5"/>
+          <p:cNvSpPr>
+            <a:spLocks noGrp="1"/>
+          </p:cNvSpPr>
+          <p:nvPr>
+            <p:ph type="ftr" sz="quarter" idx="4"/>
+          </p:nvPr>
+        </p:nvSpPr>
+        <p:spPr>
+          <a:xfrm>
+            <a:off x="0" y="8685213"/>
+            <a:ext cx="2971800" cy="458787"/>
+          </a:xfrm>
+          <a:prstGeom prst="rect">
+            <a:avLst/>
+          </a:prstGeom>
+        </p:spPr>
+        <p:txBody>
+          <a:bodyPr vert="horz" lIns="91440" tIns="45720" rIns="91440" bIns="45720" rtlCol="0" anchor="b"/>
+          <a:lstStyle>
+            <a:lvl1pPr algn="l">
+              <a:defRPr sz="1200"/>
+            </a:lvl1pPr>
+          </a:lstStyle>
+          <a:p>
+            <a:endParaRPr lang="en-US"/>
+          </a:p>
+        </p:txBody>
+      </p:sp>
+      <p:sp>
+        <p:nvSpPr>
+          <p:cNvPr id="7" name="Slide Number Placeholder 6"/>
+          <p:cNvSpPr>
+            <a:spLocks noGrp="1"/>
+          </p:cNvSpPr>
+          <p:nvPr>
+            <p:ph type="sldNum" sz="quarter" idx="5"/>
+          </p:nvPr>
+        </p:nvSpPr>
+        <p:spPr>
+          <a:xfrm>
+            <a:off x="3884613" y="8685213"/>
+            <a:ext cx="2971800" cy="458787"/>
+          </a:xfrm>
+          <a:prstGeom prst="rect">
+            <a:avLst/>
+          </a:prstGeom>
+        </p:spPr>
+        <p:txBody>
+          <a:bodyPr vert="horz" lIns="91440" tIns="45720" rIns="91440" bIns="45720" rtlCol="0" anchor="b"/>
+          <a:lstStyle>
+            <a:lvl1pPr algn="r">
+              <a:defRPr sz="1200"/>
+            </a:lvl1pPr>
+          </a:lstStyle>
+          <a:p>
+            <a:fld id="{CE5E9CC1-C706-0F49-92D6-E571CC5EEA8F}" type="slidenum">
+              <a:rPr lang="en-US"/>
+              <a:t>‹#›</a:t>
+            </a:fld>
+            <a:endParaRPr lang="en-US"/>
+          </a:p>
+        </p:txBody>
+      </p:sp>
     </p:spTree>
     <p:extLst>
       <p:ext uri="{BB962C8B-B14F-4D97-AF65-F5344CB8AC3E}">
-        <p14:creationId xmlns:p14="http://schemas.microsoft.com/office/powerpoint/2010/main" val="2119286735"/>
+        <p14:creationId xmlns:p14="http://schemas.microsoft.com/office/powerpoint/2010/main" val="1024086991"/>
       </p:ext>
     </p:extLst>
   </p:cSld>
@@ -288,8 +508,9 @@
           <a:p>
             <a:r>
               <a:rPr lang="en-US" dirty="0"/>
-              <a:t>Start with Zoom, not Databook. Say the phrase “AI sales transformation” early: this is about changing how Zoom sells, not only what it reports. Zoom has dropped “Video” from its name and calls itself an AI-first work platform. Its March 2026 announcement framed Zoom as a system of action, with AI Companion 3.0, custom agents, and Zoom CX products. AI Companion active users more than tripled year on year in Q4 FY26 and paid AI was in each of the top ten CX deals last quarter, per Zoom. The gap is the seller: the vision only lands if sellers can take it into each account. I could not open the Forbes piece (it blocked automated access), so this slide uses Zoom’s own announcement and press coverage of the rebrand. Enterprise at about 60% of revenue is derived from Zoom’s reported FY26 figures.</a:t>
-            </a:r>
+              <a:t>Start with Zoom, not Databook. If asked about FY26: Zoom’s fiscal year ends January 31, so FY26 is February 2025 to January 2026, reported on February 25, 2026. Today is Q3 of FY27, so FY26 is the latest full reported year: revenue $4,868.8M, Enterprise $2,934.1M, about 60%. Say the phrase “AI sales transformation” early: this is about changing how Zoom sells, not only what it reports. Zoom has dropped “Video” from its name and calls itself an AI-first work platform. Its March 2026 announcement framed Zoom as a system of action, with AI Companion 3.0, custom agents, and Zoom CX products. AI Companion active users more than tripled year on year in Q4 FY26 and paid AI was in each of the top ten CX deals last quarter, per Zoom. The gap is the seller: the vision only lands if sellers can take it into each account. If asked why Zoom cannot just use AI Sales Assist and Ask ZRA: they are Zoom Revenue Accelerator features that work from conversations and revenue data; Databook adds outside-in customer context, one view across CRM, usage and delivery, a CRO decision with an owner, and proof against the CFO’s target, and can use ZRA as a signal source. Check the announcement date for these two products before presenting: Zoom’s investor release I found is dated July 22, 2026. I could not open the Forbes piece (it blocked automated access), so this slide uses Zoom’s own announcement and press coverage of the rebrand. Enterprise at about 60% of revenue is derived from Zoom’s reported FY26 figures.</a:t>
+            </a:r>
+            <a:endParaRPr lang="en-US" dirty="0"/>
           </a:p>
         </p:txBody>
       </p:sp>
@@ -377,6 +598,7 @@
               <a:rPr lang="en-US" dirty="0"/>
               <a:t>Zoom wants to be known as an AI-native, holistic platform, but competitors already sell that story with the weight of an ecosystem behind it: Microsoft with Teams and Copilot, Google with Gemini inside Workspace, Cisco and RingCentral as Gartner UCaaS leaders, and Salesforce putting Agentforce inside Slack. Zoom has pointed to a total addressable market of about $125B for 2026 (Zoomtopia 2022) and up to $235B by 2028; its FY26 revenue of $4.87B is roughly 4% of the first figure, so the revenue is about 4% of that figure. That is a scale comparison, not market share, and it is illustrative: TAM definitions differ and the $235B figure comes from a third-party summary of Zoomtopia 2024, so confirm it in Zoom’s own investor slides before presenting. The point is the gap is large, it maps straight to the top line, and the way to close it is account by account, through sellers who can sell the platform vision.</a:t>
             </a:r>
+            <a:endParaRPr lang="en-US" dirty="0"/>
           </a:p>
         </p:txBody>
       </p:sp>
@@ -464,6 +686,7 @@
               <a:rPr lang="en-US" dirty="0"/>
               <a:t>This answers the gap on the previous slide: the market is there, and the top line follows when sellers can take Zoom’s AI-first vision into each account. This is the alignment statement. As an AI deployment manager from Databook, I align to what Zoom needs: if customers need to see Zoom differently, the sellers need the right information to take that vision forward. Databook works customer-back: it builds the account context, then guides the seller. That helps three things that matter to Zoom: revenue growth, how customers perceive the products, and the win rate against named rivals. The point is to help Zoom go beyond its target, not only reach it. The competitive and market data in the prototype is illustrative.</a:t>
             </a:r>
+            <a:endParaRPr lang="en-US" dirty="0"/>
           </a:p>
         </p:txBody>
       </p:sp>
@@ -551,6 +774,7 @@
               <a:rPr lang="en-US" dirty="0"/>
               <a:t>The decision system in three layers: the data layer builds the account picture from Zoom’s own systems, the intelligence layer decides what matters and what to do, and the execution layer puts guidance where sellers work and gives the CRO control and measurement. The differentiators on the bottom row are why an outcome-based model is credible: the context is verifiable, the baseline is agreed up front, and the system, not the vendor, measures the result. If no revenue shows up above target, only the platform fee is owed. The platform fee is not disclosed in Databook’s webinar. The 39% and 99% figures are Databook’s claims. Other tools tell you what happened, or find more data; Databook decides what to do on this account, and proves it. If asked about Clay, Gong or Clari, compare on trust, guidance and proof, not features, and say this is your understanding.</a:t>
             </a:r>
+            <a:endParaRPr lang="en-US" dirty="0"/>
           </a:p>
         </p:txBody>
       </p:sp>
@@ -638,6 +862,7 @@
               <a:rPr lang="en-US" dirty="0"/>
               <a:t>On the platform the CRO Hub is five colour-coded boxes: top line and decisions, key accounts, return on spend, product and brand, sellers and adoption. This is the loop the prototype runs, on one account, Northwind Traders. See: bookings are forecast against target, and every number says how Databook sees it, from Zoom’s own systems and from outside data. Find: the top accounts to spend time on, and Northwind opened to its five angles, each labelled verified, inferred or needs validation. Decide: the CRO approves reframing the Contact Center play, with an owner, a date and a modeled dollar impact, before any seller sees it. Guide: the play lands in Slack and Salesforce as four steps, and the coach is adapted once and handed to the seller. Prove: execution is tracked from authorized to buyer step, so adoption shows within weeks and revenue is claimed only as it lags in. Regions, statuses and the account are simulated.</a:t>
             </a:r>
+            <a:endParaRPr lang="en-US" dirty="0"/>
           </a:p>
         </p:txBody>
       </p:sp>
@@ -725,6 +950,7 @@
               <a:rPr lang="en-US" dirty="0"/>
               <a:t>Keep this one statement clear: behaviors and systems move together. Adoption of a new system is hard for sellers, because they are used to a certain selling motion. The implementation and adoption playbook is how Databook’s deployment managers, like me, work closely with the champions at Zoom: align them on the case for change, have the CRO lead by example by authorizing plays, enable sellers one to one, and align KPIs and incentives. If sellers do not change behavior and use the skills and capabilities Databook provides, there is no revenue uplift. Without Databook, the lever is hiring: roughly 10 to 20 reps and $3M to $5M to add $10M, with about six months of ramp, as Databook states; in the prototype data the hires from last fiscal year took about six months to a first win. On the platform, Uplift and adoption shows the same point: the modeled uplift is about +$4.6M at full adoption and +$2.3M at half, and a senior leader is on 35% of deals today against 68% for pilot sellers. With Databook, existing sellers are equipped and the fee is tied to revenue above target. The grey names are customer logos shown on databook.com; Zoom is not listed there, so frame Zoom as the next one, not a past result.</a:t>
             </a:r>
+            <a:endParaRPr lang="en-US" dirty="0"/>
           </a:p>
         </p:txBody>
       </p:sp>
@@ -802,7 +1028,6 @@
         <a:solidFill>
           <a:srgbClr val="FAFAF8"/>
         </a:solidFill>
-        <a:effectLst/>
       </p:bgPr>
     </p:bg>
     <p:spTree>
@@ -822,9 +1047,7 @@
       <p:sp>
         <p:nvSpPr>
           <p:cNvPr id="2" name="Title Placeholder 1"/>
-          <p:cNvSpPr>
-            <a:spLocks noGrp="1"/>
-          </p:cNvSpPr>
+          <p:cNvSpPr/>
           <p:nvPr>
             <p:ph type="title"/>
           </p:nvPr>
@@ -843,7 +1066,7 @@
         <p:txBody>
           <a:bodyPr wrap="square" lIns="0" tIns="0" rIns="0" bIns="0" rtlCol="0" anchor="t"/>
           <a:lstStyle>
-            <a:lvl1pPr marL="0" indent="0" algn="l">
+            <a:lvl1pPr algn="l" indent="0" marL="0">
               <a:lnSpc>
                 <a:spcPct val="115000"/>
               </a:lnSpc>
@@ -859,7 +1082,7 @@
             </a:lvl1pPr>
           </a:lstStyle>
           <a:p>
-            <a:pPr marL="0" indent="0" algn="l">
+            <a:pPr algn="l" indent="0" marL="0">
               <a:lnSpc>
                 <a:spcPct val="115000"/>
               </a:lnSpc>
@@ -872,11 +1095,9 @@
       <p:sp>
         <p:nvSpPr>
           <p:cNvPr id="3" name="Text Placeholder 2"/>
-          <p:cNvSpPr>
-            <a:spLocks noGrp="1"/>
-          </p:cNvSpPr>
+          <p:cNvSpPr/>
           <p:nvPr>
-            <p:ph type="body" idx="101"/>
+            <p:ph idx="101" type="body"/>
           </p:nvPr>
         </p:nvSpPr>
         <p:spPr>
@@ -893,7 +1114,7 @@
         <p:txBody>
           <a:bodyPr wrap="square" lIns="0" tIns="0" rIns="0" bIns="0" rtlCol="0" anchor="t"/>
           <a:lstStyle>
-            <a:lvl1pPr marL="0" indent="0" algn="l">
+            <a:lvl1pPr algn="l" indent="0" marL="0">
               <a:lnSpc>
                 <a:spcPct val="140000"/>
               </a:lnSpc>
@@ -909,7 +1130,7 @@
             </a:lvl1pPr>
           </a:lstStyle>
           <a:p>
-            <a:pPr marL="0" indent="0" algn="l">
+            <a:pPr algn="l" indent="0" marL="0">
               <a:lnSpc>
                 <a:spcPct val="140000"/>
               </a:lnSpc>
@@ -935,7 +1156,6 @@
         <a:solidFill>
           <a:srgbClr val="FAFAF8"/>
         </a:solidFill>
-        <a:effectLst/>
       </p:bgPr>
     </p:bg>
     <p:spTree>
@@ -955,9 +1175,7 @@
       <p:sp>
         <p:nvSpPr>
           <p:cNvPr id="2" name="Title Placeholder 1"/>
-          <p:cNvSpPr>
-            <a:spLocks noGrp="1"/>
-          </p:cNvSpPr>
+          <p:cNvSpPr/>
           <p:nvPr>
             <p:ph type="title"/>
           </p:nvPr>
@@ -976,7 +1194,7 @@
         <p:txBody>
           <a:bodyPr wrap="square" lIns="0" tIns="0" rIns="0" bIns="0" rtlCol="0" anchor="t"/>
           <a:lstStyle>
-            <a:lvl1pPr marL="0" indent="0" algn="l">
+            <a:lvl1pPr algn="l" indent="0" marL="0">
               <a:lnSpc>
                 <a:spcPct val="115000"/>
               </a:lnSpc>
@@ -992,7 +1210,7 @@
             </a:lvl1pPr>
           </a:lstStyle>
           <a:p>
-            <a:pPr marL="0" indent="0" algn="l">
+            <a:pPr algn="l" indent="0" marL="0">
               <a:lnSpc>
                 <a:spcPct val="115000"/>
               </a:lnSpc>
@@ -1005,11 +1223,9 @@
       <p:sp>
         <p:nvSpPr>
           <p:cNvPr id="3" name="Text Placeholder 2"/>
-          <p:cNvSpPr>
-            <a:spLocks noGrp="1"/>
-          </p:cNvSpPr>
+          <p:cNvSpPr/>
           <p:nvPr>
-            <p:ph type="body" idx="101"/>
+            <p:ph idx="101" type="body"/>
           </p:nvPr>
         </p:nvSpPr>
         <p:spPr>
@@ -1026,7 +1242,7 @@
         <p:txBody>
           <a:bodyPr wrap="square" lIns="0" tIns="0" rIns="0" bIns="0" rtlCol="0" anchor="t"/>
           <a:lstStyle>
-            <a:lvl1pPr marL="0" indent="0" algn="l">
+            <a:lvl1pPr algn="l" indent="0" marL="0">
               <a:lnSpc>
                 <a:spcPct val="140000"/>
               </a:lnSpc>
@@ -1042,7 +1258,7 @@
             </a:lvl1pPr>
           </a:lstStyle>
           <a:p>
-            <a:pPr marL="0" indent="0" algn="l">
+            <a:pPr algn="l" indent="0" marL="0">
               <a:lnSpc>
                 <a:spcPct val="140000"/>
               </a:lnSpc>
@@ -1321,7 +1537,6 @@
         <a:solidFill>
           <a:srgbClr val="BA3920"/>
         </a:solidFill>
-        <a:effectLst/>
       </p:bgPr>
     </p:bg>
     <p:spTree>
@@ -1371,13 +1586,6 @@
           </a:gradFill>
           <a:ln/>
         </p:spPr>
-        <p:txBody>
-          <a:bodyPr/>
-          <a:lstStyle/>
-          <a:p>
-            <a:endParaRPr lang="en-US"/>
-          </a:p>
-        </p:txBody>
       </p:sp>
       <p:sp>
         <p:nvSpPr>
@@ -1402,14 +1610,14 @@
           </a:bodyPr>
           <a:lstStyle/>
           <a:p>
-            <a:pPr marL="0" indent="0" algn="l">
+            <a:pPr algn="l" indent="0" marL="0">
               <a:lnSpc>
                 <a:spcPts val="1820"/>
               </a:lnSpc>
               <a:buNone/>
             </a:pPr>
             <a:r>
-              <a:rPr lang="en-US" sz="1300" b="1" kern="0" spc="150" dirty="0">
+              <a:rPr lang="en-US" sz="1300" b="1" spc="150" kern="0" dirty="0">
                 <a:solidFill>
                   <a:srgbClr val="879BF4"/>
                 </a:solidFill>
@@ -1426,9 +1634,7 @@
       <p:sp>
         <p:nvSpPr>
           <p:cNvPr id="4" name="Text 2"/>
-          <p:cNvSpPr>
-            <a:spLocks noGrp="1"/>
-          </p:cNvSpPr>
+          <p:cNvSpPr/>
           <p:nvPr>
             <p:ph type="title"/>
           </p:nvPr>
@@ -1450,14 +1656,14 @@
           </a:bodyPr>
           <a:lstStyle/>
           <a:p>
-            <a:pPr marL="0" indent="0" algn="l">
+            <a:pPr algn="l" indent="0" marL="0">
               <a:lnSpc>
                 <a:spcPts val="3990"/>
               </a:lnSpc>
               <a:buNone/>
             </a:pPr>
             <a:r>
-              <a:rPr lang="en-US" sz="3800" b="1" i="0" kern="0" spc="-100" dirty="0">
+              <a:rPr lang="en-US" sz="3800" b="1" i="0" spc="-100" kern="0" dirty="0">
                 <a:solidFill>
                   <a:srgbClr val="FAFAF8"/>
                 </a:solidFill>
@@ -1499,13 +1705,6 @@
             <a:prstDash val="solid"/>
           </a:ln>
         </p:spPr>
-        <p:txBody>
-          <a:bodyPr/>
-          <a:lstStyle/>
-          <a:p>
-            <a:endParaRPr lang="en-US"/>
-          </a:p>
-        </p:txBody>
       </p:sp>
       <p:sp>
         <p:nvSpPr>
@@ -1530,14 +1729,14 @@
           </a:bodyPr>
           <a:lstStyle/>
           <a:p>
-            <a:pPr marL="0" indent="0" algn="l">
+            <a:pPr algn="l" indent="0" marL="0">
               <a:lnSpc>
                 <a:spcPts val="1680"/>
               </a:lnSpc>
               <a:buNone/>
             </a:pPr>
             <a:r>
-              <a:rPr lang="en-US" sz="1200" b="1" kern="0" spc="100" dirty="0">
+              <a:rPr lang="en-US" sz="1200" b="1" spc="100" kern="0" dirty="0">
                 <a:solidFill>
                   <a:srgbClr val="DE605E"/>
                 </a:solidFill>
@@ -1574,7 +1773,7 @@
           </a:bodyPr>
           <a:lstStyle/>
           <a:p>
-            <a:pPr marL="0" indent="0" algn="l">
+            <a:pPr algn="l" indent="0" marL="0">
               <a:lnSpc>
                 <a:spcPts val="1755"/>
               </a:lnSpc>
@@ -1618,7 +1817,7 @@
           </a:bodyPr>
           <a:lstStyle/>
           <a:p>
-            <a:pPr marL="0" indent="0" algn="l">
+            <a:pPr algn="l" indent="0" marL="0">
               <a:lnSpc>
                 <a:spcPts val="1755"/>
               </a:lnSpc>
@@ -1662,7 +1861,7 @@
           </a:bodyPr>
           <a:lstStyle/>
           <a:p>
-            <a:pPr marL="0" indent="0" algn="l">
+            <a:pPr algn="l" indent="0" marL="0">
               <a:lnSpc>
                 <a:spcPts val="1755"/>
               </a:lnSpc>
@@ -1711,13 +1910,6 @@
             <a:prstDash val="solid"/>
           </a:ln>
         </p:spPr>
-        <p:txBody>
-          <a:bodyPr/>
-          <a:lstStyle/>
-          <a:p>
-            <a:endParaRPr lang="en-US"/>
-          </a:p>
-        </p:txBody>
       </p:sp>
       <p:sp>
         <p:nvSpPr>
@@ -1742,14 +1934,14 @@
           </a:bodyPr>
           <a:lstStyle/>
           <a:p>
-            <a:pPr marL="0" indent="0" algn="l">
+            <a:pPr algn="l" indent="0" marL="0">
               <a:lnSpc>
                 <a:spcPts val="1680"/>
               </a:lnSpc>
               <a:buNone/>
             </a:pPr>
             <a:r>
-              <a:rPr lang="en-US" sz="1200" b="1" kern="0" spc="100" dirty="0">
+              <a:rPr lang="en-US" sz="1200" b="1" spc="100" kern="0" dirty="0">
                 <a:solidFill>
                   <a:srgbClr val="DE605E"/>
                 </a:solidFill>
@@ -1786,7 +1978,7 @@
           </a:bodyPr>
           <a:lstStyle/>
           <a:p>
-            <a:pPr marL="0" indent="0" algn="l">
+            <a:pPr algn="l" indent="0" marL="0">
               <a:lnSpc>
                 <a:spcPts val="1755"/>
               </a:lnSpc>
@@ -1830,7 +2022,7 @@
           </a:bodyPr>
           <a:lstStyle/>
           <a:p>
-            <a:pPr marL="0" indent="0" algn="l">
+            <a:pPr algn="l" indent="0" marL="0">
               <a:lnSpc>
                 <a:spcPts val="1755"/>
               </a:lnSpc>
@@ -1874,7 +2066,7 @@
           </a:bodyPr>
           <a:lstStyle/>
           <a:p>
-            <a:pPr marL="0" indent="0" algn="l">
+            <a:pPr algn="l" indent="0" marL="0">
               <a:lnSpc>
                 <a:spcPts val="1755"/>
               </a:lnSpc>
@@ -1923,13 +2115,6 @@
             <a:prstDash val="solid"/>
           </a:ln>
         </p:spPr>
-        <p:txBody>
-          <a:bodyPr/>
-          <a:lstStyle/>
-          <a:p>
-            <a:endParaRPr lang="en-US"/>
-          </a:p>
-        </p:txBody>
       </p:sp>
       <p:sp>
         <p:nvSpPr>
@@ -1954,14 +2139,14 @@
           </a:bodyPr>
           <a:lstStyle/>
           <a:p>
-            <a:pPr marL="0" indent="0" algn="l">
+            <a:pPr algn="l" indent="0" marL="0">
               <a:lnSpc>
                 <a:spcPts val="1680"/>
               </a:lnSpc>
               <a:buNone/>
             </a:pPr>
             <a:r>
-              <a:rPr lang="en-US" sz="1200" b="1" kern="0" spc="100" dirty="0">
+              <a:rPr lang="en-US" sz="1200" b="1" spc="100" kern="0" dirty="0">
                 <a:solidFill>
                   <a:srgbClr val="DE605E"/>
                 </a:solidFill>
@@ -1998,7 +2183,7 @@
           </a:bodyPr>
           <a:lstStyle/>
           <a:p>
-            <a:pPr marL="0" indent="0" algn="l">
+            <a:pPr algn="l" indent="0" marL="0">
               <a:lnSpc>
                 <a:spcPts val="1755"/>
               </a:lnSpc>
@@ -2042,7 +2227,7 @@
           </a:bodyPr>
           <a:lstStyle/>
           <a:p>
-            <a:pPr marL="0" indent="0" algn="l">
+            <a:pPr algn="l" indent="0" marL="0">
               <a:lnSpc>
                 <a:spcPts val="1755"/>
               </a:lnSpc>
@@ -2086,7 +2271,7 @@
           </a:bodyPr>
           <a:lstStyle/>
           <a:p>
-            <a:pPr marL="0" indent="0" algn="l">
+            <a:pPr algn="l" indent="0" marL="0">
               <a:lnSpc>
                 <a:spcPts val="1755"/>
               </a:lnSpc>
@@ -2134,7 +2319,7 @@
           </a:bodyPr>
           <a:lstStyle/>
           <a:p>
-            <a:pPr marL="0" indent="0" algn="l">
+            <a:pPr algn="l" indent="0" marL="0">
               <a:lnSpc>
                 <a:spcPts val="2160"/>
               </a:lnSpc>
@@ -2180,19 +2365,19 @@
                 <a:lnTo>
                   <a:pt x="101600" y="904180"/>
                 </a:lnTo>
-                <a:arcTo wR="101600" hR="101600" stAng="5400000" swAng="5400000"/>
+                <a:arcTo hR="101600" wR="101600" stAng="5400000" swAng="5400000"/>
                 <a:lnTo>
                   <a:pt x="0" y="101600"/>
                 </a:lnTo>
-                <a:arcTo wR="101600" hR="101600" stAng="10800000" swAng="5400000"/>
+                <a:arcTo hR="101600" wR="101600" stAng="10800000" swAng="5400000"/>
                 <a:lnTo>
                   <a:pt x="101600" y="0"/>
                 </a:lnTo>
-                <a:arcTo wR="38100" hR="101600" stAng="16200000" swAng="-5400000"/>
+                <a:arcTo hR="101600" wR="38100" stAng="16200000" swAng="-5400000"/>
                 <a:lnTo>
                   <a:pt x="63500" y="802580"/>
                 </a:lnTo>
-                <a:arcTo wR="38100" hR="101600" stAng="10800000" swAng="-5400000"/>
+                <a:arcTo hR="101600" wR="38100" stAng="10800000" swAng="-5400000"/>
                 <a:close/>
               </a:path>
             </a:pathLst>
@@ -2202,13 +2387,6 @@
           </a:solidFill>
           <a:ln/>
         </p:spPr>
-        <p:txBody>
-          <a:bodyPr/>
-          <a:lstStyle/>
-          <a:p>
-            <a:endParaRPr lang="en-US"/>
-          </a:p>
-        </p:txBody>
       </p:sp>
       <p:sp>
         <p:nvSpPr>
@@ -2233,7 +2411,7 @@
           </a:bodyPr>
           <a:lstStyle/>
           <a:p>
-            <a:pPr marL="0" indent="0" algn="l">
+            <a:pPr algn="l" indent="0" marL="0">
               <a:lnSpc>
                 <a:spcPts val="1680"/>
               </a:lnSpc>
@@ -2248,7 +2426,7 @@
                 <a:ea typeface="Inter" pitchFamily="34" charset="-122"/>
                 <a:cs typeface="Inter" pitchFamily="34" charset="-120"/>
               </a:rPr>
-              <a:t>Sources: Zoom announcement (March 10, 2026), Zoom FY26 results, coverage of Zoom’s 2024 rebrand</a:t>
+              <a:t>Sources: Zoom announcement (March 10, 2026), Zoom FY26 results (year to Jan 31, 2026), 2024 rebrand coverage</a:t>
             </a:r>
             <a:endParaRPr lang="en-US" sz="1200" dirty="0"/>
           </a:p>
@@ -2277,7 +2455,7 @@
           </a:bodyPr>
           <a:lstStyle/>
           <a:p>
-            <a:pPr marL="0" indent="0" algn="r">
+            <a:pPr algn="r" indent="0" marL="0">
               <a:lnSpc>
                 <a:spcPts val="1680"/>
               </a:lnSpc>
@@ -2314,7 +2492,6 @@
         <a:solidFill>
           <a:srgbClr val="FAFAF8"/>
         </a:solidFill>
-        <a:effectLst/>
       </p:bgPr>
     </p:bg>
     <p:spTree>
@@ -2354,14 +2531,14 @@
           </a:bodyPr>
           <a:lstStyle/>
           <a:p>
-            <a:pPr marL="0" indent="0" algn="l">
+            <a:pPr algn="l" indent="0" marL="0">
               <a:lnSpc>
                 <a:spcPts val="1820"/>
               </a:lnSpc>
               <a:buNone/>
             </a:pPr>
             <a:r>
-              <a:rPr lang="en-US" sz="1300" b="1" kern="0" spc="150" dirty="0">
+              <a:rPr lang="en-US" sz="1300" b="1" spc="150" kern="0" dirty="0">
                 <a:solidFill>
                   <a:srgbClr val="BC3A21"/>
                 </a:solidFill>
@@ -2378,9 +2555,7 @@
       <p:sp>
         <p:nvSpPr>
           <p:cNvPr id="3" name="Text 1"/>
-          <p:cNvSpPr>
-            <a:spLocks noGrp="1"/>
-          </p:cNvSpPr>
+          <p:cNvSpPr/>
           <p:nvPr>
             <p:ph type="title"/>
           </p:nvPr>
@@ -2402,14 +2577,14 @@
           </a:bodyPr>
           <a:lstStyle/>
           <a:p>
-            <a:pPr marL="0" indent="0" algn="l">
+            <a:pPr algn="l" indent="0" marL="0">
               <a:lnSpc>
                 <a:spcPts val="3570"/>
               </a:lnSpc>
               <a:buNone/>
             </a:pPr>
             <a:r>
-              <a:rPr lang="en-US" sz="3400" b="1" i="0" kern="0" spc="-100" dirty="0">
+              <a:rPr lang="en-US" sz="3400" b="1" i="0" spc="-100" kern="0" dirty="0">
                 <a:solidFill>
                   <a:srgbClr val="0B0B12"/>
                 </a:solidFill>
@@ -2449,13 +2624,6 @@
             <a:prstDash val="solid"/>
           </a:ln>
         </p:spPr>
-        <p:txBody>
-          <a:bodyPr/>
-          <a:lstStyle/>
-          <a:p>
-            <a:endParaRPr lang="en-US"/>
-          </a:p>
-        </p:txBody>
       </p:sp>
       <p:sp>
         <p:nvSpPr>
@@ -2480,7 +2648,7 @@
           </a:bodyPr>
           <a:lstStyle/>
           <a:p>
-            <a:pPr marL="0" indent="0" algn="l">
+            <a:pPr algn="l" indent="0" marL="0">
               <a:lnSpc>
                 <a:spcPts val="2160"/>
               </a:lnSpc>
@@ -2524,7 +2692,7 @@
           </a:bodyPr>
           <a:lstStyle/>
           <a:p>
-            <a:pPr marL="0" indent="0" algn="l">
+            <a:pPr algn="l" indent="0" marL="0">
               <a:lnSpc>
                 <a:spcPts val="2100"/>
               </a:lnSpc>
@@ -2568,7 +2736,7 @@
           </a:bodyPr>
           <a:lstStyle/>
           <a:p>
-            <a:pPr marL="0" indent="0" algn="l">
+            <a:pPr algn="l" indent="0" marL="0">
               <a:lnSpc>
                 <a:spcPts val="1690"/>
               </a:lnSpc>
@@ -2612,7 +2780,7 @@
           </a:bodyPr>
           <a:lstStyle/>
           <a:p>
-            <a:pPr marL="0" indent="0" algn="l">
+            <a:pPr algn="l" indent="0" marL="0">
               <a:lnSpc>
                 <a:spcPts val="2100"/>
               </a:lnSpc>
@@ -2656,7 +2824,7 @@
           </a:bodyPr>
           <a:lstStyle/>
           <a:p>
-            <a:pPr marL="0" indent="0" algn="l">
+            <a:pPr algn="l" indent="0" marL="0">
               <a:lnSpc>
                 <a:spcPts val="1690"/>
               </a:lnSpc>
@@ -2700,7 +2868,7 @@
           </a:bodyPr>
           <a:lstStyle/>
           <a:p>
-            <a:pPr marL="0" indent="0" algn="l">
+            <a:pPr algn="l" indent="0" marL="0">
               <a:lnSpc>
                 <a:spcPts val="2100"/>
               </a:lnSpc>
@@ -2744,7 +2912,7 @@
           </a:bodyPr>
           <a:lstStyle/>
           <a:p>
-            <a:pPr marL="0" indent="0" algn="l">
+            <a:pPr algn="l" indent="0" marL="0">
               <a:lnSpc>
                 <a:spcPts val="1690"/>
               </a:lnSpc>
@@ -2788,7 +2956,7 @@
           </a:bodyPr>
           <a:lstStyle/>
           <a:p>
-            <a:pPr marL="0" indent="0" algn="l">
+            <a:pPr algn="l" indent="0" marL="0">
               <a:lnSpc>
                 <a:spcPts val="2100"/>
               </a:lnSpc>
@@ -2832,7 +3000,7 @@
           </a:bodyPr>
           <a:lstStyle/>
           <a:p>
-            <a:pPr marL="0" indent="0" algn="l">
+            <a:pPr algn="l" indent="0" marL="0">
               <a:lnSpc>
                 <a:spcPts val="1690"/>
               </a:lnSpc>
@@ -2874,13 +3042,6 @@
           </a:solidFill>
           <a:ln/>
         </p:spPr>
-        <p:txBody>
-          <a:bodyPr/>
-          <a:lstStyle/>
-          <a:p>
-            <a:endParaRPr lang="en-US"/>
-          </a:p>
-        </p:txBody>
       </p:sp>
       <p:sp>
         <p:nvSpPr>
@@ -2905,14 +3066,14 @@
           </a:bodyPr>
           <a:lstStyle/>
           <a:p>
-            <a:pPr marL="0" indent="0" algn="l">
+            <a:pPr algn="l" indent="0" marL="0">
               <a:lnSpc>
                 <a:spcPts val="1680"/>
               </a:lnSpc>
               <a:buNone/>
             </a:pPr>
             <a:r>
-              <a:rPr lang="en-US" sz="1200" b="1" kern="0" spc="100" dirty="0">
+              <a:rPr lang="en-US" sz="1200" b="1" spc="100" kern="0" dirty="0">
                 <a:solidFill>
                   <a:srgbClr val="879BF4"/>
                 </a:solidFill>
@@ -2949,14 +3110,14 @@
           </a:bodyPr>
           <a:lstStyle/>
           <a:p>
-            <a:pPr marL="0" indent="0" algn="l">
+            <a:pPr algn="l" indent="0" marL="0">
               <a:lnSpc>
                 <a:spcPts val="5200"/>
               </a:lnSpc>
               <a:buNone/>
             </a:pPr>
             <a:r>
-              <a:rPr lang="en-US" sz="5200" b="1" kern="0" spc="-150" dirty="0">
+              <a:rPr lang="en-US" sz="5200" b="1" spc="-150" kern="0" dirty="0">
                 <a:solidFill>
                   <a:srgbClr val="DE605E"/>
                 </a:solidFill>
@@ -2993,7 +3154,7 @@
           </a:bodyPr>
           <a:lstStyle/>
           <a:p>
-            <a:pPr marL="0" indent="0" algn="l">
+            <a:pPr algn="l" indent="0" marL="0">
               <a:lnSpc>
                 <a:spcPts val="1890"/>
               </a:lnSpc>
@@ -3035,13 +3196,6 @@
           </a:solidFill>
           <a:ln/>
         </p:spPr>
-        <p:txBody>
-          <a:bodyPr/>
-          <a:lstStyle/>
-          <a:p>
-            <a:endParaRPr lang="en-US"/>
-          </a:p>
-        </p:txBody>
       </p:sp>
       <p:sp>
         <p:nvSpPr>
@@ -3064,13 +3218,6 @@
           </a:solidFill>
           <a:ln/>
         </p:spPr>
-        <p:txBody>
-          <a:bodyPr/>
-          <a:lstStyle/>
-          <a:p>
-            <a:endParaRPr lang="en-US"/>
-          </a:p>
-        </p:txBody>
       </p:sp>
       <p:sp>
         <p:nvSpPr>
@@ -3095,7 +3242,7 @@
           </a:bodyPr>
           <a:lstStyle/>
           <a:p>
-            <a:pPr marL="0" indent="0" algn="l">
+            <a:pPr algn="l" indent="0" marL="0">
               <a:lnSpc>
                 <a:spcPts val="1755"/>
               </a:lnSpc>
@@ -3149,13 +3296,6 @@
             <a:prstDash val="solid"/>
           </a:ln>
         </p:spPr>
-        <p:txBody>
-          <a:bodyPr/>
-          <a:lstStyle/>
-          <a:p>
-            <a:endParaRPr lang="en-US"/>
-          </a:p>
-        </p:txBody>
       </p:sp>
       <p:sp>
         <p:nvSpPr>
@@ -3180,7 +3320,7 @@
           </a:bodyPr>
           <a:lstStyle/>
           <a:p>
-            <a:pPr marL="0" indent="0" algn="l">
+            <a:pPr algn="l" indent="0" marL="0">
               <a:lnSpc>
                 <a:spcPts val="1950"/>
               </a:lnSpc>
@@ -3224,7 +3364,7 @@
           </a:bodyPr>
           <a:lstStyle/>
           <a:p>
-            <a:pPr marL="0" indent="0" algn="l">
+            <a:pPr algn="l" indent="0" marL="0">
               <a:lnSpc>
                 <a:spcPts val="1680"/>
               </a:lnSpc>
@@ -3268,7 +3408,7 @@
           </a:bodyPr>
           <a:lstStyle/>
           <a:p>
-            <a:pPr marL="0" indent="0" algn="r">
+            <a:pPr algn="r" indent="0" marL="0">
               <a:lnSpc>
                 <a:spcPts val="1680"/>
               </a:lnSpc>
@@ -3305,7 +3445,6 @@
         <a:solidFill>
           <a:srgbClr val="FAFAF8"/>
         </a:solidFill>
-        <a:effectLst/>
       </p:bgPr>
     </p:bg>
     <p:spTree>
@@ -3345,14 +3484,14 @@
           </a:bodyPr>
           <a:lstStyle/>
           <a:p>
-            <a:pPr marL="0" indent="0" algn="l">
+            <a:pPr algn="l" indent="0" marL="0">
               <a:lnSpc>
                 <a:spcPts val="1820"/>
               </a:lnSpc>
               <a:buNone/>
             </a:pPr>
             <a:r>
-              <a:rPr lang="en-US" sz="1300" b="1" kern="0" spc="150" dirty="0">
+              <a:rPr lang="en-US" sz="1300" b="1" spc="150" kern="0" dirty="0">
                 <a:solidFill>
                   <a:srgbClr val="BC3A21"/>
                 </a:solidFill>
@@ -3369,9 +3508,7 @@
       <p:sp>
         <p:nvSpPr>
           <p:cNvPr id="3" name="Text 1"/>
-          <p:cNvSpPr>
-            <a:spLocks noGrp="1"/>
-          </p:cNvSpPr>
+          <p:cNvSpPr/>
           <p:nvPr>
             <p:ph type="title"/>
           </p:nvPr>
@@ -3393,14 +3530,14 @@
           </a:bodyPr>
           <a:lstStyle/>
           <a:p>
-            <a:pPr marL="0" indent="0" algn="l">
+            <a:pPr algn="l" indent="0" marL="0">
               <a:lnSpc>
                 <a:spcPts val="3903"/>
               </a:lnSpc>
               <a:buNone/>
             </a:pPr>
             <a:r>
-              <a:rPr lang="en-US" sz="3717" b="1" i="0" kern="0" spc="-100" dirty="0">
+              <a:rPr lang="en-US" sz="3717" b="1" i="0" spc="-100" kern="0" dirty="0">
                 <a:solidFill>
                   <a:srgbClr val="0B0B12"/>
                 </a:solidFill>
@@ -3446,7 +3583,7 @@
           </a:bodyPr>
           <a:lstStyle/>
           <a:p>
-            <a:pPr marL="0" indent="0" algn="ctr">
+            <a:pPr algn="ctr" indent="0" marL="0">
               <a:lnSpc>
                 <a:spcPts val="1960"/>
               </a:lnSpc>
@@ -3469,15 +3606,15 @@
       </p:sp>
       <p:pic>
         <p:nvPicPr>
-          <p:cNvPr id="5" name="Image 0" descr="arrow-right"/>
+          <p:cNvPr id="5" name="Image 0" descr="arrow-right">    </p:cNvPr>
           <p:cNvPicPr>
             <a:picLocks noChangeAspect="1"/>
           </p:cNvPicPr>
           <p:nvPr/>
         </p:nvPicPr>
         <p:blipFill>
-          <a:blip r:embed="rId3"/>
-          <a:srcRect/>
+          <a:blip r:embed="rId1"/>
+          <a:srcRect l="0" r="0" t="0" b="0"/>
           <a:stretch/>
         </p:blipFill>
         <p:spPr>
@@ -3522,7 +3659,7 @@
           </a:bodyPr>
           <a:lstStyle/>
           <a:p>
-            <a:pPr marL="0" indent="0" algn="ctr">
+            <a:pPr algn="ctr" indent="0" marL="0">
               <a:lnSpc>
                 <a:spcPts val="1960"/>
               </a:lnSpc>
@@ -3545,15 +3682,15 @@
       </p:sp>
       <p:pic>
         <p:nvPicPr>
-          <p:cNvPr id="7" name="Image 1" descr="arrow-right"/>
+          <p:cNvPr id="7" name="Image 1" descr="arrow-right">    </p:cNvPr>
           <p:cNvPicPr>
             <a:picLocks noChangeAspect="1"/>
           </p:cNvPicPr>
           <p:nvPr/>
         </p:nvPicPr>
         <p:blipFill>
-          <a:blip r:embed="rId3"/>
-          <a:srcRect/>
+          <a:blip r:embed="rId2"/>
+          <a:srcRect l="0" r="0" t="0" b="0"/>
           <a:stretch/>
         </p:blipFill>
         <p:spPr>
@@ -3598,7 +3735,7 @@
           </a:bodyPr>
           <a:lstStyle/>
           <a:p>
-            <a:pPr marL="0" indent="0" algn="ctr">
+            <a:pPr algn="ctr" indent="0" marL="0">
               <a:lnSpc>
                 <a:spcPts val="1960"/>
               </a:lnSpc>
@@ -3621,7 +3758,7 @@
       </p:sp>
       <p:pic>
         <p:nvPicPr>
-          <p:cNvPr id="9" name="Image 2" descr="arrow-right"/>
+          <p:cNvPr id="9" name="Image 2" descr="arrow-right">    </p:cNvPr>
           <p:cNvPicPr>
             <a:picLocks noChangeAspect="1"/>
           </p:cNvPicPr>
@@ -3629,7 +3766,7 @@
         </p:nvPicPr>
         <p:blipFill>
           <a:blip r:embed="rId3"/>
-          <a:srcRect/>
+          <a:srcRect l="0" r="0" t="0" b="0"/>
           <a:stretch/>
         </p:blipFill>
         <p:spPr>
@@ -3674,7 +3811,7 @@
           </a:bodyPr>
           <a:lstStyle/>
           <a:p>
-            <a:pPr marL="0" indent="0" algn="ctr">
+            <a:pPr algn="ctr" indent="0" marL="0">
               <a:lnSpc>
                 <a:spcPts val="1960"/>
               </a:lnSpc>
@@ -3721,13 +3858,6 @@
             <a:prstDash val="solid"/>
           </a:ln>
         </p:spPr>
-        <p:txBody>
-          <a:bodyPr/>
-          <a:lstStyle/>
-          <a:p>
-            <a:endParaRPr lang="en-US"/>
-          </a:p>
-        </p:txBody>
       </p:sp>
       <p:sp>
         <p:nvSpPr>
@@ -3751,11 +3881,11 @@
                 <a:moveTo>
                   <a:pt x="17786" y="76200"/>
                 </a:moveTo>
-                <a:arcTo wR="146050" hR="146050" stAng="12514313" swAng="3685687"/>
+                <a:arcTo hR="146050" wR="146050" stAng="12514313" swAng="3685687"/>
                 <a:lnTo>
                   <a:pt x="3244850" y="0"/>
                 </a:lnTo>
-                <a:arcTo wR="146050" hR="146050" stAng="16200000" swAng="3685687"/>
+                <a:arcTo hR="146050" wR="146050" stAng="16200000" swAng="3685687"/>
                 <a:close/>
               </a:path>
             </a:pathLst>
@@ -3765,13 +3895,6 @@
           </a:solidFill>
           <a:ln/>
         </p:spPr>
-        <p:txBody>
-          <a:bodyPr/>
-          <a:lstStyle/>
-          <a:p>
-            <a:endParaRPr lang="en-US"/>
-          </a:p>
-        </p:txBody>
       </p:sp>
       <p:sp>
         <p:nvSpPr>
@@ -3796,14 +3919,14 @@
           </a:bodyPr>
           <a:lstStyle/>
           <a:p>
-            <a:pPr marL="0" indent="0" algn="l">
+            <a:pPr algn="l" indent="0" marL="0">
               <a:lnSpc>
                 <a:spcPts val="2760"/>
               </a:lnSpc>
               <a:buNone/>
             </a:pPr>
             <a:r>
-              <a:rPr lang="en-US" sz="2300" b="1" kern="0" spc="-50" dirty="0">
+              <a:rPr lang="en-US" sz="2300" b="1" spc="-50" kern="0" dirty="0">
                 <a:solidFill>
                   <a:srgbClr val="BC3A21"/>
                 </a:solidFill>
@@ -3840,7 +3963,7 @@
           </a:bodyPr>
           <a:lstStyle/>
           <a:p>
-            <a:pPr marL="0" indent="0" algn="l">
+            <a:pPr algn="l" indent="0" marL="0">
               <a:lnSpc>
                 <a:spcPts val="1890"/>
               </a:lnSpc>
@@ -3884,7 +4007,7 @@
           </a:bodyPr>
           <a:lstStyle/>
           <a:p>
-            <a:pPr marL="0" indent="0" algn="l">
+            <a:pPr algn="l" indent="0" marL="0">
               <a:lnSpc>
                 <a:spcPts val="1890"/>
               </a:lnSpc>
@@ -3927,13 +4050,6 @@
             <a:prstDash val="solid"/>
           </a:ln>
         </p:spPr>
-        <p:txBody>
-          <a:bodyPr/>
-          <a:lstStyle/>
-          <a:p>
-            <a:endParaRPr lang="en-US"/>
-          </a:p>
-        </p:txBody>
       </p:sp>
       <p:sp>
         <p:nvSpPr>
@@ -3958,7 +4074,7 @@
           </a:bodyPr>
           <a:lstStyle/>
           <a:p>
-            <a:pPr marL="0" indent="0" algn="l">
+            <a:pPr algn="l" indent="0" marL="0">
               <a:lnSpc>
                 <a:spcPts val="1680"/>
               </a:lnSpc>
@@ -4005,13 +4121,6 @@
             <a:prstDash val="solid"/>
           </a:ln>
         </p:spPr>
-        <p:txBody>
-          <a:bodyPr/>
-          <a:lstStyle/>
-          <a:p>
-            <a:endParaRPr lang="en-US"/>
-          </a:p>
-        </p:txBody>
       </p:sp>
       <p:sp>
         <p:nvSpPr>
@@ -4035,11 +4144,11 @@
                 <a:moveTo>
                   <a:pt x="17786" y="76200"/>
                 </a:moveTo>
-                <a:arcTo wR="146050" hR="146050" stAng="12514313" swAng="3685687"/>
+                <a:arcTo hR="146050" wR="146050" stAng="12514313" swAng="3685687"/>
                 <a:lnTo>
                   <a:pt x="3244850" y="0"/>
                 </a:lnTo>
-                <a:arcTo wR="146050" hR="146050" stAng="16200000" swAng="3685687"/>
+                <a:arcTo hR="146050" wR="146050" stAng="16200000" swAng="3685687"/>
                 <a:close/>
               </a:path>
             </a:pathLst>
@@ -4049,13 +4158,6 @@
           </a:solidFill>
           <a:ln/>
         </p:spPr>
-        <p:txBody>
-          <a:bodyPr/>
-          <a:lstStyle/>
-          <a:p>
-            <a:endParaRPr lang="en-US"/>
-          </a:p>
-        </p:txBody>
       </p:sp>
       <p:sp>
         <p:nvSpPr>
@@ -4080,14 +4182,14 @@
           </a:bodyPr>
           <a:lstStyle/>
           <a:p>
-            <a:pPr marL="0" indent="0" algn="l">
+            <a:pPr algn="l" indent="0" marL="0">
               <a:lnSpc>
                 <a:spcPts val="2674"/>
               </a:lnSpc>
               <a:buNone/>
             </a:pPr>
             <a:r>
-              <a:rPr lang="en-US" sz="2228" b="1" kern="0" spc="-50" dirty="0">
+              <a:rPr lang="en-US" sz="2228" b="1" spc="-50" kern="0" dirty="0">
                 <a:solidFill>
                   <a:srgbClr val="804979"/>
                 </a:solidFill>
@@ -4124,7 +4226,7 @@
           </a:bodyPr>
           <a:lstStyle/>
           <a:p>
-            <a:pPr marL="0" indent="0" algn="l">
+            <a:pPr algn="l" indent="0" marL="0">
               <a:lnSpc>
                 <a:spcPts val="1837"/>
               </a:lnSpc>
@@ -4168,7 +4270,7 @@
           </a:bodyPr>
           <a:lstStyle/>
           <a:p>
-            <a:pPr marL="0" indent="0" algn="l">
+            <a:pPr algn="l" indent="0" marL="0">
               <a:lnSpc>
                 <a:spcPts val="1837"/>
               </a:lnSpc>
@@ -4211,13 +4313,6 @@
             <a:prstDash val="solid"/>
           </a:ln>
         </p:spPr>
-        <p:txBody>
-          <a:bodyPr/>
-          <a:lstStyle/>
-          <a:p>
-            <a:endParaRPr lang="en-US"/>
-          </a:p>
-        </p:txBody>
       </p:sp>
       <p:sp>
         <p:nvSpPr>
@@ -4242,7 +4337,7 @@
           </a:bodyPr>
           <a:lstStyle/>
           <a:p>
-            <a:pPr marL="0" indent="0" algn="l">
+            <a:pPr algn="l" indent="0" marL="0">
               <a:lnSpc>
                 <a:spcPts val="1633"/>
               </a:lnSpc>
@@ -4289,13 +4384,6 @@
             <a:prstDash val="solid"/>
           </a:ln>
         </p:spPr>
-        <p:txBody>
-          <a:bodyPr/>
-          <a:lstStyle/>
-          <a:p>
-            <a:endParaRPr lang="en-US"/>
-          </a:p>
-        </p:txBody>
       </p:sp>
       <p:sp>
         <p:nvSpPr>
@@ -4319,11 +4407,11 @@
                 <a:moveTo>
                   <a:pt x="17786" y="76200"/>
                 </a:moveTo>
-                <a:arcTo wR="146050" hR="146050" stAng="12514313" swAng="3685687"/>
+                <a:arcTo hR="146050" wR="146050" stAng="12514313" swAng="3685687"/>
                 <a:lnTo>
                   <a:pt x="3244850" y="0"/>
                 </a:lnTo>
-                <a:arcTo wR="146050" hR="146050" stAng="16200000" swAng="3685687"/>
+                <a:arcTo hR="146050" wR="146050" stAng="16200000" swAng="3685687"/>
                 <a:close/>
               </a:path>
             </a:pathLst>
@@ -4333,13 +4421,6 @@
           </a:solidFill>
           <a:ln/>
         </p:spPr>
-        <p:txBody>
-          <a:bodyPr/>
-          <a:lstStyle/>
-          <a:p>
-            <a:endParaRPr lang="en-US"/>
-          </a:p>
-        </p:txBody>
       </p:sp>
       <p:sp>
         <p:nvSpPr>
@@ -4364,14 +4445,14 @@
           </a:bodyPr>
           <a:lstStyle/>
           <a:p>
-            <a:pPr marL="0" indent="0" algn="l">
+            <a:pPr algn="l" indent="0" marL="0">
               <a:lnSpc>
                 <a:spcPts val="2674"/>
               </a:lnSpc>
               <a:buNone/>
             </a:pPr>
             <a:r>
-              <a:rPr lang="en-US" sz="2228" b="1" kern="0" spc="-50" dirty="0">
+              <a:rPr lang="en-US" sz="2228" b="1" spc="-50" kern="0" dirty="0">
                 <a:solidFill>
                   <a:srgbClr val="4558D2"/>
                 </a:solidFill>
@@ -4408,7 +4489,7 @@
           </a:bodyPr>
           <a:lstStyle/>
           <a:p>
-            <a:pPr marL="0" indent="0" algn="l">
+            <a:pPr algn="l" indent="0" marL="0">
               <a:lnSpc>
                 <a:spcPts val="1837"/>
               </a:lnSpc>
@@ -4452,7 +4533,7 @@
           </a:bodyPr>
           <a:lstStyle/>
           <a:p>
-            <a:pPr marL="0" indent="0" algn="l">
+            <a:pPr algn="l" indent="0" marL="0">
               <a:lnSpc>
                 <a:spcPts val="1837"/>
               </a:lnSpc>
@@ -4495,13 +4576,6 @@
             <a:prstDash val="solid"/>
           </a:ln>
         </p:spPr>
-        <p:txBody>
-          <a:bodyPr/>
-          <a:lstStyle/>
-          <a:p>
-            <a:endParaRPr lang="en-US"/>
-          </a:p>
-        </p:txBody>
       </p:sp>
       <p:sp>
         <p:nvSpPr>
@@ -4526,7 +4600,7 @@
           </a:bodyPr>
           <a:lstStyle/>
           <a:p>
-            <a:pPr marL="0" indent="0" algn="l">
+            <a:pPr algn="l" indent="0" marL="0">
               <a:lnSpc>
                 <a:spcPts val="1633"/>
               </a:lnSpc>
@@ -4570,7 +4644,7 @@
           </a:bodyPr>
           <a:lstStyle/>
           <a:p>
-            <a:pPr marL="0" indent="0" algn="l">
+            <a:pPr algn="l" indent="0" marL="0">
               <a:lnSpc>
                 <a:spcPts val="1680"/>
               </a:lnSpc>
@@ -4614,7 +4688,7 @@
           </a:bodyPr>
           <a:lstStyle/>
           <a:p>
-            <a:pPr marL="0" indent="0" algn="l">
+            <a:pPr algn="l" indent="0" marL="0">
               <a:lnSpc>
                 <a:spcPts val="1680"/>
               </a:lnSpc>
@@ -4658,7 +4732,7 @@
           </a:bodyPr>
           <a:lstStyle/>
           <a:p>
-            <a:pPr marL="0" indent="0" algn="r">
+            <a:pPr algn="r" indent="0" marL="0">
               <a:lnSpc>
                 <a:spcPts val="1680"/>
               </a:lnSpc>
@@ -4695,7 +4769,6 @@
         <a:solidFill>
           <a:srgbClr val="0B0B12"/>
         </a:solidFill>
-        <a:effectLst/>
       </p:bgPr>
     </p:bg>
     <p:spTree>
@@ -4735,14 +4808,14 @@
           </a:bodyPr>
           <a:lstStyle/>
           <a:p>
-            <a:pPr marL="0" indent="0" algn="l">
+            <a:pPr algn="l" indent="0" marL="0">
               <a:lnSpc>
                 <a:spcPts val="1820"/>
               </a:lnSpc>
               <a:buNone/>
             </a:pPr>
             <a:r>
-              <a:rPr lang="en-US" sz="1300" b="1" kern="0" spc="150" dirty="0">
+              <a:rPr lang="en-US" sz="1300" b="1" spc="150" kern="0" dirty="0">
                 <a:solidFill>
                   <a:srgbClr val="DE605E"/>
                 </a:solidFill>
@@ -4759,9 +4832,7 @@
       <p:sp>
         <p:nvSpPr>
           <p:cNvPr id="3" name="Text 1"/>
-          <p:cNvSpPr>
-            <a:spLocks noGrp="1"/>
-          </p:cNvSpPr>
+          <p:cNvSpPr/>
           <p:nvPr>
             <p:ph type="title"/>
           </p:nvPr>
@@ -4783,14 +4854,14 @@
           </a:bodyPr>
           <a:lstStyle/>
           <a:p>
-            <a:pPr marL="0" indent="0" algn="l">
+            <a:pPr algn="l" indent="0" marL="0">
               <a:lnSpc>
                 <a:spcPts val="3915"/>
               </a:lnSpc>
               <a:buNone/>
             </a:pPr>
             <a:r>
-              <a:rPr lang="en-US" sz="3729" b="1" i="0" kern="0" spc="-100" dirty="0">
+              <a:rPr lang="en-US" sz="3729" b="1" i="0" spc="-100" kern="0" dirty="0">
                 <a:solidFill>
                   <a:srgbClr val="FAFAF8"/>
                 </a:solidFill>
@@ -4830,13 +4901,6 @@
             <a:prstDash val="solid"/>
           </a:ln>
         </p:spPr>
-        <p:txBody>
-          <a:bodyPr/>
-          <a:lstStyle/>
-          <a:p>
-            <a:endParaRPr lang="en-US"/>
-          </a:p>
-        </p:txBody>
       </p:sp>
       <p:sp>
         <p:nvSpPr>
@@ -4861,14 +4925,14 @@
           </a:bodyPr>
           <a:lstStyle/>
           <a:p>
-            <a:pPr marL="0" indent="0" algn="l">
+            <a:pPr algn="l" indent="0" marL="0">
               <a:lnSpc>
                 <a:spcPts val="1680"/>
               </a:lnSpc>
               <a:buNone/>
             </a:pPr>
             <a:r>
-              <a:rPr lang="en-US" sz="1200" b="1" kern="0" spc="100" dirty="0">
+              <a:rPr lang="en-US" sz="1200" b="1" spc="100" kern="0" dirty="0">
                 <a:solidFill>
                   <a:srgbClr val="879BF4"/>
                 </a:solidFill>
@@ -4905,14 +4969,14 @@
           </a:bodyPr>
           <a:lstStyle/>
           <a:p>
-            <a:pPr marL="0" indent="0" algn="l">
+            <a:pPr algn="l" indent="0" marL="0">
               <a:lnSpc>
                 <a:spcPts val="2640"/>
               </a:lnSpc>
               <a:buNone/>
             </a:pPr>
             <a:r>
-              <a:rPr lang="en-US" sz="2200" b="1" kern="0" spc="-50" dirty="0">
+              <a:rPr lang="en-US" sz="2200" b="1" spc="-50" kern="0" dirty="0">
                 <a:solidFill>
                   <a:srgbClr val="FAFAF8"/>
                 </a:solidFill>
@@ -4949,7 +5013,7 @@
           </a:bodyPr>
           <a:lstStyle/>
           <a:p>
-            <a:pPr marL="0" indent="0" algn="l">
+            <a:pPr algn="l" indent="0" marL="0">
               <a:lnSpc>
                 <a:spcPts val="1755"/>
               </a:lnSpc>
@@ -4993,7 +5057,7 @@
           </a:bodyPr>
           <a:lstStyle/>
           <a:p>
-            <a:pPr marL="0" indent="0" algn="l">
+            <a:pPr algn="l" indent="0" marL="0">
               <a:lnSpc>
                 <a:spcPts val="1755"/>
               </a:lnSpc>
@@ -5040,13 +5104,6 @@
             <a:prstDash val="solid"/>
           </a:ln>
         </p:spPr>
-        <p:txBody>
-          <a:bodyPr/>
-          <a:lstStyle/>
-          <a:p>
-            <a:endParaRPr lang="en-US"/>
-          </a:p>
-        </p:txBody>
       </p:sp>
       <p:sp>
         <p:nvSpPr>
@@ -5071,14 +5128,14 @@
           </a:bodyPr>
           <a:lstStyle/>
           <a:p>
-            <a:pPr marL="0" indent="0" algn="l">
+            <a:pPr algn="l" indent="0" marL="0">
               <a:lnSpc>
                 <a:spcPts val="1680"/>
               </a:lnSpc>
               <a:buNone/>
             </a:pPr>
             <a:r>
-              <a:rPr lang="en-US" sz="1200" b="1" kern="0" spc="100" dirty="0">
+              <a:rPr lang="en-US" sz="1200" b="1" spc="100" kern="0" dirty="0">
                 <a:solidFill>
                   <a:srgbClr val="879BF4"/>
                 </a:solidFill>
@@ -5115,14 +5172,14 @@
           </a:bodyPr>
           <a:lstStyle/>
           <a:p>
-            <a:pPr marL="0" indent="0" algn="l">
+            <a:pPr algn="l" indent="0" marL="0">
               <a:lnSpc>
                 <a:spcPts val="2640"/>
               </a:lnSpc>
               <a:buNone/>
             </a:pPr>
             <a:r>
-              <a:rPr lang="en-US" sz="2200" b="1" kern="0" spc="-50" dirty="0">
+              <a:rPr lang="en-US" sz="2200" b="1" spc="-50" kern="0" dirty="0">
                 <a:solidFill>
                   <a:srgbClr val="FAFAF8"/>
                 </a:solidFill>
@@ -5159,7 +5216,7 @@
           </a:bodyPr>
           <a:lstStyle/>
           <a:p>
-            <a:pPr marL="0" indent="0" algn="l">
+            <a:pPr algn="l" indent="0" marL="0">
               <a:lnSpc>
                 <a:spcPts val="1755"/>
               </a:lnSpc>
@@ -5203,7 +5260,7 @@
           </a:bodyPr>
           <a:lstStyle/>
           <a:p>
-            <a:pPr marL="0" indent="0" algn="l">
+            <a:pPr algn="l" indent="0" marL="0">
               <a:lnSpc>
                 <a:spcPts val="1755"/>
               </a:lnSpc>
@@ -5250,13 +5307,6 @@
             <a:prstDash val="solid"/>
           </a:ln>
         </p:spPr>
-        <p:txBody>
-          <a:bodyPr/>
-          <a:lstStyle/>
-          <a:p>
-            <a:endParaRPr lang="en-US"/>
-          </a:p>
-        </p:txBody>
       </p:sp>
       <p:sp>
         <p:nvSpPr>
@@ -5281,14 +5331,14 @@
           </a:bodyPr>
           <a:lstStyle/>
           <a:p>
-            <a:pPr marL="0" indent="0" algn="l">
+            <a:pPr algn="l" indent="0" marL="0">
               <a:lnSpc>
                 <a:spcPts val="1675"/>
               </a:lnSpc>
               <a:buNone/>
             </a:pPr>
             <a:r>
-              <a:rPr lang="en-US" sz="1196" b="1" kern="0" spc="100" dirty="0">
+              <a:rPr lang="en-US" sz="1196" b="1" spc="100" kern="0" dirty="0">
                 <a:solidFill>
                   <a:srgbClr val="879BF4"/>
                 </a:solidFill>
@@ -5325,14 +5375,14 @@
           </a:bodyPr>
           <a:lstStyle/>
           <a:p>
-            <a:pPr marL="0" indent="0" algn="l">
+            <a:pPr algn="l" indent="0" marL="0">
               <a:lnSpc>
                 <a:spcPts val="2582"/>
               </a:lnSpc>
               <a:buNone/>
             </a:pPr>
             <a:r>
-              <a:rPr lang="en-US" sz="2152" b="1" kern="0" spc="-50" dirty="0">
+              <a:rPr lang="en-US" sz="2152" b="1" spc="-50" kern="0" dirty="0">
                 <a:solidFill>
                   <a:srgbClr val="FAFAF8"/>
                 </a:solidFill>
@@ -5369,7 +5419,7 @@
           </a:bodyPr>
           <a:lstStyle/>
           <a:p>
-            <a:pPr marL="0" indent="0" algn="l">
+            <a:pPr algn="l" indent="0" marL="0">
               <a:lnSpc>
                 <a:spcPts val="1733"/>
               </a:lnSpc>
@@ -5413,7 +5463,7 @@
           </a:bodyPr>
           <a:lstStyle/>
           <a:p>
-            <a:pPr marL="0" indent="0" algn="l">
+            <a:pPr algn="l" indent="0" marL="0">
               <a:lnSpc>
                 <a:spcPts val="1733"/>
               </a:lnSpc>
@@ -5460,13 +5510,6 @@
             <a:prstDash val="solid"/>
           </a:ln>
         </p:spPr>
-        <p:txBody>
-          <a:bodyPr/>
-          <a:lstStyle/>
-          <a:p>
-            <a:endParaRPr lang="en-US"/>
-          </a:p>
-        </p:txBody>
       </p:sp>
       <p:sp>
         <p:nvSpPr>
@@ -5491,7 +5534,7 @@
           </a:bodyPr>
           <a:lstStyle/>
           <a:p>
-            <a:pPr marL="0" indent="0" algn="l">
+            <a:pPr algn="l" indent="0" marL="0">
               <a:lnSpc>
                 <a:spcPts val="2118"/>
               </a:lnSpc>
@@ -5533,13 +5576,6 @@
           </a:solidFill>
           <a:ln/>
         </p:spPr>
-        <p:txBody>
-          <a:bodyPr/>
-          <a:lstStyle/>
-          <a:p>
-            <a:endParaRPr lang="en-US"/>
-          </a:p>
-        </p:txBody>
       </p:sp>
       <p:sp>
         <p:nvSpPr>
@@ -5564,7 +5600,7 @@
           </a:bodyPr>
           <a:lstStyle/>
           <a:p>
-            <a:pPr marL="0" indent="0" algn="l">
+            <a:pPr algn="l" indent="0" marL="0">
               <a:lnSpc>
                 <a:spcPts val="1690"/>
               </a:lnSpc>
@@ -5606,13 +5642,6 @@
           </a:solidFill>
           <a:ln/>
         </p:spPr>
-        <p:txBody>
-          <a:bodyPr/>
-          <a:lstStyle/>
-          <a:p>
-            <a:endParaRPr lang="en-US"/>
-          </a:p>
-        </p:txBody>
       </p:sp>
       <p:sp>
         <p:nvSpPr>
@@ -5637,7 +5666,7 @@
           </a:bodyPr>
           <a:lstStyle/>
           <a:p>
-            <a:pPr marL="0" indent="0" algn="l">
+            <a:pPr algn="l" indent="0" marL="0">
               <a:lnSpc>
                 <a:spcPts val="1690"/>
               </a:lnSpc>
@@ -5652,7 +5681,7 @@
                 <a:ea typeface="Inter" pitchFamily="34" charset="-122"/>
                 <a:cs typeface="Inter" pitchFamily="34" charset="-120"/>
               </a:rPr>
-              <a:t>A baseline agreed first: the revenue target</a:t>
+              <a:t>A baseline agreed first: the CFO’s target</a:t>
             </a:r>
             <a:endParaRPr lang="en-US" sz="1300" dirty="0"/>
           </a:p>
@@ -5679,13 +5708,6 @@
           </a:solidFill>
           <a:ln/>
         </p:spPr>
-        <p:txBody>
-          <a:bodyPr/>
-          <a:lstStyle/>
-          <a:p>
-            <a:endParaRPr lang="en-US"/>
-          </a:p>
-        </p:txBody>
       </p:sp>
       <p:sp>
         <p:nvSpPr>
@@ -5710,7 +5732,7 @@
           </a:bodyPr>
           <a:lstStyle/>
           <a:p>
-            <a:pPr marL="0" indent="0" algn="l">
+            <a:pPr algn="l" indent="0" marL="0">
               <a:lnSpc>
                 <a:spcPts val="1690"/>
               </a:lnSpc>
@@ -5754,7 +5776,7 @@
           </a:bodyPr>
           <a:lstStyle/>
           <a:p>
-            <a:pPr marL="0" indent="0" algn="l">
+            <a:pPr algn="l" indent="0" marL="0">
               <a:lnSpc>
                 <a:spcPts val="1680"/>
               </a:lnSpc>
@@ -5798,7 +5820,7 @@
           </a:bodyPr>
           <a:lstStyle/>
           <a:p>
-            <a:pPr marL="0" indent="0" algn="l">
+            <a:pPr algn="l" indent="0" marL="0">
               <a:lnSpc>
                 <a:spcPts val="1680"/>
               </a:lnSpc>
@@ -5842,7 +5864,7 @@
           </a:bodyPr>
           <a:lstStyle/>
           <a:p>
-            <a:pPr marL="0" indent="0" algn="r">
+            <a:pPr algn="r" indent="0" marL="0">
               <a:lnSpc>
                 <a:spcPts val="1680"/>
               </a:lnSpc>
@@ -5879,7 +5901,6 @@
         <a:solidFill>
           <a:srgbClr val="FAFAF8"/>
         </a:solidFill>
-        <a:effectLst/>
       </p:bgPr>
     </p:bg>
     <p:spTree>
@@ -5919,14 +5940,14 @@
           </a:bodyPr>
           <a:lstStyle/>
           <a:p>
-            <a:pPr marL="0" indent="0" algn="l">
+            <a:pPr algn="l" indent="0" marL="0">
               <a:lnSpc>
                 <a:spcPts val="1820"/>
               </a:lnSpc>
               <a:buNone/>
             </a:pPr>
             <a:r>
-              <a:rPr lang="en-US" sz="1300" b="1" kern="0" spc="150" dirty="0">
+              <a:rPr lang="en-US" sz="1300" b="1" spc="150" kern="0" dirty="0">
                 <a:solidFill>
                   <a:srgbClr val="BC3A21"/>
                 </a:solidFill>
@@ -5943,9 +5964,7 @@
       <p:sp>
         <p:nvSpPr>
           <p:cNvPr id="3" name="Text 1"/>
-          <p:cNvSpPr>
-            <a:spLocks noGrp="1"/>
-          </p:cNvSpPr>
+          <p:cNvSpPr/>
           <p:nvPr>
             <p:ph type="title"/>
           </p:nvPr>
@@ -5967,14 +5986,14 @@
           </a:bodyPr>
           <a:lstStyle/>
           <a:p>
-            <a:pPr marL="0" indent="0" algn="l">
+            <a:pPr algn="l" indent="0" marL="0">
               <a:lnSpc>
                 <a:spcPts val="3990"/>
               </a:lnSpc>
               <a:buNone/>
             </a:pPr>
             <a:r>
-              <a:rPr lang="en-US" sz="3800" b="1" i="0" kern="0" spc="-100" dirty="0">
+              <a:rPr lang="en-US" sz="3800" b="1" i="0" spc="-100" kern="0" dirty="0">
                 <a:solidFill>
                   <a:srgbClr val="0B0B12"/>
                 </a:solidFill>
@@ -5982,7 +6001,7 @@
                 <a:ea typeface="Inter" pitchFamily="34" charset="-122"/>
                 <a:cs typeface="Inter" pitchFamily="34" charset="-120"/>
               </a:rPr>
-              <a:t>The CRO loop</a:t>
+              <a:t>The CRO loop, run on Northwind</a:t>
             </a:r>
             <a:endParaRPr lang="en-US" sz="3800" dirty="0"/>
           </a:p>
@@ -6014,13 +6033,6 @@
             <a:prstDash val="solid"/>
           </a:ln>
         </p:spPr>
-        <p:txBody>
-          <a:bodyPr/>
-          <a:lstStyle/>
-          <a:p>
-            <a:endParaRPr lang="en-US"/>
-          </a:p>
-        </p:txBody>
       </p:sp>
       <p:sp>
         <p:nvSpPr>
@@ -6044,11 +6056,11 @@
                 <a:moveTo>
                   <a:pt x="8487" y="76200"/>
                 </a:moveTo>
-                <a:arcTo wR="120650" hR="120650" stAng="12097096" swAng="4102904"/>
+                <a:arcTo hR="120650" wR="120650" stAng="12097096" swAng="4102904"/>
                 <a:lnTo>
                   <a:pt x="1878310" y="0"/>
                 </a:lnTo>
-                <a:arcTo wR="120650" hR="120650" stAng="16200000" swAng="4102904"/>
+                <a:arcTo hR="120650" wR="120650" stAng="16200000" swAng="4102904"/>
                 <a:close/>
               </a:path>
             </a:pathLst>
@@ -6058,13 +6070,6 @@
           </a:solidFill>
           <a:ln/>
         </p:spPr>
-        <p:txBody>
-          <a:bodyPr/>
-          <a:lstStyle/>
-          <a:p>
-            <a:endParaRPr lang="en-US"/>
-          </a:p>
-        </p:txBody>
       </p:sp>
       <p:sp>
         <p:nvSpPr>
@@ -6089,14 +6094,14 @@
           </a:bodyPr>
           <a:lstStyle/>
           <a:p>
-            <a:pPr marL="0" indent="0" algn="l">
+            <a:pPr algn="l" indent="0" marL="0">
               <a:lnSpc>
                 <a:spcPts val="2640"/>
               </a:lnSpc>
               <a:buNone/>
             </a:pPr>
             <a:r>
-              <a:rPr lang="en-US" sz="2200" b="1" kern="0" spc="-50" dirty="0">
+              <a:rPr lang="en-US" sz="2200" b="1" spc="-50" kern="0" dirty="0">
                 <a:solidFill>
                   <a:srgbClr val="BC3A21"/>
                 </a:solidFill>
@@ -6131,13 +6136,6 @@
           </a:solidFill>
           <a:ln/>
         </p:spPr>
-        <p:txBody>
-          <a:bodyPr/>
-          <a:lstStyle/>
-          <a:p>
-            <a:endParaRPr lang="en-US"/>
-          </a:p>
-        </p:txBody>
       </p:sp>
       <p:sp>
         <p:nvSpPr>
@@ -6160,13 +6158,6 @@
           </a:solidFill>
           <a:ln/>
         </p:spPr>
-        <p:txBody>
-          <a:bodyPr/>
-          <a:lstStyle/>
-          <a:p>
-            <a:endParaRPr lang="en-US"/>
-          </a:p>
-        </p:txBody>
       </p:sp>
       <p:sp>
         <p:nvSpPr>
@@ -6191,7 +6182,7 @@
           </a:bodyPr>
           <a:lstStyle/>
           <a:p>
-            <a:pPr marL="0" indent="0" algn="l">
+            <a:pPr algn="l" indent="0" marL="0">
               <a:lnSpc>
                 <a:spcPts val="1680"/>
               </a:lnSpc>
@@ -6235,7 +6226,7 @@
           </a:bodyPr>
           <a:lstStyle/>
           <a:p>
-            <a:pPr marL="0" indent="0" algn="l">
+            <a:pPr algn="l" indent="0" marL="0">
               <a:lnSpc>
                 <a:spcPts val="1680"/>
               </a:lnSpc>
@@ -6277,13 +6268,6 @@
           </a:solidFill>
           <a:ln/>
         </p:spPr>
-        <p:txBody>
-          <a:bodyPr/>
-          <a:lstStyle/>
-          <a:p>
-            <a:endParaRPr lang="en-US"/>
-          </a:p>
-        </p:txBody>
       </p:sp>
       <p:sp>
         <p:nvSpPr>
@@ -6308,7 +6292,7 @@
           </a:bodyPr>
           <a:lstStyle/>
           <a:p>
-            <a:pPr marL="0" indent="0" algn="l">
+            <a:pPr algn="l" indent="0" marL="0">
               <a:lnSpc>
                 <a:spcPts val="1680"/>
               </a:lnSpc>
@@ -6352,7 +6336,7 @@
           </a:bodyPr>
           <a:lstStyle/>
           <a:p>
-            <a:pPr marL="0" indent="0" algn="l">
+            <a:pPr algn="l" indent="0" marL="0">
               <a:lnSpc>
                 <a:spcPts val="1680"/>
               </a:lnSpc>
@@ -6394,13 +6378,6 @@
           </a:solidFill>
           <a:ln/>
         </p:spPr>
-        <p:txBody>
-          <a:bodyPr/>
-          <a:lstStyle/>
-          <a:p>
-            <a:endParaRPr lang="en-US"/>
-          </a:p>
-        </p:txBody>
       </p:sp>
       <p:sp>
         <p:nvSpPr>
@@ -6425,7 +6402,7 @@
           </a:bodyPr>
           <a:lstStyle/>
           <a:p>
-            <a:pPr marL="0" indent="0" algn="l">
+            <a:pPr algn="l" indent="0" marL="0">
               <a:lnSpc>
                 <a:spcPts val="1680"/>
               </a:lnSpc>
@@ -6469,7 +6446,7 @@
           </a:bodyPr>
           <a:lstStyle/>
           <a:p>
-            <a:pPr marL="0" indent="0" algn="l">
+            <a:pPr algn="l" indent="0" marL="0">
               <a:lnSpc>
                 <a:spcPts val="1680"/>
               </a:lnSpc>
@@ -6513,7 +6490,7 @@
           </a:bodyPr>
           <a:lstStyle/>
           <a:p>
-            <a:pPr marL="0" indent="0" algn="l">
+            <a:pPr algn="l" indent="0" marL="0">
               <a:lnSpc>
                 <a:spcPts val="1750"/>
               </a:lnSpc>
@@ -6557,7 +6534,7 @@
           </a:bodyPr>
           <a:lstStyle/>
           <a:p>
-            <a:pPr marL="0" indent="0" algn="l">
+            <a:pPr algn="l" indent="0" marL="0">
               <a:lnSpc>
                 <a:spcPts val="1620"/>
               </a:lnSpc>
@@ -6615,13 +6592,6 @@
             <a:prstDash val="solid"/>
           </a:ln>
         </p:spPr>
-        <p:txBody>
-          <a:bodyPr/>
-          <a:lstStyle/>
-          <a:p>
-            <a:endParaRPr lang="en-US"/>
-          </a:p>
-        </p:txBody>
       </p:sp>
       <p:sp>
         <p:nvSpPr>
@@ -6645,11 +6615,11 @@
                 <a:moveTo>
                   <a:pt x="8487" y="76200"/>
                 </a:moveTo>
-                <a:arcTo wR="120650" hR="120650" stAng="12097096" swAng="4102904"/>
+                <a:arcTo hR="120650" wR="120650" stAng="12097096" swAng="4102904"/>
                 <a:lnTo>
                   <a:pt x="1878360" y="0"/>
                 </a:lnTo>
-                <a:arcTo wR="120650" hR="120650" stAng="16200000" swAng="4102904"/>
+                <a:arcTo hR="120650" wR="120650" stAng="16200000" swAng="4102904"/>
                 <a:close/>
               </a:path>
             </a:pathLst>
@@ -6659,13 +6629,6 @@
           </a:solidFill>
           <a:ln/>
         </p:spPr>
-        <p:txBody>
-          <a:bodyPr/>
-          <a:lstStyle/>
-          <a:p>
-            <a:endParaRPr lang="en-US"/>
-          </a:p>
-        </p:txBody>
       </p:sp>
       <p:sp>
         <p:nvSpPr>
@@ -6690,14 +6653,14 @@
           </a:bodyPr>
           <a:lstStyle/>
           <a:p>
-            <a:pPr marL="0" indent="0" algn="l">
+            <a:pPr algn="l" indent="0" marL="0">
               <a:lnSpc>
                 <a:spcPts val="2640"/>
               </a:lnSpc>
               <a:buNone/>
             </a:pPr>
             <a:r>
-              <a:rPr lang="en-US" sz="2200" b="1" kern="0" spc="-50" dirty="0">
+              <a:rPr lang="en-US" sz="2200" b="1" spc="-50" kern="0" dirty="0">
                 <a:solidFill>
                   <a:srgbClr val="9E414D"/>
                 </a:solidFill>
@@ -6732,13 +6695,6 @@
           </a:solidFill>
           <a:ln/>
         </p:spPr>
-        <p:txBody>
-          <a:bodyPr/>
-          <a:lstStyle/>
-          <a:p>
-            <a:endParaRPr lang="en-US"/>
-          </a:p>
-        </p:txBody>
       </p:sp>
       <p:sp>
         <p:nvSpPr>
@@ -6761,13 +6717,6 @@
           </a:solidFill>
           <a:ln/>
         </p:spPr>
-        <p:txBody>
-          <a:bodyPr/>
-          <a:lstStyle/>
-          <a:p>
-            <a:endParaRPr lang="en-US"/>
-          </a:p>
-        </p:txBody>
       </p:sp>
       <p:sp>
         <p:nvSpPr>
@@ -6790,13 +6739,6 @@
           </a:solidFill>
           <a:ln/>
         </p:spPr>
-        <p:txBody>
-          <a:bodyPr/>
-          <a:lstStyle/>
-          <a:p>
-            <a:endParaRPr lang="en-US"/>
-          </a:p>
-        </p:txBody>
       </p:sp>
       <p:sp>
         <p:nvSpPr>
@@ -6819,13 +6761,6 @@
           </a:solidFill>
           <a:ln/>
         </p:spPr>
-        <p:txBody>
-          <a:bodyPr/>
-          <a:lstStyle/>
-          <a:p>
-            <a:endParaRPr lang="en-US"/>
-          </a:p>
-        </p:txBody>
       </p:sp>
       <p:sp>
         <p:nvSpPr>
@@ -6848,13 +6783,6 @@
           </a:solidFill>
           <a:ln/>
         </p:spPr>
-        <p:txBody>
-          <a:bodyPr/>
-          <a:lstStyle/>
-          <a:p>
-            <a:endParaRPr lang="en-US"/>
-          </a:p>
-        </p:txBody>
       </p:sp>
       <p:sp>
         <p:nvSpPr>
@@ -6877,13 +6805,6 @@
           </a:solidFill>
           <a:ln/>
         </p:spPr>
-        <p:txBody>
-          <a:bodyPr/>
-          <a:lstStyle/>
-          <a:p>
-            <a:endParaRPr lang="en-US"/>
-          </a:p>
-        </p:txBody>
       </p:sp>
       <p:sp>
         <p:nvSpPr>
@@ -6908,7 +6829,7 @@
           </a:bodyPr>
           <a:lstStyle/>
           <a:p>
-            <a:pPr marL="0" indent="0" algn="l">
+            <a:pPr algn="l" indent="0" marL="0">
               <a:lnSpc>
                 <a:spcPts val="1659"/>
               </a:lnSpc>
@@ -6952,7 +6873,7 @@
           </a:bodyPr>
           <a:lstStyle/>
           <a:p>
-            <a:pPr marL="0" indent="0" algn="l">
+            <a:pPr algn="l" indent="0" marL="0">
               <a:lnSpc>
                 <a:spcPts val="1750"/>
               </a:lnSpc>
@@ -6996,7 +6917,7 @@
           </a:bodyPr>
           <a:lstStyle/>
           <a:p>
-            <a:pPr marL="0" indent="0" algn="l">
+            <a:pPr algn="l" indent="0" marL="0">
               <a:lnSpc>
                 <a:spcPts val="1620"/>
               </a:lnSpc>
@@ -7054,13 +6975,6 @@
             <a:prstDash val="solid"/>
           </a:ln>
         </p:spPr>
-        <p:txBody>
-          <a:bodyPr/>
-          <a:lstStyle/>
-          <a:p>
-            <a:endParaRPr lang="en-US"/>
-          </a:p>
-        </p:txBody>
       </p:sp>
       <p:sp>
         <p:nvSpPr>
@@ -7084,11 +6998,11 @@
                 <a:moveTo>
                   <a:pt x="8487" y="76200"/>
                 </a:moveTo>
-                <a:arcTo wR="120650" hR="120650" stAng="12097096" swAng="4102904"/>
+                <a:arcTo hR="120650" wR="120650" stAng="12097096" swAng="4102904"/>
                 <a:lnTo>
                   <a:pt x="1878310" y="0"/>
                 </a:lnTo>
-                <a:arcTo wR="120650" hR="120650" stAng="16200000" swAng="4102904"/>
+                <a:arcTo hR="120650" wR="120650" stAng="16200000" swAng="4102904"/>
                 <a:close/>
               </a:path>
             </a:pathLst>
@@ -7098,13 +7012,6 @@
           </a:solidFill>
           <a:ln/>
         </p:spPr>
-        <p:txBody>
-          <a:bodyPr/>
-          <a:lstStyle/>
-          <a:p>
-            <a:endParaRPr lang="en-US"/>
-          </a:p>
-        </p:txBody>
       </p:sp>
       <p:sp>
         <p:nvSpPr>
@@ -7129,14 +7036,14 @@
           </a:bodyPr>
           <a:lstStyle/>
           <a:p>
-            <a:pPr marL="0" indent="0" algn="l">
+            <a:pPr algn="l" indent="0" marL="0">
               <a:lnSpc>
                 <a:spcPts val="2640"/>
               </a:lnSpc>
               <a:buNone/>
             </a:pPr>
             <a:r>
-              <a:rPr lang="en-US" sz="2200" b="1" kern="0" spc="-50" dirty="0">
+              <a:rPr lang="en-US" sz="2200" b="1" spc="-50" kern="0" dirty="0">
                 <a:solidFill>
                   <a:srgbClr val="804979"/>
                 </a:solidFill>
@@ -7171,13 +7078,6 @@
           </a:solidFill>
           <a:ln/>
         </p:spPr>
-        <p:txBody>
-          <a:bodyPr/>
-          <a:lstStyle/>
-          <a:p>
-            <a:endParaRPr lang="en-US"/>
-          </a:p>
-        </p:txBody>
       </p:sp>
       <p:sp>
         <p:nvSpPr>
@@ -7202,7 +7102,7 @@
           </a:bodyPr>
           <a:lstStyle/>
           <a:p>
-            <a:pPr marL="0" indent="0" algn="l">
+            <a:pPr algn="l" indent="0" marL="0">
               <a:lnSpc>
                 <a:spcPts val="1409"/>
               </a:lnSpc>
@@ -7244,13 +7144,6 @@
           </a:solidFill>
           <a:ln/>
         </p:spPr>
-        <p:txBody>
-          <a:bodyPr/>
-          <a:lstStyle/>
-          <a:p>
-            <a:endParaRPr lang="en-US"/>
-          </a:p>
-        </p:txBody>
       </p:sp>
       <p:sp>
         <p:nvSpPr>
@@ -7275,7 +7168,7 @@
           </a:bodyPr>
           <a:lstStyle/>
           <a:p>
-            <a:pPr marL="0" indent="0" algn="l">
+            <a:pPr algn="l" indent="0" marL="0">
               <a:lnSpc>
                 <a:spcPts val="1680"/>
               </a:lnSpc>
@@ -7320,13 +7213,6 @@
             <a:prstDash val="solid"/>
           </a:ln>
         </p:spPr>
-        <p:txBody>
-          <a:bodyPr/>
-          <a:lstStyle/>
-          <a:p>
-            <a:endParaRPr lang="en-US"/>
-          </a:p>
-        </p:txBody>
       </p:sp>
       <p:sp>
         <p:nvSpPr>
@@ -7351,7 +7237,7 @@
           </a:bodyPr>
           <a:lstStyle/>
           <a:p>
-            <a:pPr marL="0" indent="0" algn="l">
+            <a:pPr algn="l" indent="0" marL="0">
               <a:lnSpc>
                 <a:spcPts val="1680"/>
               </a:lnSpc>
@@ -7395,7 +7281,7 @@
           </a:bodyPr>
           <a:lstStyle/>
           <a:p>
-            <a:pPr marL="0" indent="0" algn="l">
+            <a:pPr algn="l" indent="0" marL="0">
               <a:lnSpc>
                 <a:spcPts val="1516"/>
               </a:lnSpc>
@@ -7439,7 +7325,7 @@
           </a:bodyPr>
           <a:lstStyle/>
           <a:p>
-            <a:pPr marL="0" indent="0" algn="l">
+            <a:pPr algn="l" indent="0" marL="0">
               <a:lnSpc>
                 <a:spcPts val="1750"/>
               </a:lnSpc>
@@ -7483,7 +7369,7 @@
           </a:bodyPr>
           <a:lstStyle/>
           <a:p>
-            <a:pPr marL="0" indent="0" algn="l">
+            <a:pPr algn="l" indent="0" marL="0">
               <a:lnSpc>
                 <a:spcPts val="1620"/>
               </a:lnSpc>
@@ -7541,13 +7427,6 @@
             <a:prstDash val="solid"/>
           </a:ln>
         </p:spPr>
-        <p:txBody>
-          <a:bodyPr/>
-          <a:lstStyle/>
-          <a:p>
-            <a:endParaRPr lang="en-US"/>
-          </a:p>
-        </p:txBody>
       </p:sp>
       <p:sp>
         <p:nvSpPr>
@@ -7571,11 +7450,11 @@
                 <a:moveTo>
                   <a:pt x="8487" y="76200"/>
                 </a:moveTo>
-                <a:arcTo wR="120650" hR="120650" stAng="12097096" swAng="4102904"/>
+                <a:arcTo hR="120650" wR="120650" stAng="12097096" swAng="4102904"/>
                 <a:lnTo>
                   <a:pt x="1878360" y="0"/>
                 </a:lnTo>
-                <a:arcTo wR="120650" hR="120650" stAng="16200000" swAng="4102904"/>
+                <a:arcTo hR="120650" wR="120650" stAng="16200000" swAng="4102904"/>
                 <a:close/>
               </a:path>
             </a:pathLst>
@@ -7585,13 +7464,6 @@
           </a:solidFill>
           <a:ln/>
         </p:spPr>
-        <p:txBody>
-          <a:bodyPr/>
-          <a:lstStyle/>
-          <a:p>
-            <a:endParaRPr lang="en-US"/>
-          </a:p>
-        </p:txBody>
       </p:sp>
       <p:sp>
         <p:nvSpPr>
@@ -7616,14 +7488,14 @@
           </a:bodyPr>
           <a:lstStyle/>
           <a:p>
-            <a:pPr marL="0" indent="0" algn="l">
+            <a:pPr algn="l" indent="0" marL="0">
               <a:lnSpc>
                 <a:spcPts val="2640"/>
               </a:lnSpc>
               <a:buNone/>
             </a:pPr>
             <a:r>
-              <a:rPr lang="en-US" sz="2200" b="1" kern="0" spc="-50" dirty="0">
+              <a:rPr lang="en-US" sz="2200" b="1" spc="-50" kern="0" dirty="0">
                 <a:solidFill>
                   <a:srgbClr val="6250A6"/>
                 </a:solidFill>
@@ -7658,13 +7530,6 @@
           </a:solidFill>
           <a:ln/>
         </p:spPr>
-        <p:txBody>
-          <a:bodyPr/>
-          <a:lstStyle/>
-          <a:p>
-            <a:endParaRPr lang="en-US"/>
-          </a:p>
-        </p:txBody>
       </p:sp>
       <p:sp>
         <p:nvSpPr>
@@ -7689,7 +7554,7 @@
           </a:bodyPr>
           <a:lstStyle/>
           <a:p>
-            <a:pPr marL="0" indent="0" algn="l">
+            <a:pPr algn="l" indent="0" marL="0">
               <a:lnSpc>
                 <a:spcPts val="1680"/>
               </a:lnSpc>
@@ -7737,7 +7602,7 @@
           </a:bodyPr>
           <a:lstStyle/>
           <a:p>
-            <a:pPr marL="0" indent="0" algn="l">
+            <a:pPr algn="l" indent="0" marL="0">
               <a:lnSpc>
                 <a:spcPts val="1560"/>
               </a:lnSpc>
@@ -7781,7 +7646,7 @@
           </a:bodyPr>
           <a:lstStyle/>
           <a:p>
-            <a:pPr marL="0" indent="0" algn="l">
+            <a:pPr algn="l" indent="0" marL="0">
               <a:lnSpc>
                 <a:spcPts val="1750"/>
               </a:lnSpc>
@@ -7825,7 +7690,7 @@
           </a:bodyPr>
           <a:lstStyle/>
           <a:p>
-            <a:pPr marL="0" indent="0" algn="l">
+            <a:pPr algn="l" indent="0" marL="0">
               <a:lnSpc>
                 <a:spcPts val="1620"/>
               </a:lnSpc>
@@ -7883,13 +7748,6 @@
             <a:prstDash val="solid"/>
           </a:ln>
         </p:spPr>
-        <p:txBody>
-          <a:bodyPr/>
-          <a:lstStyle/>
-          <a:p>
-            <a:endParaRPr lang="en-US"/>
-          </a:p>
-        </p:txBody>
       </p:sp>
       <p:sp>
         <p:nvSpPr>
@@ -7913,11 +7771,11 @@
                 <a:moveTo>
                   <a:pt x="8487" y="76200"/>
                 </a:moveTo>
-                <a:arcTo wR="120650" hR="120650" stAng="12097096" swAng="4102904"/>
+                <a:arcTo hR="120650" wR="120650" stAng="12097096" swAng="4102904"/>
                 <a:lnTo>
                   <a:pt x="1878310" y="0"/>
                 </a:lnTo>
-                <a:arcTo wR="120650" hR="120650" stAng="16200000" swAng="4102904"/>
+                <a:arcTo hR="120650" wR="120650" stAng="16200000" swAng="4102904"/>
                 <a:close/>
               </a:path>
             </a:pathLst>
@@ -7927,13 +7785,6 @@
           </a:solidFill>
           <a:ln/>
         </p:spPr>
-        <p:txBody>
-          <a:bodyPr/>
-          <a:lstStyle/>
-          <a:p>
-            <a:endParaRPr lang="en-US"/>
-          </a:p>
-        </p:txBody>
       </p:sp>
       <p:sp>
         <p:nvSpPr>
@@ -7958,14 +7809,14 @@
           </a:bodyPr>
           <a:lstStyle/>
           <a:p>
-            <a:pPr marL="0" indent="0" algn="l">
+            <a:pPr algn="l" indent="0" marL="0">
               <a:lnSpc>
                 <a:spcPts val="2640"/>
               </a:lnSpc>
               <a:buNone/>
             </a:pPr>
             <a:r>
-              <a:rPr lang="en-US" sz="2200" b="1" kern="0" spc="-50" dirty="0">
+              <a:rPr lang="en-US" sz="2200" b="1" spc="-50" kern="0" dirty="0">
                 <a:solidFill>
                   <a:srgbClr val="4558D2"/>
                 </a:solidFill>
@@ -8000,13 +7851,6 @@
           </a:solidFill>
           <a:ln/>
         </p:spPr>
-        <p:txBody>
-          <a:bodyPr/>
-          <a:lstStyle/>
-          <a:p>
-            <a:endParaRPr lang="en-US"/>
-          </a:p>
-        </p:txBody>
       </p:sp>
       <p:sp>
         <p:nvSpPr>
@@ -8029,13 +7873,6 @@
           </a:solidFill>
           <a:ln/>
         </p:spPr>
-        <p:txBody>
-          <a:bodyPr/>
-          <a:lstStyle/>
-          <a:p>
-            <a:endParaRPr lang="en-US"/>
-          </a:p>
-        </p:txBody>
       </p:sp>
       <p:sp>
         <p:nvSpPr>
@@ -8058,13 +7895,6 @@
           </a:solidFill>
           <a:ln/>
         </p:spPr>
-        <p:txBody>
-          <a:bodyPr/>
-          <a:lstStyle/>
-          <a:p>
-            <a:endParaRPr lang="en-US"/>
-          </a:p>
-        </p:txBody>
       </p:sp>
       <p:sp>
         <p:nvSpPr>
@@ -8087,13 +7917,6 @@
           </a:solidFill>
           <a:ln/>
         </p:spPr>
-        <p:txBody>
-          <a:bodyPr/>
-          <a:lstStyle/>
-          <a:p>
-            <a:endParaRPr lang="en-US"/>
-          </a:p>
-        </p:txBody>
       </p:sp>
       <p:sp>
         <p:nvSpPr>
@@ -8116,13 +7939,6 @@
           </a:solidFill>
           <a:ln/>
         </p:spPr>
-        <p:txBody>
-          <a:bodyPr/>
-          <a:lstStyle/>
-          <a:p>
-            <a:endParaRPr lang="en-US"/>
-          </a:p>
-        </p:txBody>
       </p:sp>
       <p:sp>
         <p:nvSpPr>
@@ -8145,13 +7961,6 @@
           </a:solidFill>
           <a:ln/>
         </p:spPr>
-        <p:txBody>
-          <a:bodyPr/>
-          <a:lstStyle/>
-          <a:p>
-            <a:endParaRPr lang="en-US"/>
-          </a:p>
-        </p:txBody>
       </p:sp>
       <p:sp>
         <p:nvSpPr>
@@ -8176,7 +7985,7 @@
           </a:bodyPr>
           <a:lstStyle/>
           <a:p>
-            <a:pPr marL="0" indent="0" algn="l">
+            <a:pPr algn="l" indent="0" marL="0">
               <a:lnSpc>
                 <a:spcPts val="1560"/>
               </a:lnSpc>
@@ -8220,7 +8029,7 @@
           </a:bodyPr>
           <a:lstStyle/>
           <a:p>
-            <a:pPr marL="0" indent="0" algn="l">
+            <a:pPr algn="l" indent="0" marL="0">
               <a:lnSpc>
                 <a:spcPts val="1750"/>
               </a:lnSpc>
@@ -8264,7 +8073,7 @@
           </a:bodyPr>
           <a:lstStyle/>
           <a:p>
-            <a:pPr marL="0" indent="0" algn="l">
+            <a:pPr algn="l" indent="0" marL="0">
               <a:lnSpc>
                 <a:spcPts val="1620"/>
               </a:lnSpc>
@@ -8319,7 +8128,7 @@
           </a:bodyPr>
           <a:lstStyle/>
           <a:p>
-            <a:pPr marL="0" indent="0" algn="l">
+            <a:pPr algn="l" indent="0" marL="0">
               <a:lnSpc>
                 <a:spcPts val="1680"/>
               </a:lnSpc>
@@ -8363,7 +8172,7 @@
           </a:bodyPr>
           <a:lstStyle/>
           <a:p>
-            <a:pPr marL="0" indent="0" algn="r">
+            <a:pPr algn="r" indent="0" marL="0">
               <a:lnSpc>
                 <a:spcPts val="1680"/>
               </a:lnSpc>
@@ -8400,7 +8209,6 @@
         <a:solidFill>
           <a:srgbClr val="A8331D"/>
         </a:solidFill>
-        <a:effectLst/>
       </p:bgPr>
     </p:bg>
     <p:spTree>
@@ -8450,13 +8258,6 @@
           </a:gradFill>
           <a:ln/>
         </p:spPr>
-        <p:txBody>
-          <a:bodyPr/>
-          <a:lstStyle/>
-          <a:p>
-            <a:endParaRPr lang="en-US"/>
-          </a:p>
-        </p:txBody>
       </p:sp>
       <p:sp>
         <p:nvSpPr>
@@ -8481,14 +8282,14 @@
           </a:bodyPr>
           <a:lstStyle/>
           <a:p>
-            <a:pPr marL="0" indent="0" algn="l">
+            <a:pPr algn="l" indent="0" marL="0">
               <a:lnSpc>
                 <a:spcPts val="1820"/>
               </a:lnSpc>
               <a:buNone/>
             </a:pPr>
             <a:r>
-              <a:rPr lang="en-US" sz="1300" b="1" kern="0" spc="150" dirty="0">
+              <a:rPr lang="en-US" sz="1300" b="1" spc="150" kern="0" dirty="0">
                 <a:solidFill>
                   <a:srgbClr val="879BF4"/>
                 </a:solidFill>
@@ -8505,9 +8306,7 @@
       <p:sp>
         <p:nvSpPr>
           <p:cNvPr id="4" name="Text 2"/>
-          <p:cNvSpPr>
-            <a:spLocks noGrp="1"/>
-          </p:cNvSpPr>
+          <p:cNvSpPr/>
           <p:nvPr>
             <p:ph type="title"/>
           </p:nvPr>
@@ -8529,14 +8328,14 @@
           </a:bodyPr>
           <a:lstStyle/>
           <a:p>
-            <a:pPr marL="0" indent="0" algn="l">
+            <a:pPr algn="l" indent="0" marL="0">
               <a:lnSpc>
                 <a:spcPts val="3815"/>
               </a:lnSpc>
               <a:buNone/>
             </a:pPr>
             <a:r>
-              <a:rPr lang="en-US" sz="3741" b="1" i="0" kern="0" spc="-150" dirty="0">
+              <a:rPr lang="en-US" sz="3741" b="1" i="0" spc="-150" kern="0" dirty="0">
                 <a:solidFill>
                   <a:srgbClr val="FAFAF8"/>
                 </a:solidFill>
@@ -8573,7 +8372,7 @@
           </a:bodyPr>
           <a:lstStyle/>
           <a:p>
-            <a:pPr marL="0" indent="0" algn="l">
+            <a:pPr algn="l" indent="0" marL="0">
               <a:lnSpc>
                 <a:spcPts val="1920"/>
               </a:lnSpc>
@@ -8653,13 +8452,6 @@
             <a:prstDash val="solid"/>
           </a:ln>
         </p:spPr>
-        <p:txBody>
-          <a:bodyPr/>
-          <a:lstStyle/>
-          <a:p>
-            <a:endParaRPr lang="en-US"/>
-          </a:p>
-        </p:txBody>
       </p:sp>
       <p:sp>
         <p:nvSpPr>
@@ -8684,14 +8476,14 @@
           </a:bodyPr>
           <a:lstStyle/>
           <a:p>
-            <a:pPr marL="0" indent="0" algn="l">
+            <a:pPr algn="l" indent="0" marL="0">
               <a:lnSpc>
                 <a:spcPts val="1675"/>
               </a:lnSpc>
               <a:buNone/>
             </a:pPr>
             <a:r>
-              <a:rPr lang="en-US" sz="1196" b="1" kern="0" spc="100" dirty="0">
+              <a:rPr lang="en-US" sz="1196" b="1" spc="100" kern="0" dirty="0">
                 <a:solidFill>
                   <a:srgbClr val="A82813"/>
                 </a:solidFill>
@@ -8728,14 +8520,14 @@
           </a:bodyPr>
           <a:lstStyle/>
           <a:p>
-            <a:pPr marL="0" indent="0" algn="l">
+            <a:pPr algn="l" indent="0" marL="0">
               <a:lnSpc>
                 <a:spcPts val="2119"/>
               </a:lnSpc>
               <a:buNone/>
             </a:pPr>
             <a:r>
-              <a:rPr lang="en-US" sz="1766" b="1" kern="0" spc="-50" dirty="0">
+              <a:rPr lang="en-US" sz="1766" b="1" spc="-50" kern="0" dirty="0">
                 <a:solidFill>
                   <a:srgbClr val="0B0B12"/>
                 </a:solidFill>
@@ -8772,7 +8564,7 @@
           </a:bodyPr>
           <a:lstStyle/>
           <a:p>
-            <a:pPr marL="0" indent="0" algn="l">
+            <a:pPr algn="l" indent="0" marL="0">
               <a:lnSpc>
                 <a:spcPts val="1674"/>
               </a:lnSpc>
@@ -8819,13 +8611,6 @@
             <a:prstDash val="solid"/>
           </a:ln>
         </p:spPr>
-        <p:txBody>
-          <a:bodyPr/>
-          <a:lstStyle/>
-          <a:p>
-            <a:endParaRPr lang="en-US"/>
-          </a:p>
-        </p:txBody>
       </p:sp>
       <p:sp>
         <p:nvSpPr>
@@ -8850,14 +8635,14 @@
           </a:bodyPr>
           <a:lstStyle/>
           <a:p>
-            <a:pPr marL="0" indent="0" algn="l">
+            <a:pPr algn="l" indent="0" marL="0">
               <a:lnSpc>
                 <a:spcPts val="1675"/>
               </a:lnSpc>
               <a:buNone/>
             </a:pPr>
             <a:r>
-              <a:rPr lang="en-US" sz="1196" b="1" kern="0" spc="100" dirty="0">
+              <a:rPr lang="en-US" sz="1196" b="1" spc="100" kern="0" dirty="0">
                 <a:solidFill>
                   <a:srgbClr val="2E3A9E"/>
                 </a:solidFill>
@@ -8894,14 +8679,14 @@
           </a:bodyPr>
           <a:lstStyle/>
           <a:p>
-            <a:pPr marL="0" indent="0" algn="l">
+            <a:pPr algn="l" indent="0" marL="0">
               <a:lnSpc>
                 <a:spcPts val="2119"/>
               </a:lnSpc>
               <a:buNone/>
             </a:pPr>
             <a:r>
-              <a:rPr lang="en-US" sz="1766" b="1" kern="0" spc="-50" dirty="0">
+              <a:rPr lang="en-US" sz="1766" b="1" spc="-50" kern="0" dirty="0">
                 <a:solidFill>
                   <a:srgbClr val="0B0B12"/>
                 </a:solidFill>
@@ -8938,7 +8723,7 @@
           </a:bodyPr>
           <a:lstStyle/>
           <a:p>
-            <a:pPr marL="0" indent="0" algn="l">
+            <a:pPr algn="l" indent="0" marL="0">
               <a:lnSpc>
                 <a:spcPts val="1674"/>
               </a:lnSpc>
@@ -8980,13 +8765,6 @@
           </a:solidFill>
           <a:ln/>
         </p:spPr>
-        <p:txBody>
-          <a:bodyPr/>
-          <a:lstStyle/>
-          <a:p>
-            <a:endParaRPr lang="en-US"/>
-          </a:p>
-        </p:txBody>
       </p:sp>
       <p:sp>
         <p:nvSpPr>
@@ -9013,19 +8791,19 @@
                 <a:lnTo>
                   <a:pt x="101600" y="1666677"/>
                 </a:lnTo>
-                <a:arcTo wR="101600" hR="101600" stAng="5400000" swAng="5400000"/>
+                <a:arcTo hR="101600" wR="101600" stAng="5400000" swAng="5400000"/>
                 <a:lnTo>
                   <a:pt x="0" y="101600"/>
                 </a:lnTo>
-                <a:arcTo wR="101600" hR="101600" stAng="10800000" swAng="5400000"/>
+                <a:arcTo hR="101600" wR="101600" stAng="10800000" swAng="5400000"/>
                 <a:lnTo>
                   <a:pt x="101600" y="0"/>
                 </a:lnTo>
-                <a:arcTo wR="38100" hR="101600" stAng="16200000" swAng="-5400000"/>
+                <a:arcTo hR="101600" wR="38100" stAng="16200000" swAng="-5400000"/>
                 <a:lnTo>
                   <a:pt x="63500" y="1565077"/>
                 </a:lnTo>
-                <a:arcTo wR="38100" hR="101600" stAng="10800000" swAng="-5400000"/>
+                <a:arcTo hR="101600" wR="38100" stAng="10800000" swAng="-5400000"/>
                 <a:close/>
               </a:path>
             </a:pathLst>
@@ -9035,13 +8813,6 @@
           </a:solidFill>
           <a:ln/>
         </p:spPr>
-        <p:txBody>
-          <a:bodyPr/>
-          <a:lstStyle/>
-          <a:p>
-            <a:endParaRPr lang="en-US"/>
-          </a:p>
-        </p:txBody>
       </p:sp>
       <p:sp>
         <p:nvSpPr>
@@ -9066,14 +8837,14 @@
           </a:bodyPr>
           <a:lstStyle/>
           <a:p>
-            <a:pPr marL="0" indent="0" algn="l">
+            <a:pPr algn="l" indent="0" marL="0">
               <a:lnSpc>
                 <a:spcPts val="2321"/>
               </a:lnSpc>
               <a:buNone/>
             </a:pPr>
             <a:r>
-              <a:rPr lang="en-US" sz="1658" b="1" kern="0" spc="-50" dirty="0">
+              <a:rPr lang="en-US" sz="1658" b="1" spc="-50" kern="0" dirty="0">
                 <a:solidFill>
                   <a:srgbClr val="0B0B12"/>
                 </a:solidFill>
@@ -9110,7 +8881,7 @@
           </a:bodyPr>
           <a:lstStyle/>
           <a:p>
-            <a:pPr marL="0" indent="0" algn="l">
+            <a:pPr algn="l" indent="0" marL="0">
               <a:lnSpc>
                 <a:spcPts val="1658"/>
               </a:lnSpc>
@@ -9152,13 +8923,6 @@
           </a:solidFill>
           <a:ln/>
         </p:spPr>
-        <p:txBody>
-          <a:bodyPr/>
-          <a:lstStyle/>
-          <a:p>
-            <a:endParaRPr lang="en-US"/>
-          </a:p>
-        </p:txBody>
       </p:sp>
       <p:sp>
         <p:nvSpPr>
@@ -9183,7 +8947,7 @@
           </a:bodyPr>
           <a:lstStyle/>
           <a:p>
-            <a:pPr marL="0" indent="0" algn="l">
+            <a:pPr algn="l" indent="0" marL="0">
               <a:lnSpc>
                 <a:spcPts val="1500"/>
               </a:lnSpc>
@@ -9231,7 +8995,7 @@
           </a:bodyPr>
           <a:lstStyle/>
           <a:p>
-            <a:pPr marL="0" indent="0" algn="l">
+            <a:pPr algn="l" indent="0" marL="0">
               <a:lnSpc>
                 <a:spcPts val="1500"/>
               </a:lnSpc>
@@ -9279,7 +9043,7 @@
           </a:bodyPr>
           <a:lstStyle/>
           <a:p>
-            <a:pPr marL="0" indent="0" algn="l">
+            <a:pPr algn="l" indent="0" marL="0">
               <a:lnSpc>
                 <a:spcPts val="1500"/>
               </a:lnSpc>
@@ -9327,7 +9091,7 @@
           </a:bodyPr>
           <a:lstStyle/>
           <a:p>
-            <a:pPr marL="0" indent="0" algn="l">
+            <a:pPr algn="l" indent="0" marL="0">
               <a:lnSpc>
                 <a:spcPts val="1500"/>
               </a:lnSpc>
@@ -9376,13 +9140,6 @@
             <a:prstDash val="solid"/>
           </a:ln>
         </p:spPr>
-        <p:txBody>
-          <a:bodyPr/>
-          <a:lstStyle/>
-          <a:p>
-            <a:endParaRPr lang="en-US"/>
-          </a:p>
-        </p:txBody>
       </p:sp>
       <p:sp>
         <p:nvSpPr>
@@ -9407,14 +9164,14 @@
           </a:bodyPr>
           <a:lstStyle/>
           <a:p>
-            <a:pPr marL="0" indent="0" algn="l">
+            <a:pPr algn="l" indent="0" marL="0">
               <a:lnSpc>
                 <a:spcPts val="1675"/>
               </a:lnSpc>
               <a:buNone/>
             </a:pPr>
             <a:r>
-              <a:rPr lang="en-US" sz="1196" b="1" kern="0" spc="100" dirty="0">
+              <a:rPr lang="en-US" sz="1196" b="1" spc="100" kern="0" dirty="0">
                 <a:solidFill>
                   <a:srgbClr val="B9B7C2"/>
                 </a:solidFill>
@@ -9453,19 +9210,19 @@
                 <a:lnTo>
                   <a:pt x="791666" y="0"/>
                 </a:lnTo>
-                <a:arcTo wR="138410" hR="138410" stAng="16200000" swAng="5400000"/>
+                <a:arcTo hR="138410" wR="138410" stAng="16200000" swAng="5400000"/>
                 <a:lnTo>
                   <a:pt x="930077" y="138410"/>
                 </a:lnTo>
-                <a:arcTo wR="138410" hR="138410" stAng="0" swAng="5400000"/>
+                <a:arcTo hR="138410" wR="138410" stAng="0" swAng="5400000"/>
                 <a:lnTo>
                   <a:pt x="138410" y="276820"/>
                 </a:lnTo>
-                <a:arcTo wR="138410" hR="138410" stAng="5400000" swAng="5400000"/>
+                <a:arcTo hR="138410" wR="138410" stAng="5400000" swAng="5400000"/>
                 <a:lnTo>
                   <a:pt x="0" y="138410"/>
                 </a:lnTo>
-                <a:arcTo wR="138410" hR="138410" stAng="10800000" swAng="5400000"/>
+                <a:arcTo hR="138410" wR="138410" stAng="10800000" swAng="5400000"/>
                 <a:close/>
               </a:path>
             </a:pathLst>
@@ -9484,7 +9241,7 @@
           </a:bodyPr>
           <a:lstStyle/>
           <a:p>
-            <a:pPr marL="0" indent="0" algn="ctr">
+            <a:pPr algn="ctr" indent="0" marL="0">
               <a:lnSpc>
                 <a:spcPts val="1680"/>
               </a:lnSpc>
@@ -9530,19 +9287,19 @@
                 <a:lnTo>
                   <a:pt x="872927" y="0"/>
                 </a:lnTo>
-                <a:arcTo wR="138410" hR="138410" stAng="16200000" swAng="5400000"/>
+                <a:arcTo hR="138410" wR="138410" stAng="16200000" swAng="5400000"/>
                 <a:lnTo>
                   <a:pt x="1011337" y="138410"/>
                 </a:lnTo>
-                <a:arcTo wR="138410" hR="138410" stAng="0" swAng="5400000"/>
+                <a:arcTo hR="138410" wR="138410" stAng="0" swAng="5400000"/>
                 <a:lnTo>
                   <a:pt x="138410" y="276820"/>
                 </a:lnTo>
-                <a:arcTo wR="138410" hR="138410" stAng="5400000" swAng="5400000"/>
+                <a:arcTo hR="138410" wR="138410" stAng="5400000" swAng="5400000"/>
                 <a:lnTo>
                   <a:pt x="0" y="138410"/>
                 </a:lnTo>
-                <a:arcTo wR="138410" hR="138410" stAng="10800000" swAng="5400000"/>
+                <a:arcTo hR="138410" wR="138410" stAng="10800000" swAng="5400000"/>
                 <a:close/>
               </a:path>
             </a:pathLst>
@@ -9561,7 +9318,7 @@
           </a:bodyPr>
           <a:lstStyle/>
           <a:p>
-            <a:pPr marL="0" indent="0" algn="ctr">
+            <a:pPr algn="ctr" indent="0" marL="0">
               <a:lnSpc>
                 <a:spcPts val="1680"/>
               </a:lnSpc>
@@ -9607,19 +9364,19 @@
                 <a:lnTo>
                   <a:pt x="1437779" y="0"/>
                 </a:lnTo>
-                <a:arcTo wR="138410" hR="138410" stAng="16200000" swAng="5400000"/>
+                <a:arcTo hR="138410" wR="138410" stAng="16200000" swAng="5400000"/>
                 <a:lnTo>
                   <a:pt x="1576189" y="138410"/>
                 </a:lnTo>
-                <a:arcTo wR="138410" hR="138410" stAng="0" swAng="5400000"/>
+                <a:arcTo hR="138410" wR="138410" stAng="0" swAng="5400000"/>
                 <a:lnTo>
                   <a:pt x="138410" y="276820"/>
                 </a:lnTo>
-                <a:arcTo wR="138410" hR="138410" stAng="5400000" swAng="5400000"/>
+                <a:arcTo hR="138410" wR="138410" stAng="5400000" swAng="5400000"/>
                 <a:lnTo>
                   <a:pt x="0" y="138410"/>
                 </a:lnTo>
-                <a:arcTo wR="138410" hR="138410" stAng="10800000" swAng="5400000"/>
+                <a:arcTo hR="138410" wR="138410" stAng="10800000" swAng="5400000"/>
                 <a:close/>
               </a:path>
             </a:pathLst>
@@ -9638,7 +9395,7 @@
           </a:bodyPr>
           <a:lstStyle/>
           <a:p>
-            <a:pPr marL="0" indent="0" algn="ctr">
+            <a:pPr algn="ctr" indent="0" marL="0">
               <a:lnSpc>
                 <a:spcPts val="1680"/>
               </a:lnSpc>
@@ -9661,13 +9418,90 @@
       </p:sp>
       <p:sp>
         <p:nvSpPr>
+          <p:cNvPr id="28" name="Text 26"/>
+          <p:cNvSpPr/>
+          <p:nvPr/>
+        </p:nvSpPr>
+        <p:spPr>
+          <a:xfrm>
+            <a:off x="4724102" y="5457775"/>
+            <a:ext cx="1325116" cy="276820"/>
+          </a:xfrm>
+          <a:custGeom>
+            <a:avLst/>
+            <a:gdLst/>
+            <a:ahLst/>
+            <a:cxnLst/>
+            <a:rect l="l" t="t" r="r" b="b"/>
+            <a:pathLst>
+              <a:path w="1325116" h="276820">
+                <a:moveTo>
+                  <a:pt x="138410" y="0"/>
+                </a:moveTo>
+                <a:lnTo>
+                  <a:pt x="1186706" y="0"/>
+                </a:lnTo>
+                <a:arcTo hR="138410" wR="138410" stAng="16200000" swAng="5400000"/>
+                <a:lnTo>
+                  <a:pt x="1325116" y="138410"/>
+                </a:lnTo>
+                <a:arcTo hR="138410" wR="138410" stAng="0" swAng="5400000"/>
+                <a:lnTo>
+                  <a:pt x="138410" y="276820"/>
+                </a:lnTo>
+                <a:arcTo hR="138410" wR="138410" stAng="5400000" swAng="5400000"/>
+                <a:lnTo>
+                  <a:pt x="0" y="138410"/>
+                </a:lnTo>
+                <a:arcTo hR="138410" wR="138410" stAng="10800000" swAng="5400000"/>
+                <a:close/>
+              </a:path>
+            </a:pathLst>
+          </a:custGeom>
+          <a:noFill/>
+          <a:ln w="12700">
+            <a:solidFill>
+              <a:srgbClr val="6E6B75"/>
+            </a:solidFill>
+            <a:prstDash val="solid"/>
+          </a:ln>
+        </p:spPr>
+        <p:txBody>
+          <a:bodyPr wrap="none" lIns="0" tIns="0" rIns="0" bIns="0" rtlCol="0" anchor="ctr">
+            <a:normAutofit/>
+          </a:bodyPr>
+          <a:lstStyle/>
+          <a:p>
+            <a:pPr algn="ctr" indent="0" marL="0">
+              <a:lnSpc>
+                <a:spcPts val="1680"/>
+              </a:lnSpc>
+              <a:buNone/>
+            </a:pPr>
+            <a:r>
+              <a:rPr lang="en-US" sz="1200" b="1" dirty="0">
+                <a:solidFill>
+                  <a:srgbClr val="B9B7C2"/>
+                </a:solidFill>
+                <a:latin typeface="Inter" pitchFamily="34" charset="0"/>
+                <a:ea typeface="Inter" pitchFamily="34" charset="-122"/>
+                <a:cs typeface="Inter" pitchFamily="34" charset="-120"/>
+              </a:rPr>
+              <a:t>Konica Minolta</a:t>
+            </a:r>
+            <a:endParaRPr lang="en-US" sz="1200" dirty="0"/>
+          </a:p>
+        </p:txBody>
+      </p:sp>
+      <p:sp>
+        <p:nvSpPr>
           <p:cNvPr id="29" name="Text 27"/>
           <p:cNvSpPr/>
           <p:nvPr/>
         </p:nvSpPr>
         <p:spPr>
           <a:xfrm>
-            <a:off x="4724101" y="5469181"/>
+            <a:off x="6125418" y="5457775"/>
             <a:ext cx="1023045" cy="276820"/>
           </a:xfrm>
           <a:custGeom>
@@ -9684,19 +9518,19 @@
                 <a:lnTo>
                   <a:pt x="884634" y="0"/>
                 </a:lnTo>
-                <a:arcTo wR="138410" hR="138410" stAng="16200000" swAng="5400000"/>
+                <a:arcTo hR="138410" wR="138410" stAng="16200000" swAng="5400000"/>
                 <a:lnTo>
                   <a:pt x="1023045" y="138410"/>
                 </a:lnTo>
-                <a:arcTo wR="138410" hR="138410" stAng="0" swAng="5400000"/>
+                <a:arcTo hR="138410" wR="138410" stAng="0" swAng="5400000"/>
                 <a:lnTo>
                   <a:pt x="138410" y="276820"/>
                 </a:lnTo>
-                <a:arcTo wR="138410" hR="138410" stAng="5400000" swAng="5400000"/>
+                <a:arcTo hR="138410" wR="138410" stAng="5400000" swAng="5400000"/>
                 <a:lnTo>
                   <a:pt x="0" y="138410"/>
                 </a:lnTo>
-                <a:arcTo wR="138410" hR="138410" stAng="10800000" swAng="5400000"/>
+                <a:arcTo hR="138410" wR="138410" stAng="10800000" swAng="5400000"/>
                 <a:close/>
               </a:path>
             </a:pathLst>
@@ -9715,7 +9549,7 @@
           </a:bodyPr>
           <a:lstStyle/>
           <a:p>
-            <a:pPr marL="0" indent="0" algn="ctr">
+            <a:pPr algn="ctr" indent="0" marL="0">
               <a:lnSpc>
                 <a:spcPts val="1680"/>
               </a:lnSpc>
@@ -9744,7 +9578,7 @@
         </p:nvSpPr>
         <p:spPr>
           <a:xfrm>
-            <a:off x="5823346" y="5469181"/>
+            <a:off x="7224663" y="5457775"/>
             <a:ext cx="775791" cy="276820"/>
           </a:xfrm>
           <a:custGeom>
@@ -9761,19 +9595,19 @@
                 <a:lnTo>
                   <a:pt x="637381" y="0"/>
                 </a:lnTo>
-                <a:arcTo wR="138410" hR="138410" stAng="16200000" swAng="5400000"/>
+                <a:arcTo hR="138410" wR="138410" stAng="16200000" swAng="5400000"/>
                 <a:lnTo>
                   <a:pt x="775791" y="138410"/>
                 </a:lnTo>
-                <a:arcTo wR="138410" hR="138410" stAng="0" swAng="5400000"/>
+                <a:arcTo hR="138410" wR="138410" stAng="0" swAng="5400000"/>
                 <a:lnTo>
                   <a:pt x="138410" y="276820"/>
                 </a:lnTo>
-                <a:arcTo wR="138410" hR="138410" stAng="5400000" swAng="5400000"/>
+                <a:arcTo hR="138410" wR="138410" stAng="5400000" swAng="5400000"/>
                 <a:lnTo>
                   <a:pt x="0" y="138410"/>
                 </a:lnTo>
-                <a:arcTo wR="138410" hR="138410" stAng="10800000" swAng="5400000"/>
+                <a:arcTo hR="138410" wR="138410" stAng="10800000" swAng="5400000"/>
                 <a:close/>
               </a:path>
             </a:pathLst>
@@ -9792,7 +9626,7 @@
           </a:bodyPr>
           <a:lstStyle/>
           <a:p>
-            <a:pPr marL="0" indent="0" algn="ctr">
+            <a:pPr algn="ctr" indent="0" marL="0">
               <a:lnSpc>
                 <a:spcPts val="1680"/>
               </a:lnSpc>
@@ -9821,7 +9655,7 @@
         </p:nvSpPr>
         <p:spPr>
           <a:xfrm>
-            <a:off x="6675337" y="5469181"/>
+            <a:off x="8076654" y="5457775"/>
             <a:ext cx="505371" cy="276820"/>
           </a:xfrm>
           <a:custGeom>
@@ -9838,19 +9672,19 @@
                 <a:lnTo>
                   <a:pt x="366961" y="0"/>
                 </a:lnTo>
-                <a:arcTo wR="138410" hR="138410" stAng="16200000" swAng="5400000"/>
+                <a:arcTo hR="138410" wR="138410" stAng="16200000" swAng="5400000"/>
                 <a:lnTo>
                   <a:pt x="505371" y="138410"/>
                 </a:lnTo>
-                <a:arcTo wR="138410" hR="138410" stAng="0" swAng="5400000"/>
+                <a:arcTo hR="138410" wR="138410" stAng="0" swAng="5400000"/>
                 <a:lnTo>
                   <a:pt x="138410" y="276820"/>
                 </a:lnTo>
-                <a:arcTo wR="138410" hR="138410" stAng="5400000" swAng="5400000"/>
+                <a:arcTo hR="138410" wR="138410" stAng="5400000" swAng="5400000"/>
                 <a:lnTo>
                   <a:pt x="0" y="138410"/>
                 </a:lnTo>
-                <a:arcTo wR="138410" hR="138410" stAng="10800000" swAng="5400000"/>
+                <a:arcTo hR="138410" wR="138410" stAng="10800000" swAng="5400000"/>
                 <a:close/>
               </a:path>
             </a:pathLst>
@@ -9869,7 +9703,7 @@
           </a:bodyPr>
           <a:lstStyle/>
           <a:p>
-            <a:pPr marL="0" indent="0" algn="ctr">
+            <a:pPr algn="ctr" indent="0" marL="0">
               <a:lnSpc>
                 <a:spcPts val="1680"/>
               </a:lnSpc>
@@ -9898,7 +9732,7 @@
         </p:nvSpPr>
         <p:spPr>
           <a:xfrm>
-            <a:off x="7256908" y="5469181"/>
+            <a:off x="8658225" y="5457775"/>
             <a:ext cx="905570" cy="276820"/>
           </a:xfrm>
           <a:custGeom>
@@ -9915,19 +9749,19 @@
                 <a:lnTo>
                   <a:pt x="767159" y="0"/>
                 </a:lnTo>
-                <a:arcTo wR="138410" hR="138410" stAng="16200000" swAng="5400000"/>
+                <a:arcTo hR="138410" wR="138410" stAng="16200000" swAng="5400000"/>
                 <a:lnTo>
                   <a:pt x="905570" y="138410"/>
                 </a:lnTo>
-                <a:arcTo wR="138410" hR="138410" stAng="0" swAng="5400000"/>
+                <a:arcTo hR="138410" wR="138410" stAng="0" swAng="5400000"/>
                 <a:lnTo>
                   <a:pt x="138410" y="276820"/>
                 </a:lnTo>
-                <a:arcTo wR="138410" hR="138410" stAng="5400000" swAng="5400000"/>
+                <a:arcTo hR="138410" wR="138410" stAng="5400000" swAng="5400000"/>
                 <a:lnTo>
                   <a:pt x="0" y="138410"/>
                 </a:lnTo>
-                <a:arcTo wR="138410" hR="138410" stAng="10800000" swAng="5400000"/>
+                <a:arcTo hR="138410" wR="138410" stAng="10800000" swAng="5400000"/>
                 <a:close/>
               </a:path>
             </a:pathLst>
@@ -9946,7 +9780,7 @@
           </a:bodyPr>
           <a:lstStyle/>
           <a:p>
-            <a:pPr marL="0" indent="0" algn="ctr">
+            <a:pPr algn="ctr" indent="0" marL="0">
               <a:lnSpc>
                 <a:spcPts val="1680"/>
               </a:lnSpc>
@@ -9990,7 +9824,7 @@
           </a:bodyPr>
           <a:lstStyle/>
           <a:p>
-            <a:pPr marL="0" indent="0" algn="l">
+            <a:pPr algn="l" indent="0" marL="0">
               <a:lnSpc>
                 <a:spcPts val="1680"/>
               </a:lnSpc>
@@ -10034,7 +9868,7 @@
           </a:bodyPr>
           <a:lstStyle/>
           <a:p>
-            <a:pPr marL="0" indent="0" algn="r">
+            <a:pPr algn="r" indent="0" marL="0">
               <a:lnSpc>
                 <a:spcPts val="1680"/>
               </a:lnSpc>
@@ -10050,6 +9884,294 @@
                 <a:cs typeface="Inter" pitchFamily="34" charset="-120"/>
               </a:rPr>
               <a:t>6</a:t>
+            </a:r>
+            <a:endParaRPr lang="en-US" sz="1200" dirty="0"/>
+          </a:p>
+        </p:txBody>
+      </p:sp>
+    </p:spTree>
+  </p:cSld>
+  <p:clrMapOvr>
+    <a:masterClrMapping/>
+  </p:clrMapOvr>
+</p:sld>
+</file>
+
+<file path=ppt/slides/slide7.xml><?xml version="1.0" encoding="utf-8"?>
+<p:sld xmlns:a="http://schemas.openxmlformats.org/drawingml/2006/main" xmlns:r="http://schemas.openxmlformats.org/officeDocument/2006/relationships" xmlns:p="http://schemas.openxmlformats.org/presentationml/2006/main">
+  <p:cSld name="Slide 1">
+    <p:bg>
+      <p:bgPr>
+        <a:solidFill>
+          <a:srgbClr val="BA3920"/>
+        </a:solidFill>
+      </p:bgPr>
+    </p:bg>
+    <p:spTree>
+      <p:nvGrpSpPr>
+        <p:cNvPr id="1" name=""/>
+        <p:cNvGrpSpPr/>
+        <p:nvPr/>
+      </p:nvGrpSpPr>
+      <p:grpSpPr>
+        <a:xfrm>
+          <a:off x="0" y="0"/>
+          <a:ext cx="0" cy="0"/>
+          <a:chOff x="0" y="0"/>
+          <a:chExt cx="0" cy="0"/>
+        </a:xfrm>
+      </p:grpSpPr>
+      <p:sp>
+        <p:nvSpPr>
+          <p:cNvPr id="2" name="Shape 0"/>
+          <p:cNvSpPr/>
+          <p:nvPr/>
+        </p:nvSpPr>
+        <p:spPr>
+          <a:xfrm>
+            <a:off x="0" y="0"/>
+            <a:ext cx="12192000" cy="6858000"/>
+          </a:xfrm>
+          <a:prstGeom prst="rect">
+            <a:avLst/>
+          </a:prstGeom>
+          <a:gradFill rotWithShape="1">
+            <a:gsLst>
+              <a:gs pos="0">
+                <a:srgbClr val="BA3920"/>
+              </a:gs>
+              <a:gs pos="42000">
+                <a:srgbClr val="130F14"/>
+              </a:gs>
+              <a:gs pos="62000">
+                <a:srgbClr val="131319"/>
+              </a:gs>
+              <a:gs pos="100000">
+                <a:srgbClr val="4558D2"/>
+              </a:gs>
+            </a:gsLst>
+            <a:lin ang="2100000" scaled="0"/>
+          </a:gradFill>
+          <a:ln/>
+        </p:spPr>
+      </p:sp>
+      <p:sp>
+        <p:nvSpPr>
+          <p:cNvPr id="2" name="Title kicker"/>
+          <p:cNvSpPr/>
+          <p:nvPr/>
+        </p:nvSpPr>
+        <p:spPr>
+          <a:xfrm>
+            <a:off x="812800" y="812800"/>
+            <a:ext cx="10883392" cy="256530"/>
+          </a:xfrm>
+          <a:prstGeom prst="rect">
+            <a:avLst/>
+          </a:prstGeom>
+          <a:noFill/>
+          <a:ln/>
+        </p:spPr>
+        <p:txBody>
+          <a:bodyPr wrap="square" lIns="0" tIns="0" rIns="0" bIns="0" rtlCol="0" anchor="t">
+            <a:normAutofit/>
+          </a:bodyPr>
+          <a:lstStyle/>
+          <a:p>
+            <a:pPr algn="l" indent="0" marL="0">
+              <a:lnSpc>
+                <a:spcPts val="1820"/>
+              </a:lnSpc>
+              <a:buNone/>
+            </a:pPr>
+            <a:r>
+              <a:rPr lang="en-US" sz="1300" b="1" spc="150" kern="0" dirty="0">
+                <a:solidFill>
+                  <a:srgbClr val="879BF4"/>
+                </a:solidFill>
+                <a:latin typeface="Inter" pitchFamily="34" charset="0"/>
+                <a:ea typeface="Inter" pitchFamily="34" charset="-122"/>
+                <a:cs typeface="Inter" pitchFamily="34" charset="-120"/>
+              </a:rPr>
+              <a:t>DATABOOK PANEL · MOCK ENGAGEMENT</a:t>
+            </a:r>
+            <a:endParaRPr lang="en-US" sz="1300" dirty="0"/>
+          </a:p>
+        </p:txBody>
+      </p:sp>
+      <p:sp>
+        <p:nvSpPr>
+          <p:cNvPr id="3" name="Title"/>
+          <p:cNvSpPr/>
+          <p:nvPr>
+            <p:ph type="title"/>
+          </p:nvPr>
+        </p:nvSpPr>
+        <p:spPr>
+          <a:xfrm>
+            <a:off x="812800" y="1900000"/>
+            <a:ext cx="10883392" cy="1500000"/>
+          </a:xfrm>
+          <a:prstGeom prst="rect">
+            <a:avLst/>
+          </a:prstGeom>
+          <a:noFill/>
+          <a:ln/>
+        </p:spPr>
+        <p:txBody>
+          <a:bodyPr wrap="square" lIns="0" tIns="0" rIns="0" bIns="0" rtlCol="0" anchor="t">
+            <a:normAutofit/>
+          </a:bodyPr>
+          <a:lstStyle/>
+          <a:p>
+            <a:pPr algn="l" indent="0" marL="0">
+              <a:lnSpc>
+                <a:spcPts val="3990"/>
+              </a:lnSpc>
+              <a:buNone/>
+            </a:pPr>
+            <a:r>
+              <a:rPr lang="en-US" sz="4400" b="1" i="0" spc="-100" kern="0" dirty="0">
+                <a:solidFill>
+                  <a:srgbClr val="FAFAF8"/>
+                </a:solidFill>
+                <a:latin typeface="Inter" pitchFamily="34" charset="0"/>
+                <a:ea typeface="Inter" pitchFamily="34" charset="-122"/>
+                <a:cs typeface="Inter" pitchFamily="34" charset="-120"/>
+              </a:rPr>
+              <a:t>AI Sales Transformation for Zoom</a:t>
+            </a:r>
+            <a:endParaRPr lang="en-US" sz="4400" dirty="0"/>
+          </a:p>
+        </p:txBody>
+      </p:sp>
+      <p:sp>
+        <p:nvSpPr>
+          <p:cNvPr id="4" name="Subtitle"/>
+          <p:cNvSpPr/>
+          <p:nvPr/>
+        </p:nvSpPr>
+        <p:spPr>
+          <a:xfrm>
+            <a:off x="812800" y="3500000"/>
+            <a:ext cx="10883392" cy="520000"/>
+          </a:xfrm>
+          <a:prstGeom prst="rect">
+            <a:avLst/>
+          </a:prstGeom>
+          <a:noFill/>
+          <a:ln/>
+        </p:spPr>
+        <p:txBody>
+          <a:bodyPr wrap="square" lIns="0" tIns="0" rIns="0" bIns="0" rtlCol="0" anchor="t">
+            <a:normAutofit/>
+          </a:bodyPr>
+          <a:lstStyle/>
+          <a:p>
+            <a:pPr algn="l" indent="0" marL="0">
+              <a:lnSpc>
+                <a:spcPts val="1820"/>
+              </a:lnSpc>
+              <a:buNone/>
+            </a:pPr>
+            <a:r>
+              <a:rPr lang="en-US" sz="2200" b="1" spc="150" kern="0" dirty="0">
+                <a:solidFill>
+                  <a:srgbClr val="FAFAF8"/>
+                </a:solidFill>
+                <a:latin typeface="Inter" pitchFamily="34" charset="0"/>
+                <a:ea typeface="Inter" pitchFamily="34" charset="-122"/>
+                <a:cs typeface="Inter" pitchFamily="34" charset="-120"/>
+              </a:rPr>
+              <a:t>A decision system for the CRO, run on one account, with Databook</a:t>
+            </a:r>
+            <a:endParaRPr lang="en-US" sz="2200" dirty="0"/>
+          </a:p>
+        </p:txBody>
+      </p:sp>
+      <p:sp>
+        <p:nvSpPr>
+          <p:cNvPr id="5" name="Five steps"/>
+          <p:cNvSpPr/>
+          <p:nvPr/>
+        </p:nvSpPr>
+        <p:spPr>
+          <a:xfrm>
+            <a:off x="812800" y="4300000"/>
+            <a:ext cx="10883392" cy="400000"/>
+          </a:xfrm>
+          <a:prstGeom prst="rect">
+            <a:avLst/>
+          </a:prstGeom>
+          <a:noFill/>
+          <a:ln/>
+        </p:spPr>
+        <p:txBody>
+          <a:bodyPr wrap="square" lIns="0" tIns="0" rIns="0" bIns="0" rtlCol="0" anchor="t">
+            <a:normAutofit/>
+          </a:bodyPr>
+          <a:lstStyle/>
+          <a:p>
+            <a:pPr algn="l" indent="0" marL="0">
+              <a:lnSpc>
+                <a:spcPts val="1820"/>
+              </a:lnSpc>
+              <a:buNone/>
+            </a:pPr>
+            <a:r>
+              <a:rPr lang="en-US" sz="1600" b="1" spc="150" kern="0" dirty="0">
+                <a:solidFill>
+                  <a:srgbClr val="879BF4"/>
+                </a:solidFill>
+                <a:latin typeface="Inter" pitchFamily="34" charset="0"/>
+                <a:ea typeface="Inter" pitchFamily="34" charset="-122"/>
+                <a:cs typeface="Inter" pitchFamily="34" charset="-120"/>
+              </a:rPr>
+              <a:t>SEE  ·  FIND  ·  DECIDE  ·  GUIDE  ·  PROVE</a:t>
+            </a:r>
+            <a:endParaRPr lang="en-US" sz="1600" dirty="0"/>
+          </a:p>
+        </p:txBody>
+      </p:sp>
+      <p:sp>
+        <p:nvSpPr>
+          <p:cNvPr id="6" name="Title footer"/>
+          <p:cNvSpPr/>
+          <p:nvPr/>
+        </p:nvSpPr>
+        <p:spPr>
+          <a:xfrm>
+            <a:off x="812800" y="6238280"/>
+            <a:ext cx="10566400" cy="238720"/>
+          </a:xfrm>
+          <a:prstGeom prst="rect">
+            <a:avLst/>
+          </a:prstGeom>
+          <a:noFill/>
+          <a:ln/>
+        </p:spPr>
+        <p:txBody>
+          <a:bodyPr wrap="square" lIns="0" tIns="0" rIns="0" bIns="0" rtlCol="0" anchor="t">
+            <a:normAutofit/>
+          </a:bodyPr>
+          <a:lstStyle/>
+          <a:p>
+            <a:pPr algn="l" indent="0" marL="0">
+              <a:lnSpc>
+                <a:spcPts val="1680"/>
+              </a:lnSpc>
+              <a:buNone/>
+            </a:pPr>
+            <a:r>
+              <a:rPr lang="en-US" sz="1200" dirty="0">
+                <a:solidFill>
+                  <a:srgbClr val="D5D3DE"/>
+                </a:solidFill>
+                <a:latin typeface="Inter" pitchFamily="34" charset="0"/>
+                <a:ea typeface="Inter" pitchFamily="34" charset="-122"/>
+                <a:cs typeface="Inter" pitchFamily="34" charset="-120"/>
+              </a:rPr>
+              <a:t>All account data is synthetic. Only Zoom’s reported revenue and guidance are real.</a:t>
             </a:r>
             <a:endParaRPr lang="en-US" sz="1200" dirty="0"/>
           </a:p>
@@ -10351,319 +10473,4 @@
   <a:objectDefaults/>
   <a:extraClrSchemeLst/>
 </a:theme>
-</file>
-
-<file path=ppt/theme/theme2.xml><?xml version="1.0" encoding="utf-8"?>
-<a:theme xmlns:a="http://schemas.openxmlformats.org/drawingml/2006/main" name="Office Theme">
-  <a:themeElements>
-    <a:clrScheme name="Office">
-      <a:dk1>
-        <a:sysClr val="windowText" lastClr="000000"/>
-      </a:dk1>
-      <a:lt1>
-        <a:sysClr val="window" lastClr="FFFFFF"/>
-      </a:lt1>
-      <a:dk2>
-        <a:srgbClr val="0E2841"/>
-      </a:dk2>
-      <a:lt2>
-        <a:srgbClr val="E8E8E8"/>
-      </a:lt2>
-      <a:accent1>
-        <a:srgbClr val="156082"/>
-      </a:accent1>
-      <a:accent2>
-        <a:srgbClr val="E97132"/>
-      </a:accent2>
-      <a:accent3>
-        <a:srgbClr val="196B24"/>
-      </a:accent3>
-      <a:accent4>
-        <a:srgbClr val="0F9ED5"/>
-      </a:accent4>
-      <a:accent5>
-        <a:srgbClr val="A02B93"/>
-      </a:accent5>
-      <a:accent6>
-        <a:srgbClr val="4EA72E"/>
-      </a:accent6>
-      <a:hlink>
-        <a:srgbClr val="467886"/>
-      </a:hlink>
-      <a:folHlink>
-        <a:srgbClr val="96607D"/>
-      </a:folHlink>
-    </a:clrScheme>
-    <a:fontScheme name="Office">
-      <a:majorFont>
-        <a:latin typeface="Aptos Display" panose="02110004020202020204"/>
-        <a:ea typeface=""/>
-        <a:cs typeface=""/>
-        <a:font script="Jpan" typeface="游ゴシック Light"/>
-        <a:font script="Hang" typeface="맑은 고딕"/>
-        <a:font script="Hans" typeface="等线 Light"/>
-        <a:font script="Hant" typeface="新細明體"/>
-        <a:font script="Arab" typeface="Times New Roman"/>
-        <a:font script="Hebr" typeface="Times New Roman"/>
-        <a:font script="Thai" typeface="Angsana New"/>
-        <a:font script="Ethi" typeface="Nyala"/>
-        <a:font script="Beng" typeface="Vrinda"/>
-        <a:font script="Gujr" typeface="Shruti"/>
-        <a:font script="Khmr" typeface="MoolBoran"/>
-        <a:font script="Knda" typeface="Tunga"/>
-        <a:font script="Guru" typeface="Raavi"/>
-        <a:font script="Cans" typeface="Euphemia"/>
-        <a:font script="Cher" typeface="Plantagenet Cherokee"/>
-        <a:font script="Yiii" typeface="Microsoft Yi Baiti"/>
-        <a:font script="Tibt" typeface="Microsoft Himalaya"/>
-        <a:font script="Thaa" typeface="MV Boli"/>
-        <a:font script="Deva" typeface="Mangal"/>
-        <a:font script="Telu" typeface="Gautami"/>
-        <a:font script="Taml" typeface="Latha"/>
-        <a:font script="Syrc" typeface="Estrangelo Edessa"/>
-        <a:font script="Orya" typeface="Kalinga"/>
-        <a:font script="Mlym" typeface="Kartika"/>
-        <a:font script="Laoo" typeface="DokChampa"/>
-        <a:font script="Sinh" typeface="Iskoola Pota"/>
-        <a:font script="Mong" typeface="Mongolian Baiti"/>
-        <a:font script="Viet" typeface="Times New Roman"/>
-        <a:font script="Uigh" typeface="Microsoft Uighur"/>
-        <a:font script="Geor" typeface="Sylfaen"/>
-        <a:font script="Armn" typeface="Arial"/>
-        <a:font script="Bugi" typeface="Leelawadee UI"/>
-        <a:font script="Bopo" typeface="Microsoft JhengHei"/>
-        <a:font script="Java" typeface="Javanese Text"/>
-        <a:font script="Lisu" typeface="Segoe UI"/>
-        <a:font script="Mymr" typeface="Myanmar Text"/>
-        <a:font script="Nkoo" typeface="Ebrima"/>
-        <a:font script="Olck" typeface="Nirmala UI"/>
-        <a:font script="Osma" typeface="Ebrima"/>
-        <a:font script="Phag" typeface="Phagspa"/>
-        <a:font script="Syrn" typeface="Estrangelo Edessa"/>
-        <a:font script="Syrj" typeface="Estrangelo Edessa"/>
-        <a:font script="Syre" typeface="Estrangelo Edessa"/>
-        <a:font script="Sora" typeface="Nirmala UI"/>
-        <a:font script="Tale" typeface="Microsoft Tai Le"/>
-        <a:font script="Talu" typeface="Microsoft New Tai Lue"/>
-        <a:font script="Tfng" typeface="Ebrima"/>
-      </a:majorFont>
-      <a:minorFont>
-        <a:latin typeface="Aptos" panose="02110004020202020204"/>
-        <a:ea typeface=""/>
-        <a:cs typeface=""/>
-        <a:font script="Jpan" typeface="游ゴシック"/>
-        <a:font script="Hang" typeface="맑은 고딕"/>
-        <a:font script="Hans" typeface="等线"/>
-        <a:font script="Hant" typeface="新細明體"/>
-        <a:font script="Arab" typeface="Arial"/>
-        <a:font script="Hebr" typeface="Arial"/>
-        <a:font script="Thai" typeface="Cordia New"/>
-        <a:font script="Ethi" typeface="Nyala"/>
-        <a:font script="Beng" typeface="Vrinda"/>
-        <a:font script="Gujr" typeface="Shruti"/>
-        <a:font script="Khmr" typeface="DaunPenh"/>
-        <a:font script="Knda" typeface="Tunga"/>
-        <a:font script="Guru" typeface="Raavi"/>
-        <a:font script="Cans" typeface="Euphemia"/>
-        <a:font script="Cher" typeface="Plantagenet Cherokee"/>
-        <a:font script="Yiii" typeface="Microsoft Yi Baiti"/>
-        <a:font script="Tibt" typeface="Microsoft Himalaya"/>
-        <a:font script="Thaa" typeface="MV Boli"/>
-        <a:font script="Deva" typeface="Mangal"/>
-        <a:font script="Telu" typeface="Gautami"/>
-        <a:font script="Taml" typeface="Latha"/>
-        <a:font script="Syrc" typeface="Estrangelo Edessa"/>
-        <a:font script="Orya" typeface="Kalinga"/>
-        <a:font script="Mlym" typeface="Kartika"/>
-        <a:font script="Laoo" typeface="DokChampa"/>
-        <a:font script="Sinh" typeface="Iskoola Pota"/>
-        <a:font script="Mong" typeface="Mongolian Baiti"/>
-        <a:font script="Viet" typeface="Arial"/>
-        <a:font script="Uigh" typeface="Microsoft Uighur"/>
-        <a:font script="Geor" typeface="Sylfaen"/>
-        <a:font script="Armn" typeface="Arial"/>
-        <a:font script="Bugi" typeface="Leelawadee UI"/>
-        <a:font script="Bopo" typeface="Microsoft JhengHei"/>
-        <a:font script="Java" typeface="Javanese Text"/>
-        <a:font script="Lisu" typeface="Segoe UI"/>
-        <a:font script="Mymr" typeface="Myanmar Text"/>
-        <a:font script="Nkoo" typeface="Ebrima"/>
-        <a:font script="Olck" typeface="Nirmala UI"/>
-        <a:font script="Osma" typeface="Ebrima"/>
-        <a:font script="Phag" typeface="Phagspa"/>
-        <a:font script="Syrn" typeface="Estrangelo Edessa"/>
-        <a:font script="Syrj" typeface="Estrangelo Edessa"/>
-        <a:font script="Syre" typeface="Estrangelo Edessa"/>
-        <a:font script="Sora" typeface="Nirmala UI"/>
-        <a:font script="Tale" typeface="Microsoft Tai Le"/>
-        <a:font script="Talu" typeface="Microsoft New Tai Lue"/>
-        <a:font script="Tfng" typeface="Ebrima"/>
-      </a:minorFont>
-    </a:fontScheme>
-    <a:fmtScheme name="Office">
-      <a:fillStyleLst>
-        <a:solidFill>
-          <a:schemeClr val="phClr"/>
-        </a:solidFill>
-        <a:gradFill rotWithShape="1">
-          <a:gsLst>
-            <a:gs pos="0">
-              <a:schemeClr val="phClr">
-                <a:lumMod val="110000"/>
-                <a:satMod val="105000"/>
-                <a:tint val="67000"/>
-              </a:schemeClr>
-            </a:gs>
-            <a:gs pos="50000">
-              <a:schemeClr val="phClr">
-                <a:lumMod val="105000"/>
-                <a:satMod val="103000"/>
-                <a:tint val="73000"/>
-              </a:schemeClr>
-            </a:gs>
-            <a:gs pos="100000">
-              <a:schemeClr val="phClr">
-                <a:lumMod val="105000"/>
-                <a:satMod val="109000"/>
-                <a:tint val="81000"/>
-              </a:schemeClr>
-            </a:gs>
-          </a:gsLst>
-          <a:lin ang="5400000" scaled="0"/>
-        </a:gradFill>
-        <a:gradFill rotWithShape="1">
-          <a:gsLst>
-            <a:gs pos="0">
-              <a:schemeClr val="phClr">
-                <a:satMod val="103000"/>
-                <a:lumMod val="102000"/>
-                <a:tint val="94000"/>
-              </a:schemeClr>
-            </a:gs>
-            <a:gs pos="50000">
-              <a:schemeClr val="phClr">
-                <a:satMod val="110000"/>
-                <a:lumMod val="100000"/>
-                <a:shade val="100000"/>
-              </a:schemeClr>
-            </a:gs>
-            <a:gs pos="100000">
-              <a:schemeClr val="phClr">
-                <a:lumMod val="99000"/>
-                <a:satMod val="120000"/>
-                <a:shade val="78000"/>
-              </a:schemeClr>
-            </a:gs>
-          </a:gsLst>
-          <a:lin ang="5400000" scaled="0"/>
-        </a:gradFill>
-      </a:fillStyleLst>
-      <a:lnStyleLst>
-        <a:ln w="12700" cap="flat" cmpd="sng" algn="ctr">
-          <a:solidFill>
-            <a:schemeClr val="phClr"/>
-          </a:solidFill>
-          <a:prstDash val="solid"/>
-          <a:miter lim="800000"/>
-        </a:ln>
-        <a:ln w="19050" cap="flat" cmpd="sng" algn="ctr">
-          <a:solidFill>
-            <a:schemeClr val="phClr"/>
-          </a:solidFill>
-          <a:prstDash val="solid"/>
-          <a:miter lim="800000"/>
-        </a:ln>
-        <a:ln w="25400" cap="flat" cmpd="sng" algn="ctr">
-          <a:solidFill>
-            <a:schemeClr val="phClr"/>
-          </a:solidFill>
-          <a:prstDash val="solid"/>
-          <a:miter lim="800000"/>
-        </a:ln>
-      </a:lnStyleLst>
-      <a:effectStyleLst>
-        <a:effectStyle>
-          <a:effectLst/>
-        </a:effectStyle>
-        <a:effectStyle>
-          <a:effectLst/>
-        </a:effectStyle>
-        <a:effectStyle>
-          <a:effectLst>
-            <a:outerShdw blurRad="57150" dist="19050" dir="5400000" algn="ctr" rotWithShape="0">
-              <a:srgbClr val="000000">
-                <a:alpha val="63000"/>
-              </a:srgbClr>
-            </a:outerShdw>
-          </a:effectLst>
-        </a:effectStyle>
-      </a:effectStyleLst>
-      <a:bgFillStyleLst>
-        <a:solidFill>
-          <a:schemeClr val="phClr"/>
-        </a:solidFill>
-        <a:solidFill>
-          <a:schemeClr val="phClr">
-            <a:tint val="95000"/>
-            <a:satMod val="170000"/>
-          </a:schemeClr>
-        </a:solidFill>
-        <a:gradFill rotWithShape="1">
-          <a:gsLst>
-            <a:gs pos="0">
-              <a:schemeClr val="phClr">
-                <a:tint val="93000"/>
-                <a:satMod val="150000"/>
-                <a:shade val="98000"/>
-                <a:lumMod val="102000"/>
-              </a:schemeClr>
-            </a:gs>
-            <a:gs pos="50000">
-              <a:schemeClr val="phClr">
-                <a:tint val="98000"/>
-                <a:satMod val="130000"/>
-                <a:shade val="90000"/>
-                <a:lumMod val="103000"/>
-              </a:schemeClr>
-            </a:gs>
-            <a:gs pos="100000">
-              <a:schemeClr val="phClr">
-                <a:shade val="63000"/>
-                <a:satMod val="120000"/>
-              </a:schemeClr>
-            </a:gs>
-          </a:gsLst>
-          <a:lin ang="5400000" scaled="0"/>
-        </a:gradFill>
-      </a:bgFillStyleLst>
-    </a:fmtScheme>
-  </a:themeElements>
-  <a:objectDefaults>
-    <a:lnDef>
-      <a:spPr/>
-      <a:bodyPr/>
-      <a:lstStyle/>
-      <a:style>
-        <a:lnRef idx="2">
-          <a:schemeClr val="accent1"/>
-        </a:lnRef>
-        <a:fillRef idx="0">
-          <a:schemeClr val="accent1"/>
-        </a:fillRef>
-        <a:effectRef idx="1">
-          <a:schemeClr val="accent1"/>
-        </a:effectRef>
-        <a:fontRef idx="minor">
-          <a:schemeClr val="tx1"/>
-        </a:fontRef>
-      </a:style>
-    </a:lnDef>
-  </a:objectDefaults>
-  <a:extraClrSchemeLst/>
-  <a:extLst>
-    <a:ext uri="{05A4C25C-085E-4340-85A3-A5531E510DB2}">
-      <thm15:themeFamily xmlns:thm15="http://schemas.microsoft.com/office/thememl/2012/main" name="Office Theme" id="{2E142A2C-CD16-42D6-873A-C26D2A0506FA}" vid="{1BDDFF52-6CD6-40A5-AB3C-68EB2F1E4D0A}"/>
-    </a:ext>
-  </a:extLst>
-</a:theme>
 </file>
</xml_diff>